<commit_message>
docs: add comprehensive aaPanel LNMP setup guide and update presentation with aaPanel SOP slides
</commit_message>
<xml_diff>
--- a/Panduan_Arsitektur_dan_Setting_Production_3_Server_ESA.pptx
+++ b/Panduan_Arsitektur_dan_Setting_Production_3_Server_ESA.pptx
@@ -12,6 +12,7 @@
     <p:sldId id="260" r:id="rId11"/>
     <p:sldId id="261" r:id="rId12"/>
     <p:sldId id="262" r:id="rId13"/>
+    <p:sldId id="263" r:id="rId14"/>
   </p:sldIdLst>
   <p:sldSz cx="12191695" cy="6858000" type="screen4x3"/>
   <p:notesSz cx="6858000" cy="9144000"/>
@@ -3191,7 +3192,7 @@
         <p:spPr>
           <a:xfrm>
             <a:off x="1280160" y="1188720"/>
-            <a:ext cx="4754880" cy="411480"/>
+            <a:ext cx="5029200" cy="411480"/>
           </a:xfrm>
           <a:prstGeom prst="roundRect">
             <a:avLst/>
@@ -3231,7 +3232,7 @@
               </a:defRPr>
             </a:pPr>
             <a:r>
-              <a:t>PANDUAN TEKNIS INFRASTRUKTUR IT • 2026</a:t>
+              <a:t>PANDUAN TEKNIS &amp; SOP AAPANEL • 2026</a:t>
             </a:r>
           </a:p>
         </p:txBody>
@@ -3259,14 +3260,14 @@
           <a:lstStyle/>
           <a:p>
             <a:pPr>
-              <a:defRPr sz="3000" b="1">
+              <a:defRPr sz="2800" b="1">
                 <a:solidFill>
                   <a:srgbClr val="FFFFFF"/>
                 </a:solidFill>
               </a:defRPr>
             </a:pPr>
             <a:r>
-              <a:t>Panduan Arsitektur &amp; Setting 3 Server Produksi</a:t>
+              <a:t>Panduan Arsitektur &amp; Setting 3 Server (aaPanel)</a:t>
             </a:r>
           </a:p>
           <a:p>
@@ -3274,14 +3275,14 @@
               <a:spcBef>
                 <a:spcPts val="800"/>
               </a:spcBef>
-              <a:defRPr sz="1900" b="1">
+              <a:defRPr sz="1800" b="1">
                 <a:solidFill>
                   <a:srgbClr val="34D399"/>
                 </a:solidFill>
               </a:defRPr>
             </a:pPr>
             <a:r>
-              <a:t>Sistem Presensi Mobile &amp; Pelaporan Lapangan (ESA Groups)</a:t>
+              <a:t>Aplikasi Presensi Mobile &amp; Pelaporan Lapangan (ESA Groups - 23.511 Karyawan)</a:t>
             </a:r>
           </a:p>
           <a:p>
@@ -3289,14 +3290,14 @@
               <a:spcBef>
                 <a:spcPts val="1000"/>
               </a:spcBef>
-              <a:defRPr sz="1150">
+              <a:defRPr sz="1100">
                 <a:solidFill>
                   <a:srgbClr val="94A3B8"/>
                 </a:solidFill>
               </a:defRPr>
             </a:pPr>
             <a:r>
-              <a:t>Dokumen Standard Operating Procedure (SOP) Konfigurasi Server, Dynamic Routing, Cross-Entity Hierarchy, &amp; Subdomain Portal Prinsiple</a:t>
+              <a:t>SOP Lengkap Konfigurasi aaPanel (LNMP Stack, PHP 8.2 Tuning, Supervisor, Cron Job Odoo, &amp; Dynamic Routing)</a:t>
             </a:r>
           </a:p>
         </p:txBody>
@@ -3350,7 +3351,7 @@
               </a:defRPr>
             </a:pPr>
             <a:r>
-              <a:t>CAKUPAN PANDUAN DEPLOYMENT:</a:t>
+              <a:t>CAKUPAN PANDUAN DEPLOYMENT AAPANEL:</a:t>
             </a:r>
           </a:p>
           <a:p>
@@ -3365,7 +3366,7 @@
               </a:defRPr>
             </a:pPr>
             <a:r>
-              <a:t>1. Topologi Jaringan &amp; Pembagian Komputasi (AMK: 11.687, ATB+ATK+ABO: 7.424, AKP: 4.400 Karyawan)</a:t>
+              <a:t>1. Setup LNMP (Nginx 1.24, PHP 8.2-FPM, PostgreSQL/MySQL, Redis 7, Supervisor Process Manager)</a:t>
             </a:r>
           </a:p>
           <a:p>
@@ -3380,7 +3381,7 @@
               </a:defRPr>
             </a:pPr>
             <a:r>
-              <a:t>2. Skema Single Gateway Domain &amp; Auto Dynamic Server Routing pada Aplikasi Mobile (Android/iOS)</a:t>
+              <a:t>2. Konfigurasi Website, Document Root /public, URL Rewrite Laravel, dan SSL Let's Encrypt Wildcard (*.esagroups.id)</a:t>
             </a:r>
           </a:p>
           <a:p>
@@ -3395,7 +3396,7 @@
               </a:defRPr>
             </a:pPr>
             <a:r>
-              <a:t>3. Mekanisme Approval Lintas Entitas (Cross-Entity Hierarchy SPV) &amp; Integrasi Subdomain Reporting Klien</a:t>
+              <a:t>3. Setting Dynamic Routing Mobile App, Hierarki SPV Lintas Entitas, dan Cron Background Sync Odoo</a:t>
             </a:r>
           </a:p>
         </p:txBody>
@@ -4086,7 +4087,7 @@
               </a:defRPr>
             </a:pPr>
             <a:r>
-              <a:t>MOBILE CLIENT INTEGRATION</a:t>
+              <a:t>SOP KONFIGURASI SERVER (BAGIAN 1)</a:t>
             </a:r>
           </a:p>
         </p:txBody>
@@ -4121,7 +4122,7 @@
               </a:defRPr>
             </a:pPr>
             <a:r>
-              <a:t>Skema URL &amp; Dynamic Server Routing pada Mobile App</a:t>
+              <a:t>Panduan Instalasi aaPanel &amp; Konfigurasi LNMP Stack</a:t>
             </a:r>
           </a:p>
         </p:txBody>
@@ -4156,7 +4157,7 @@
               </a:defRPr>
             </a:pPr>
             <a:r>
-              <a:t>Karyawan cukup memasukkan NIK di aplikasi mobile; sistem otomatis merutekan traffic ke server yang tepat.</a:t>
+              <a:t>Tahapan penyiapan environment pada Ubuntu 22.04 LTS hingga siap digunakan.</a:t>
             </a:r>
           </a:p>
         </p:txBody>
@@ -4170,7 +4171,7 @@
         <p:spPr>
           <a:xfrm>
             <a:off x="731520" y="1645920"/>
-            <a:ext cx="6217920" cy="4754880"/>
+            <a:ext cx="10728655" cy="1097280"/>
           </a:xfrm>
           <a:prstGeom prst="roundRect">
             <a:avLst/>
@@ -4178,7 +4179,7 @@
           <a:solidFill>
             <a:srgbClr val="14203C"/>
           </a:solidFill>
-          <a:ln w="19050">
+          <a:ln>
             <a:solidFill>
               <a:srgbClr val="38BDF8"/>
             </a:solidFill>
@@ -4199,7 +4200,7 @@
           </a:fontRef>
         </p:style>
         <p:txBody>
-          <a:bodyPr rtlCol="0" anchor="ctr" wrap="square" lIns="274320" tIns="228600" rIns="274320"/>
+          <a:bodyPr rtlCol="0" anchor="ctr" wrap="square" lIns="274320" tIns="164592"/>
           <a:lstStyle/>
           <a:p>
             <a:pPr algn="ctr">
@@ -4210,127 +4211,22 @@
               </a:defRPr>
             </a:pPr>
             <a:r>
-              <a:t>ALUR PENETAPAN URL DI APLIKASI MOBILE:</a:t>
+              <a:t>1. Instalasi aaPanel di Ubuntu 22.04</a:t>
             </a:r>
           </a:p>
           <a:p>
             <a:pPr>
               <a:spcBef>
-                <a:spcPts val="800"/>
+                <a:spcPts val="400"/>
               </a:spcBef>
-              <a:defRPr sz="1050" b="1">
-                <a:solidFill>
-                  <a:srgbClr val="FFFFFF"/>
-                </a:solidFill>
-              </a:defRPr>
-            </a:pPr>
-            <a:r>
-              <a:t>• 1. Single Gateway Entrypoint</a:t>
-            </a:r>
-          </a:p>
-          <a:p>
-            <a:pPr>
-              <a:spcBef>
-                <a:spcPts val="200"/>
-              </a:spcBef>
-              <a:defRPr sz="950">
-                <a:solidFill>
-                  <a:srgbClr val="94A3B8"/>
-                </a:solidFill>
-              </a:defRPr>
-            </a:pPr>
-            <a:r>
-              <a:t>   Aplikasi mobile di-build dengan 1 domain default: https://api.esagroups.id. Karyawan TIDAK perlu memilih atau mengetik server manual.</a:t>
-            </a:r>
-          </a:p>
-          <a:p>
-            <a:pPr>
-              <a:spcBef>
-                <a:spcPts val="800"/>
-              </a:spcBef>
-              <a:defRPr sz="1050" b="1">
-                <a:solidFill>
-                  <a:srgbClr val="FFFFFF"/>
-                </a:solidFill>
-              </a:defRPr>
-            </a:pPr>
-            <a:r>
-              <a:t>• 2. Login &amp; Server Discovery</a:t>
-            </a:r>
-          </a:p>
-          <a:p>
-            <a:pPr>
-              <a:spcBef>
-                <a:spcPts val="200"/>
-              </a:spcBef>
-              <a:defRPr sz="950">
-                <a:solidFill>
-                  <a:srgbClr val="94A3B8"/>
-                </a:solidFill>
-              </a:defRPr>
-            </a:pPr>
-            <a:r>
-              <a:t>   Karyawan input NIK &amp; Password. Gateway memeriksa entitas karyawan dan meneruskan verifikasi ke server entitas terkait.</a:t>
-            </a:r>
-          </a:p>
-          <a:p>
-            <a:pPr>
-              <a:spcBef>
-                <a:spcPts val="800"/>
-              </a:spcBef>
-              <a:defRPr sz="1050" b="1">
-                <a:solidFill>
-                  <a:srgbClr val="FFFFFF"/>
-                </a:solidFill>
-              </a:defRPr>
-            </a:pPr>
-            <a:r>
-              <a:t>• 3. Dynamic Endpoint Storing</a:t>
-            </a:r>
-          </a:p>
-          <a:p>
-            <a:pPr>
-              <a:spcBef>
-                <a:spcPts val="200"/>
-              </a:spcBef>
-              <a:defRPr sz="950">
-                <a:solidFill>
-                  <a:srgbClr val="94A3B8"/>
-                </a:solidFill>
-              </a:defRPr>
-            </a:pPr>
-            <a:r>
-              <a:t>   Setelah login sukses, server mengembalikan API Base URL (misal https://atb.esagroups.id). Mobile app menyimpan endpoint ini di local secure storage.</a:t>
-            </a:r>
-          </a:p>
-          <a:p>
-            <a:pPr>
-              <a:spcBef>
-                <a:spcPts val="800"/>
-              </a:spcBef>
-              <a:defRPr sz="1050" b="1">
-                <a:solidFill>
-                  <a:srgbClr val="FFFFFF"/>
-                </a:solidFill>
-              </a:defRPr>
-            </a:pPr>
-            <a:r>
-              <a:t>• 4. Direct High-Speed Traffic</a:t>
-            </a:r>
-          </a:p>
-          <a:p>
-            <a:pPr>
-              <a:spcBef>
-                <a:spcPts val="200"/>
-              </a:spcBef>
-              <a:defRPr sz="950">
-                <a:solidFill>
-                  <a:srgbClr val="94A3B8"/>
-                </a:solidFill>
-              </a:defRPr>
-            </a:pPr>
-            <a:r>
-              <a:t>   Seluruh transaksi presensi, selfie kamera, geofence GPS, dan visit report selanjutnya langsung dikirim ke server tujuan secara efisien.</a:t>
+              <a:defRPr sz="1000">
+                <a:solidFill>
+                  <a:srgbClr val="E2E8F0"/>
+                </a:solidFill>
+              </a:defRPr>
+            </a:pPr>
+            <a:r>
+              <a:t>Eksekusi one-line script instalasi resmi aaPanel via terminal SSH: `wget -O install.sh http://www.aapanel.com/script/install-ubuntu_6.0_en.sh &amp;&amp; sudo bash install.sh aapanel`.</a:t>
             </a:r>
           </a:p>
         </p:txBody>
@@ -4343,8 +4239,8 @@
         </p:nvSpPr>
         <p:spPr>
           <a:xfrm>
-            <a:off x="7132320" y="1645920"/>
-            <a:ext cx="4327855" cy="4754880"/>
+            <a:off x="731520" y="2834640"/>
+            <a:ext cx="10728655" cy="1097280"/>
           </a:xfrm>
           <a:prstGeom prst="roundRect">
             <a:avLst/>
@@ -4354,7 +4250,7 @@
           </a:solidFill>
           <a:ln>
             <a:solidFill>
-              <a:srgbClr val="334155"/>
+              <a:srgbClr val="2D4473"/>
             </a:solidFill>
           </a:ln>
         </p:spPr>
@@ -4373,101 +4269,171 @@
           </a:fontRef>
         </p:style>
         <p:txBody>
-          <a:bodyPr rtlCol="0" anchor="ctr" wrap="square" lIns="228600" tIns="228600" rIns="228600"/>
+          <a:bodyPr rtlCol="0" anchor="ctr" wrap="square" lIns="274320" tIns="164592"/>
           <a:lstStyle/>
           <a:p>
             <a:pPr algn="ctr">
-              <a:defRPr sz="1100" b="1">
-                <a:solidFill>
-                  <a:srgbClr val="34D399"/>
-                </a:solidFill>
-              </a:defRPr>
-            </a:pPr>
-            <a:r>
-              <a:t>STRUKTUR RESPONSE AUTH (JSON):</a:t>
+              <a:defRPr sz="1200" b="1">
+                <a:solidFill>
+                  <a:srgbClr val="38BDF8"/>
+                </a:solidFill>
+              </a:defRPr>
+            </a:pPr>
+            <a:r>
+              <a:t>2. Instalasi Paket LNMP (App Store)</a:t>
             </a:r>
           </a:p>
           <a:p>
             <a:pPr>
               <a:spcBef>
-                <a:spcPts val="800"/>
+                <a:spcPts val="400"/>
               </a:spcBef>
-              <a:defRPr sz="900">
-                <a:solidFill>
-                  <a:srgbClr val="A78BFA"/>
-                </a:solidFill>
-              </a:defRPr>
-            </a:pPr>
-            <a:r>
-              <a:t>{</a:t>
-            </a:r>
-            <a:br/>
-            <a:r>
-              <a:t>  "status": "success",</a:t>
-            </a:r>
-            <a:br/>
-            <a:r>
-              <a:t>  "message": "Login berhasil",</a:t>
-            </a:r>
-            <a:br/>
-            <a:r>
-              <a:t>  "data": {</a:t>
-            </a:r>
-            <a:br/>
-            <a:r>
-              <a:t>    "token": "45|eyJhbGciOiJIUz...",</a:t>
-            </a:r>
-            <a:br/>
-            <a:r>
-              <a:t>    "employee": {</a:t>
-            </a:r>
-            <a:br/>
-            <a:r>
-              <a:t>      "nik": "3578012345670001",</a:t>
-            </a:r>
-            <a:br/>
-            <a:r>
-              <a:t>      "name": "Budi Santoso",</a:t>
-            </a:r>
-            <a:br/>
-            <a:r>
-              <a:t>      "company": "PT ATB",</a:t>
-            </a:r>
-            <a:br/>
-            <a:r>
-              <a:t>      "is_head_spv": true</a:t>
-            </a:r>
-            <a:br/>
-            <a:r>
-              <a:t>    },</a:t>
-            </a:r>
-            <a:br/>
-            <a:r>
-              <a:t>    "routing": {</a:t>
-            </a:r>
-            <a:br/>
-            <a:r>
-              <a:t>      "assigned_server": "SERVER_2",</a:t>
-            </a:r>
-            <a:br/>
-            <a:r>
-              <a:t>      "api_base_url": "https://atb.esagroups.id/api",</a:t>
-            </a:r>
-            <a:br/>
-            <a:r>
-              <a:t>      "media_cdn_url": "https://storage.esagroups.id"</a:t>
-            </a:r>
-            <a:br/>
-            <a:r>
-              <a:t>    }</a:t>
-            </a:r>
-            <a:br/>
-            <a:r>
-              <a:t>  }</a:t>
-            </a:r>
-            <a:br/>
-            <a:r>
-              <a:t>}</a:t>
+              <a:defRPr sz="1000">
+                <a:solidFill>
+                  <a:srgbClr val="E2E8F0"/>
+                </a:solidFill>
+              </a:defRPr>
+            </a:pPr>
+            <a:r>
+              <a:t>Pilih stack: Nginx 1.24+, PHP 8.2 (Wajib), PostgreSQL 15 / MySQL 8.0, Redis 7.0+, dan Supervisor Process Manager.</a:t>
+            </a:r>
+          </a:p>
+        </p:txBody>
+      </p:sp>
+      <p:sp>
+        <p:nvSpPr>
+          <p:cNvPr id="8" name="Rounded Rectangle 7"/>
+          <p:cNvSpPr/>
+          <p:nvPr/>
+        </p:nvSpPr>
+        <p:spPr>
+          <a:xfrm>
+            <a:off x="731520" y="4023360"/>
+            <a:ext cx="10728655" cy="1097280"/>
+          </a:xfrm>
+          <a:prstGeom prst="roundRect">
+            <a:avLst/>
+          </a:prstGeom>
+          <a:solidFill>
+            <a:srgbClr val="14203C"/>
+          </a:solidFill>
+          <a:ln>
+            <a:solidFill>
+              <a:srgbClr val="38BDF8"/>
+            </a:solidFill>
+          </a:ln>
+        </p:spPr>
+        <p:style>
+          <a:lnRef idx="1">
+            <a:schemeClr val="accent1"/>
+          </a:lnRef>
+          <a:fillRef idx="3">
+            <a:schemeClr val="accent1"/>
+          </a:fillRef>
+          <a:effectRef idx="2">
+            <a:schemeClr val="accent1"/>
+          </a:effectRef>
+          <a:fontRef idx="minor">
+            <a:schemeClr val="lt1"/>
+          </a:fontRef>
+        </p:style>
+        <p:txBody>
+          <a:bodyPr rtlCol="0" anchor="ctr" wrap="square" lIns="274320" tIns="164592"/>
+          <a:lstStyle/>
+          <a:p>
+            <a:pPr algn="ctr">
+              <a:defRPr sz="1200" b="1">
+                <a:solidFill>
+                  <a:srgbClr val="38BDF8"/>
+                </a:solidFill>
+              </a:defRPr>
+            </a:pPr>
+            <a:r>
+              <a:t>3. Instalasi Ekstensi PHP 8.2</a:t>
+            </a:r>
+          </a:p>
+          <a:p>
+            <a:pPr>
+              <a:spcBef>
+                <a:spcPts val="400"/>
+              </a:spcBef>
+              <a:defRPr sz="1000">
+                <a:solidFill>
+                  <a:srgbClr val="E2E8F0"/>
+                </a:solidFill>
+              </a:defRPr>
+            </a:pPr>
+            <a:r>
+              <a:t>Masuk ke PHP 8.2 Settings &gt; Install Extensions: Wajib install `fileinfo`, `redis`, `pgsql`/`pdo_pgsql`, `gd`, `zip`, `xmlrpc`, `bcmath`, dan `opcache`.</a:t>
+            </a:r>
+          </a:p>
+        </p:txBody>
+      </p:sp>
+      <p:sp>
+        <p:nvSpPr>
+          <p:cNvPr id="9" name="Rounded Rectangle 8"/>
+          <p:cNvSpPr/>
+          <p:nvPr/>
+        </p:nvSpPr>
+        <p:spPr>
+          <a:xfrm>
+            <a:off x="731520" y="5212080"/>
+            <a:ext cx="10728655" cy="1097280"/>
+          </a:xfrm>
+          <a:prstGeom prst="roundRect">
+            <a:avLst/>
+          </a:prstGeom>
+          <a:solidFill>
+            <a:srgbClr val="0F172A"/>
+          </a:solidFill>
+          <a:ln>
+            <a:solidFill>
+              <a:srgbClr val="2D4473"/>
+            </a:solidFill>
+          </a:ln>
+        </p:spPr>
+        <p:style>
+          <a:lnRef idx="1">
+            <a:schemeClr val="accent1"/>
+          </a:lnRef>
+          <a:fillRef idx="3">
+            <a:schemeClr val="accent1"/>
+          </a:fillRef>
+          <a:effectRef idx="2">
+            <a:schemeClr val="accent1"/>
+          </a:effectRef>
+          <a:fontRef idx="minor">
+            <a:schemeClr val="lt1"/>
+          </a:fontRef>
+        </p:style>
+        <p:txBody>
+          <a:bodyPr rtlCol="0" anchor="ctr" wrap="square" lIns="274320" tIns="164592"/>
+          <a:lstStyle/>
+          <a:p>
+            <a:pPr algn="ctr">
+              <a:defRPr sz="1200" b="1">
+                <a:solidFill>
+                  <a:srgbClr val="38BDF8"/>
+                </a:solidFill>
+              </a:defRPr>
+            </a:pPr>
+            <a:r>
+              <a:t>4. Tuning Performa PHP (php.ini)</a:t>
+            </a:r>
+          </a:p>
+          <a:p>
+            <a:pPr>
+              <a:spcBef>
+                <a:spcPts val="400"/>
+              </a:spcBef>
+              <a:defRPr sz="1000">
+                <a:solidFill>
+                  <a:srgbClr val="E2E8F0"/>
+                </a:solidFill>
+              </a:defRPr>
+            </a:pPr>
+            <a:r>
+              <a:t>Atur nilai: `memory_limit = 1024M`, `upload_max_filesize = 50M`, `post_max_size = 50M`, `max_execution_time = 300`, `max_input_vars = 5000`.</a:t>
             </a:r>
           </a:p>
         </p:txBody>
@@ -4563,7 +4529,7 @@
               </a:defRPr>
             </a:pPr>
             <a:r>
-              <a:t>WORKFLOW MANAGEMENT</a:t>
+              <a:t>SOP KONFIGURASI SERVER (BAGIAN 2)</a:t>
             </a:r>
           </a:p>
         </p:txBody>
@@ -4598,7 +4564,7 @@
               </a:defRPr>
             </a:pPr>
             <a:r>
-              <a:t>Hierarki Atasan Lintas Entitas (Cross-Entity Hierarchy)</a:t>
+              <a:t>Setting Website, SSL Wildcard, Supervisor &amp; Cron Job</a:t>
             </a:r>
           </a:p>
         </p:txBody>
@@ -4633,7 +4599,7 @@
               </a:defRPr>
             </a:pPr>
             <a:r>
-              <a:t>Menangani approval Cuti, Izin, Lembur, dan Monitoring Karyawan yang memiliki Head/SPV di entitas berbeda.</a:t>
+              <a:t>Langkah deploy kode aplikasi, SSL otomatis, dan otomatisasi task background.</a:t>
             </a:r>
           </a:p>
         </p:txBody>
@@ -4647,7 +4613,7 @@
         <p:spPr>
           <a:xfrm>
             <a:off x="731520" y="1645920"/>
-            <a:ext cx="5212080" cy="2103120"/>
+            <a:ext cx="10728655" cy="868680"/>
           </a:xfrm>
           <a:prstGeom prst="roundRect">
             <a:avLst/>
@@ -4655,9 +4621,9 @@
           <a:solidFill>
             <a:srgbClr val="14203C"/>
           </a:solidFill>
-          <a:ln w="15240">
+          <a:ln>
             <a:solidFill>
-              <a:srgbClr val="38BDF8"/>
+              <a:srgbClr val="34D399"/>
             </a:solidFill>
           </a:ln>
         </p:spPr>
@@ -4676,33 +4642,33 @@
           </a:fontRef>
         </p:style>
         <p:txBody>
-          <a:bodyPr rtlCol="0" anchor="ctr" wrap="square" lIns="274320" tIns="228600" rIns="274320"/>
+          <a:bodyPr rtlCol="0" anchor="ctr" wrap="square" lIns="228600" tIns="109728"/>
           <a:lstStyle/>
           <a:p>
             <a:pPr algn="ctr">
-              <a:defRPr sz="1250" b="1">
-                <a:solidFill>
-                  <a:srgbClr val="38BDF8"/>
-                </a:solidFill>
-              </a:defRPr>
-            </a:pPr>
-            <a:r>
-              <a:t>1. Identifikasi Relasi via NIK Global</a:t>
+              <a:defRPr sz="1100" b="1">
+                <a:solidFill>
+                  <a:srgbClr val="34D399"/>
+                </a:solidFill>
+              </a:defRPr>
+            </a:pPr>
+            <a:r>
+              <a:t>1. Add Website &amp; Document Root</a:t>
             </a:r>
           </a:p>
           <a:p>
             <a:pPr>
               <a:spcBef>
-                <a:spcPts val="800"/>
+                <a:spcPts val="200"/>
               </a:spcBef>
-              <a:defRPr sz="1000">
+              <a:defRPr sz="950">
                 <a:solidFill>
                   <a:srgbClr val="E2E8F0"/>
                 </a:solidFill>
               </a:defRPr>
             </a:pPr>
             <a:r>
-              <a:t>Struktur atasan-bawahan dihubungkan menggunakan NIK Karyawan. Jika staf di PT ATB (Server 2) memiliki atasan di PT AMK (Server 1), data mencatat `supervisor_nik = [NIK_SPV_AMK]`.</a:t>
+              <a:t>Buat website di aaPanel (misal `amk.esagroups.id` &amp; `*.amk.esagroups.id`). Set **Running Directory** ke `/public`. Set URL Rewrite ke preset `laravel5`.</a:t>
             </a:r>
           </a:p>
         </p:txBody>
@@ -4715,8 +4681,77 @@
         </p:nvSpPr>
         <p:spPr>
           <a:xfrm>
-            <a:off x="6217920" y="1645920"/>
-            <a:ext cx="5212080" cy="2103120"/>
+            <a:off x="731520" y="2606040"/>
+            <a:ext cx="10728655" cy="868680"/>
+          </a:xfrm>
+          <a:prstGeom prst="roundRect">
+            <a:avLst/>
+          </a:prstGeom>
+          <a:solidFill>
+            <a:srgbClr val="0F172A"/>
+          </a:solidFill>
+          <a:ln>
+            <a:solidFill>
+              <a:srgbClr val="2D4473"/>
+            </a:solidFill>
+          </a:ln>
+        </p:spPr>
+        <p:style>
+          <a:lnRef idx="1">
+            <a:schemeClr val="accent1"/>
+          </a:lnRef>
+          <a:fillRef idx="3">
+            <a:schemeClr val="accent1"/>
+          </a:fillRef>
+          <a:effectRef idx="2">
+            <a:schemeClr val="accent1"/>
+          </a:effectRef>
+          <a:fontRef idx="minor">
+            <a:schemeClr val="lt1"/>
+          </a:fontRef>
+        </p:style>
+        <p:txBody>
+          <a:bodyPr rtlCol="0" anchor="ctr" wrap="square" lIns="228600" tIns="109728"/>
+          <a:lstStyle/>
+          <a:p>
+            <a:pPr algn="ctr">
+              <a:defRPr sz="1100" b="1">
+                <a:solidFill>
+                  <a:srgbClr val="34D399"/>
+                </a:solidFill>
+              </a:defRPr>
+            </a:pPr>
+            <a:r>
+              <a:t>2. SSL Let's Encrypt Wildcard</a:t>
+            </a:r>
+          </a:p>
+          <a:p>
+            <a:pPr>
+              <a:spcBef>
+                <a:spcPts val="200"/>
+              </a:spcBef>
+              <a:defRPr sz="950">
+                <a:solidFill>
+                  <a:srgbClr val="E2E8F0"/>
+                </a:solidFill>
+              </a:defRPr>
+            </a:pPr>
+            <a:r>
+              <a:t>Buka tab SSL &gt; Let's Encrypt &gt; centang domain dan subdomain &gt; Apply. Aktifkan toggle **Force HTTPS** untuk enkripsi penuh port 443.</a:t>
+            </a:r>
+          </a:p>
+        </p:txBody>
+      </p:sp>
+      <p:sp>
+        <p:nvSpPr>
+          <p:cNvPr id="8" name="Rounded Rectangle 7"/>
+          <p:cNvSpPr/>
+          <p:nvPr/>
+        </p:nvSpPr>
+        <p:spPr>
+          <a:xfrm>
+            <a:off x="731520" y="3566160"/>
+            <a:ext cx="10728655" cy="868680"/>
           </a:xfrm>
           <a:prstGeom prst="roundRect">
             <a:avLst/>
@@ -4724,7 +4759,7 @@
           <a:solidFill>
             <a:srgbClr val="14203C"/>
           </a:solidFill>
-          <a:ln w="15240">
+          <a:ln>
             <a:solidFill>
               <a:srgbClr val="34D399"/>
             </a:solidFill>
@@ -4745,47 +4780,116 @@
           </a:fontRef>
         </p:style>
         <p:txBody>
-          <a:bodyPr rtlCol="0" anchor="ctr" wrap="square" lIns="274320" tIns="228600" rIns="274320"/>
+          <a:bodyPr rtlCol="0" anchor="ctr" wrap="square" lIns="228600" tIns="109728"/>
           <a:lstStyle/>
           <a:p>
             <a:pPr algn="ctr">
-              <a:defRPr sz="1250" b="1">
+              <a:defRPr sz="1100" b="1">
                 <a:solidFill>
                   <a:srgbClr val="34D399"/>
                 </a:solidFill>
               </a:defRPr>
             </a:pPr>
             <a:r>
-              <a:t>2. Delegasi Notifikasi Approval</a:t>
+              <a:t>3. Clone Project &amp; Build Cache</a:t>
             </a:r>
           </a:p>
           <a:p>
             <a:pPr>
               <a:spcBef>
-                <a:spcPts val="800"/>
+                <a:spcPts val="200"/>
               </a:spcBef>
-              <a:defRPr sz="1000">
+              <a:defRPr sz="950">
                 <a:solidFill>
                   <a:srgbClr val="E2E8F0"/>
                 </a:solidFill>
               </a:defRPr>
             </a:pPr>
             <a:r>
-              <a:t>Saat staf mengajukan Izin/Cuti/Lembur, event approval diteruskan ke SPV via jalur Private Network (Inter-VPC). Notifikasi langsung muncul di aplikasi mobile SPV secara real-time.</a:t>
-            </a:r>
-          </a:p>
-        </p:txBody>
-      </p:sp>
-      <p:sp>
-        <p:nvSpPr>
-          <p:cNvPr id="8" name="Rounded Rectangle 7"/>
+              <a:t>Di terminal: `git clone ...`, `composer install --no-dev`, `cp .env.example .env`, `php artisan key:generate`, `php artisan migrate --force`, `php artisan optimize`.</a:t>
+            </a:r>
+          </a:p>
+        </p:txBody>
+      </p:sp>
+      <p:sp>
+        <p:nvSpPr>
+          <p:cNvPr id="9" name="Rounded Rectangle 8"/>
           <p:cNvSpPr/>
           <p:nvPr/>
         </p:nvSpPr>
         <p:spPr>
           <a:xfrm>
-            <a:off x="731520" y="4023360"/>
-            <a:ext cx="5212080" cy="2103120"/>
+            <a:off x="731520" y="4526280"/>
+            <a:ext cx="10728655" cy="868680"/>
+          </a:xfrm>
+          <a:prstGeom prst="roundRect">
+            <a:avLst/>
+          </a:prstGeom>
+          <a:solidFill>
+            <a:srgbClr val="0F172A"/>
+          </a:solidFill>
+          <a:ln>
+            <a:solidFill>
+              <a:srgbClr val="2D4473"/>
+            </a:solidFill>
+          </a:ln>
+        </p:spPr>
+        <p:style>
+          <a:lnRef idx="1">
+            <a:schemeClr val="accent1"/>
+          </a:lnRef>
+          <a:fillRef idx="3">
+            <a:schemeClr val="accent1"/>
+          </a:fillRef>
+          <a:effectRef idx="2">
+            <a:schemeClr val="accent1"/>
+          </a:effectRef>
+          <a:fontRef idx="minor">
+            <a:schemeClr val="lt1"/>
+          </a:fontRef>
+        </p:style>
+        <p:txBody>
+          <a:bodyPr rtlCol="0" anchor="ctr" wrap="square" lIns="228600" tIns="109728"/>
+          <a:lstStyle/>
+          <a:p>
+            <a:pPr algn="ctr">
+              <a:defRPr sz="1100" b="1">
+                <a:solidFill>
+                  <a:srgbClr val="34D399"/>
+                </a:solidFill>
+              </a:defRPr>
+            </a:pPr>
+            <a:r>
+              <a:t>4. Supervisor Queue Worker</a:t>
+            </a:r>
+          </a:p>
+          <a:p>
+            <a:pPr>
+              <a:spcBef>
+                <a:spcPts val="200"/>
+              </a:spcBef>
+              <a:defRPr sz="950">
+                <a:solidFill>
+                  <a:srgbClr val="E2E8F0"/>
+                </a:solidFill>
+              </a:defRPr>
+            </a:pPr>
+            <a:r>
+              <a:t>Di App Store &gt; Supervisor &gt; Add Daemon: Command `php artisan queue:work redis --sleep=3 --tries=3` dengan 4 worker paralel untuk antrean background email &amp; notifikasi.</a:t>
+            </a:r>
+          </a:p>
+        </p:txBody>
+      </p:sp>
+      <p:sp>
+        <p:nvSpPr>
+          <p:cNvPr id="10" name="Rounded Rectangle 9"/>
+          <p:cNvSpPr/>
+          <p:nvPr/>
+        </p:nvSpPr>
+        <p:spPr>
+          <a:xfrm>
+            <a:off x="731520" y="5486400"/>
+            <a:ext cx="10728655" cy="868680"/>
           </a:xfrm>
           <a:prstGeom prst="roundRect">
             <a:avLst/>
@@ -4793,9 +4897,9 @@
           <a:solidFill>
             <a:srgbClr val="14203C"/>
           </a:solidFill>
-          <a:ln w="15240">
+          <a:ln>
             <a:solidFill>
-              <a:srgbClr val="FBBF24"/>
+              <a:srgbClr val="34D399"/>
             </a:solidFill>
           </a:ln>
         </p:spPr>
@@ -4814,102 +4918,33 @@
           </a:fontRef>
         </p:style>
         <p:txBody>
-          <a:bodyPr rtlCol="0" anchor="ctr" wrap="square" lIns="274320" tIns="228600" rIns="274320"/>
+          <a:bodyPr rtlCol="0" anchor="ctr" wrap="square" lIns="228600" tIns="109728"/>
           <a:lstStyle/>
           <a:p>
             <a:pPr algn="ctr">
-              <a:defRPr sz="1250" b="1">
-                <a:solidFill>
-                  <a:srgbClr val="FBBF24"/>
-                </a:solidFill>
-              </a:defRPr>
-            </a:pPr>
-            <a:r>
-              <a:t>3. Single Dashboard Tim bagi SPV</a:t>
+              <a:defRPr sz="1100" b="1">
+                <a:solidFill>
+                  <a:srgbClr val="34D399"/>
+                </a:solidFill>
+              </a:defRPr>
+            </a:pPr>
+            <a:r>
+              <a:t>5. Setting Cron Job Dini Hari</a:t>
             </a:r>
           </a:p>
           <a:p>
             <a:pPr>
               <a:spcBef>
-                <a:spcPts val="800"/>
+                <a:spcPts val="200"/>
               </a:spcBef>
-              <a:defRPr sz="1000">
+              <a:defRPr sz="950">
                 <a:solidFill>
                   <a:srgbClr val="E2E8F0"/>
                 </a:solidFill>
               </a:defRPr>
             </a:pPr>
             <a:r>
-              <a:t>SPV di Server 1 dapat melihat daftar kehadiran dan live tracking seluruh anggotanya (baik anggota dari AMK, ATB, maupun AKP) dalam 1 layar dashboard terpadu tanpa harus berganti akun.</a:t>
-            </a:r>
-          </a:p>
-        </p:txBody>
-      </p:sp>
-      <p:sp>
-        <p:nvSpPr>
-          <p:cNvPr id="9" name="Rounded Rectangle 8"/>
-          <p:cNvSpPr/>
-          <p:nvPr/>
-        </p:nvSpPr>
-        <p:spPr>
-          <a:xfrm>
-            <a:off x="6217920" y="4023360"/>
-            <a:ext cx="5212080" cy="2103120"/>
-          </a:xfrm>
-          <a:prstGeom prst="roundRect">
-            <a:avLst/>
-          </a:prstGeom>
-          <a:solidFill>
-            <a:srgbClr val="14203C"/>
-          </a:solidFill>
-          <a:ln w="15240">
-            <a:solidFill>
-              <a:srgbClr val="A855F7"/>
-            </a:solidFill>
-          </a:ln>
-        </p:spPr>
-        <p:style>
-          <a:lnRef idx="1">
-            <a:schemeClr val="accent1"/>
-          </a:lnRef>
-          <a:fillRef idx="3">
-            <a:schemeClr val="accent1"/>
-          </a:fillRef>
-          <a:effectRef idx="2">
-            <a:schemeClr val="accent1"/>
-          </a:effectRef>
-          <a:fontRef idx="minor">
-            <a:schemeClr val="lt1"/>
-          </a:fontRef>
-        </p:style>
-        <p:txBody>
-          <a:bodyPr rtlCol="0" anchor="ctr" wrap="square" lIns="274320" tIns="228600" rIns="274320"/>
-          <a:lstStyle/>
-          <a:p>
-            <a:pPr algn="ctr">
-              <a:defRPr sz="1250" b="1">
-                <a:solidFill>
-                  <a:srgbClr val="A855F7"/>
-                </a:solidFill>
-              </a:defRPr>
-            </a:pPr>
-            <a:r>
-              <a:t>4. Callback Status Otomatis</a:t>
-            </a:r>
-          </a:p>
-          <a:p>
-            <a:pPr>
-              <a:spcBef>
-                <a:spcPts val="800"/>
-              </a:spcBef>
-              <a:defRPr sz="1000">
-                <a:solidFill>
-                  <a:srgbClr val="E2E8F0"/>
-                </a:solidFill>
-              </a:defRPr>
-            </a:pPr>
-            <a:r>
-              <a:t>Ketika SPV mengklik tombol Approve / Reject, sistem mengupdate status presensi bawahan di server asalnya seketika dan mengirimkan push notification ke staf.</a:t>
+              <a:t>Di menu Cron aaPanel: Tambah task setiap 1 menit (`php artisan schedule:run`) dan task jam 01:00 WIB (`php artisan odoo:sync-employees`).</a:t>
             </a:r>
           </a:p>
         </p:txBody>
@@ -5005,7 +5040,7 @@
               </a:defRPr>
             </a:pPr>
             <a:r>
-              <a:t>CLIENT REPORTING PORTAL</a:t>
+              <a:t>MOBILE CLIENT INTEGRATION</a:t>
             </a:r>
           </a:p>
         </p:txBody>
@@ -5040,7 +5075,7 @@
               </a:defRPr>
             </a:pPr>
             <a:r>
-              <a:t>Subdomain Khusus Pelaporan &amp; Monitoring Prinsiple</a:t>
+              <a:t>Skema URL &amp; Dynamic Server Routing pada Mobile App</a:t>
             </a:r>
           </a:p>
         </p:txBody>
@@ -5075,7 +5110,7 @@
               </a:defRPr>
             </a:pPr>
             <a:r>
-              <a:t>Portal white-label mandiri bagi prinsiple/klien (Dulux, Fonterra, Wings, dll) dengan akses data terisolasi.</a:t>
+              <a:t>Karyawan cukup memasukkan NIK di aplikasi mobile; sistem otomatis merutekan traffic ke server yang tepat.</a:t>
             </a:r>
           </a:p>
         </p:txBody>
@@ -5089,7 +5124,7 @@
         <p:spPr>
           <a:xfrm>
             <a:off x="731520" y="1645920"/>
-            <a:ext cx="5669280" cy="4754880"/>
+            <a:ext cx="6217920" cy="4754880"/>
           </a:xfrm>
           <a:prstGeom prst="roundRect">
             <a:avLst/>
@@ -5099,7 +5134,7 @@
           </a:solidFill>
           <a:ln w="19050">
             <a:solidFill>
-              <a:srgbClr val="34D399"/>
+              <a:srgbClr val="38BDF8"/>
             </a:solidFill>
           </a:ln>
         </p:spPr>
@@ -5124,12 +5159,12 @@
             <a:pPr algn="ctr">
               <a:defRPr sz="1200" b="1">
                 <a:solidFill>
-                  <a:srgbClr val="34D399"/>
-                </a:solidFill>
-              </a:defRPr>
-            </a:pPr>
-            <a:r>
-              <a:t>FITUR PORTAL SUBDOMAIN PRINSIPLE:</a:t>
+                  <a:srgbClr val="38BDF8"/>
+                </a:solidFill>
+              </a:defRPr>
+            </a:pPr>
+            <a:r>
+              <a:t>ALUR PENETAPAN URL DI APLIKASI MOBILE:</a:t>
             </a:r>
           </a:p>
           <a:p>
@@ -5144,7 +5179,7 @@
               </a:defRPr>
             </a:pPr>
             <a:r>
-              <a:t>• Wildcard DNS (*.esagroups.id)</a:t>
+              <a:t>• 1. Single Gateway Entrypoint</a:t>
             </a:r>
           </a:p>
           <a:p>
@@ -5159,7 +5194,7 @@
               </a:defRPr>
             </a:pPr>
             <a:r>
-              <a:t>   Cukup 1 konfigurasi DNS wildcard; setiap prinsiple baru otomatis langsung aktif subdomainnya tanpa konfigurasi DNS ulang.</a:t>
+              <a:t>   Aplikasi mobile di-build dengan 1 domain default: https://api.esagroups.id. Karyawan TIDAK perlu memilih atau mengetik server manual.</a:t>
             </a:r>
           </a:p>
           <a:p>
@@ -5174,7 +5209,7 @@
               </a:defRPr>
             </a:pPr>
             <a:r>
-              <a:t>• White-Label Branding Eksklusif</a:t>
+              <a:t>• 2. Login &amp; Server Discovery</a:t>
             </a:r>
           </a:p>
           <a:p>
@@ -5189,7 +5224,7 @@
               </a:defRPr>
             </a:pPr>
             <a:r>
-              <a:t>   Logo, tema warna, dan nama prinsiple disesuaikan otomatis saat subdomain dibuka (misal: dulux.esagroups.id atau fonterra.esagroups.id).</a:t>
+              <a:t>   Karyawan input NIK &amp; Password. Gateway memeriksa entitas karyawan dan meneruskan verifikasi ke server entitas terkait.</a:t>
             </a:r>
           </a:p>
           <a:p>
@@ -5204,7 +5239,7 @@
               </a:defRPr>
             </a:pPr>
             <a:r>
-              <a:t>• Data Privacy &amp; Strict Isolation</a:t>
+              <a:t>• 3. Dynamic Endpoint Storing</a:t>
             </a:r>
           </a:p>
           <a:p>
@@ -5219,7 +5254,7 @@
               </a:defRPr>
             </a:pPr>
             <a:r>
-              <a:t>   Klien HANYA dapat melihat absensi, rute kunjungan toko, dan laporan sales karyawan yang ditempatkan di produk mereka.</a:t>
+              <a:t>   Setelah login sukses, server mengembalikan API Base URL (misal https://atb.esagroups.id). Mobile app menyimpan endpoint ini di local secure storage.</a:t>
             </a:r>
           </a:p>
           <a:p>
@@ -5234,7 +5269,7 @@
               </a:defRPr>
             </a:pPr>
             <a:r>
-              <a:t>• Self-Service Export Excel / PDF</a:t>
+              <a:t>• 4. Direct High-Speed Traffic</a:t>
             </a:r>
           </a:p>
           <a:p>
@@ -5249,7 +5284,7 @@
               </a:defRPr>
             </a:pPr>
             <a:r>
-              <a:t>   Prinsiple dapat mengunduh rekapitulasi kehadiran dan bukti foto display toko secara mandiri kapan saja.</a:t>
+              <a:t>   Seluruh transaksi presensi, selfie kamera, geofence GPS, dan visit report selanjutnya langsung dikirim ke server tujuan secara efisien.</a:t>
             </a:r>
           </a:p>
         </p:txBody>
@@ -5262,8 +5297,8 @@
         </p:nvSpPr>
         <p:spPr>
           <a:xfrm>
-            <a:off x="6583680" y="1645920"/>
-            <a:ext cx="4876495" cy="4754880"/>
+            <a:off x="7132320" y="1645920"/>
+            <a:ext cx="4327855" cy="4754880"/>
           </a:xfrm>
           <a:prstGeom prst="roundRect">
             <a:avLst/>
@@ -5273,7 +5308,7 @@
           </a:solidFill>
           <a:ln>
             <a:solidFill>
-              <a:srgbClr val="2D4473"/>
+              <a:srgbClr val="334155"/>
             </a:solidFill>
           </a:ln>
         </p:spPr>
@@ -5292,180 +5327,101 @@
           </a:fontRef>
         </p:style>
         <p:txBody>
-          <a:bodyPr rtlCol="0" anchor="ctr" wrap="square" lIns="274320" tIns="228600" rIns="274320"/>
+          <a:bodyPr rtlCol="0" anchor="ctr" wrap="square" lIns="228600" tIns="228600" rIns="228600"/>
           <a:lstStyle/>
           <a:p>
             <a:pPr algn="ctr">
               <a:defRPr sz="1100" b="1">
                 <a:solidFill>
-                  <a:srgbClr val="38BDF8"/>
-                </a:solidFill>
-              </a:defRPr>
-            </a:pPr>
-            <a:r>
-              <a:t>CONTOH PEMETAAN SUBDOMAIN KLIEN:</a:t>
+                  <a:srgbClr val="34D399"/>
+                </a:solidFill>
+              </a:defRPr>
+            </a:pPr>
+            <a:r>
+              <a:t>STRUKTUR RESPONSE AUTH (JSON):</a:t>
             </a:r>
           </a:p>
           <a:p>
             <a:pPr>
               <a:spcBef>
-                <a:spcPts val="700"/>
+                <a:spcPts val="800"/>
               </a:spcBef>
-              <a:defRPr sz="1000" b="1">
-                <a:solidFill>
-                  <a:srgbClr val="38BDF8"/>
-                </a:solidFill>
-              </a:defRPr>
-            </a:pPr>
-            <a:r>
-              <a:t>🌐 https://dulux.esagroups.id</a:t>
-            </a:r>
-          </a:p>
-          <a:p>
-            <a:pPr>
               <a:defRPr sz="900">
                 <a:solidFill>
-                  <a:srgbClr val="FFFFFF"/>
-                </a:solidFill>
-              </a:defRPr>
-            </a:pPr>
-            <a:r>
-              <a:t>   Portal Reporting Khusus AkzoNobel / Dulux</a:t>
-            </a:r>
-          </a:p>
-          <a:p>
-            <a:pPr>
-              <a:spcBef>
-                <a:spcPts val="700"/>
-              </a:spcBef>
-              <a:defRPr sz="1000" b="1">
-                <a:solidFill>
-                  <a:srgbClr val="38BDF8"/>
-                </a:solidFill>
-              </a:defRPr>
-            </a:pPr>
-            <a:r>
-              <a:t>🌐 https://fonterra.esagroups.id</a:t>
-            </a:r>
-          </a:p>
-          <a:p>
-            <a:pPr>
-              <a:defRPr sz="900">
-                <a:solidFill>
-                  <a:srgbClr val="FFFFFF"/>
-                </a:solidFill>
-              </a:defRPr>
-            </a:pPr>
-            <a:r>
-              <a:t>   Portal Reporting Anchor, Anlene, Boneeto</a:t>
-            </a:r>
-          </a:p>
-          <a:p>
-            <a:pPr>
-              <a:spcBef>
-                <a:spcPts val="700"/>
-              </a:spcBef>
-              <a:defRPr sz="1000" b="1">
-                <a:solidFill>
-                  <a:srgbClr val="38BDF8"/>
-                </a:solidFill>
-              </a:defRPr>
-            </a:pPr>
-            <a:r>
-              <a:t>🌐 https://wings.esagroups.id</a:t>
-            </a:r>
-          </a:p>
-          <a:p>
-            <a:pPr>
-              <a:defRPr sz="900">
-                <a:solidFill>
-                  <a:srgbClr val="FFFFFF"/>
-                </a:solidFill>
-              </a:defRPr>
-            </a:pPr>
-            <a:r>
-              <a:t>   Portal Reporting Multi-Entitas Wings Group</a:t>
-            </a:r>
-          </a:p>
-          <a:p>
-            <a:pPr>
-              <a:spcBef>
-                <a:spcPts val="700"/>
-              </a:spcBef>
-              <a:defRPr sz="1000" b="1">
-                <a:solidFill>
-                  <a:srgbClr val="38BDF8"/>
-                </a:solidFill>
-              </a:defRPr>
-            </a:pPr>
-            <a:r>
-              <a:t>🌐 https://sidomuncul.esagroups.id</a:t>
-            </a:r>
-          </a:p>
-          <a:p>
-            <a:pPr>
-              <a:defRPr sz="900">
-                <a:solidFill>
-                  <a:srgbClr val="FFFFFF"/>
-                </a:solidFill>
-              </a:defRPr>
-            </a:pPr>
-            <a:r>
-              <a:t>   Portal Reporting PT Sido Muncul</a:t>
-            </a:r>
-          </a:p>
-          <a:p>
-            <a:pPr>
-              <a:spcBef>
-                <a:spcPts val="700"/>
-              </a:spcBef>
-              <a:defRPr sz="1000" b="1">
-                <a:solidFill>
-                  <a:srgbClr val="38BDF8"/>
-                </a:solidFill>
-              </a:defRPr>
-            </a:pPr>
-            <a:r>
-              <a:t>🌐 https://unilever.esagroups.id</a:t>
-            </a:r>
-          </a:p>
-          <a:p>
-            <a:pPr>
-              <a:defRPr sz="900">
-                <a:solidFill>
-                  <a:srgbClr val="FFFFFF"/>
-                </a:solidFill>
-              </a:defRPr>
-            </a:pPr>
-            <a:r>
-              <a:t>   Portal Reporting FMCG Unilever</a:t>
-            </a:r>
-          </a:p>
-          <a:p>
-            <a:pPr>
-              <a:spcBef>
-                <a:spcPts val="700"/>
-              </a:spcBef>
-              <a:defRPr sz="1000" b="1">
-                <a:solidFill>
-                  <a:srgbClr val="38BDF8"/>
-                </a:solidFill>
-              </a:defRPr>
-            </a:pPr>
-            <a:r>
-              <a:t>🌐 https://kalbe.esagroups.id</a:t>
-            </a:r>
-          </a:p>
-          <a:p>
-            <a:pPr>
-              <a:defRPr sz="900">
-                <a:solidFill>
-                  <a:srgbClr val="FFFFFF"/>
-                </a:solidFill>
-              </a:defRPr>
-            </a:pPr>
-            <a:r>
-              <a:t>   Portal Reporting Divisi Pharma &amp; Nutrition</a:t>
+                  <a:srgbClr val="A78BFA"/>
+                </a:solidFill>
+              </a:defRPr>
+            </a:pPr>
+            <a:r>
+              <a:t>{</a:t>
+            </a:r>
+            <a:br/>
+            <a:r>
+              <a:t>  "status": "success",</a:t>
+            </a:r>
+            <a:br/>
+            <a:r>
+              <a:t>  "message": "Login berhasil",</a:t>
+            </a:r>
+            <a:br/>
+            <a:r>
+              <a:t>  "data": {</a:t>
+            </a:r>
+            <a:br/>
+            <a:r>
+              <a:t>    "token": "45|eyJhbGciOiJIUz...",</a:t>
+            </a:r>
+            <a:br/>
+            <a:r>
+              <a:t>    "employee": {</a:t>
+            </a:r>
+            <a:br/>
+            <a:r>
+              <a:t>      "nik": "3578012345670001",</a:t>
+            </a:r>
+            <a:br/>
+            <a:r>
+              <a:t>      "name": "Budi Santoso",</a:t>
+            </a:r>
+            <a:br/>
+            <a:r>
+              <a:t>      "company": "PT ATB",</a:t>
+            </a:r>
+            <a:br/>
+            <a:r>
+              <a:t>      "is_head_spv": true</a:t>
+            </a:r>
+            <a:br/>
+            <a:r>
+              <a:t>    },</a:t>
+            </a:r>
+            <a:br/>
+            <a:r>
+              <a:t>    "routing": {</a:t>
+            </a:r>
+            <a:br/>
+            <a:r>
+              <a:t>      "assigned_server": "SERVER_2",</a:t>
+            </a:r>
+            <a:br/>
+            <a:r>
+              <a:t>      "api_base_url": "https://atb.esagroups.id/api",</a:t>
+            </a:r>
+            <a:br/>
+            <a:r>
+              <a:t>      "media_cdn_url": "https://storage.esagroups.id"</a:t>
+            </a:r>
+            <a:br/>
+            <a:r>
+              <a:t>    }</a:t>
+            </a:r>
+            <a:br/>
+            <a:r>
+              <a:t>  }</a:t>
+            </a:r>
+            <a:br/>
+            <a:r>
+              <a:t>}</a:t>
             </a:r>
           </a:p>
         </p:txBody>
@@ -5561,7 +5517,7 @@
               </a:defRPr>
             </a:pPr>
             <a:r>
-              <a:t>STANDARD OPERATING PROCEDURE</a:t>
+              <a:t>WORKFLOW MANAGEMENT</a:t>
             </a:r>
           </a:p>
         </p:txBody>
@@ -5596,7 +5552,7 @@
               </a:defRPr>
             </a:pPr>
             <a:r>
-              <a:t>Checklist &amp; SOP Konfigurasi Server Produksi</a:t>
+              <a:t>Hierarki Atasan Lintas Entitas (Cross-Entity Hierarchy)</a:t>
             </a:r>
           </a:p>
         </p:txBody>
@@ -5631,7 +5587,7 @@
               </a:defRPr>
             </a:pPr>
             <a:r>
-              <a:t>Panduan langkah demi langkah penyiapan environment 3 Server Cloud VPS hingga Go-Live.</a:t>
+              <a:t>Menangani approval Cuti, Izin, Lembur, dan Monitoring Karyawan yang memiliki Head/SPV di entitas berbeda.</a:t>
             </a:r>
           </a:p>
         </p:txBody>
@@ -5645,7 +5601,7 @@
         <p:spPr>
           <a:xfrm>
             <a:off x="731520" y="1645920"/>
-            <a:ext cx="10728655" cy="868680"/>
+            <a:ext cx="5212080" cy="2103120"/>
           </a:xfrm>
           <a:prstGeom prst="roundRect">
             <a:avLst/>
@@ -5653,9 +5609,9 @@
           <a:solidFill>
             <a:srgbClr val="14203C"/>
           </a:solidFill>
-          <a:ln>
+          <a:ln w="15240">
             <a:solidFill>
-              <a:srgbClr val="2D4473"/>
+              <a:srgbClr val="38BDF8"/>
             </a:solidFill>
           </a:ln>
         </p:spPr>
@@ -5674,18 +5630,475 @@
           </a:fontRef>
         </p:style>
         <p:txBody>
-          <a:bodyPr rtlCol="0" anchor="ctr" wrap="square" lIns="228600" tIns="109728"/>
+          <a:bodyPr rtlCol="0" anchor="ctr" wrap="square" lIns="274320" tIns="228600" rIns="274320"/>
           <a:lstStyle/>
           <a:p>
             <a:pPr algn="ctr">
-              <a:defRPr sz="1100" b="1">
+              <a:defRPr sz="1250" b="1">
                 <a:solidFill>
                   <a:srgbClr val="38BDF8"/>
                 </a:solidFill>
               </a:defRPr>
             </a:pPr>
             <a:r>
-              <a:t>Langkah 1: Provisioning &amp; OS</a:t>
+              <a:t>1. Identifikasi Relasi via NIK Global</a:t>
+            </a:r>
+          </a:p>
+          <a:p>
+            <a:pPr>
+              <a:spcBef>
+                <a:spcPts val="800"/>
+              </a:spcBef>
+              <a:defRPr sz="1000">
+                <a:solidFill>
+                  <a:srgbClr val="E2E8F0"/>
+                </a:solidFill>
+              </a:defRPr>
+            </a:pPr>
+            <a:r>
+              <a:t>Struktur atasan-bawahan dihubungkan menggunakan NIK Karyawan. Jika staf di PT ATB (Server 2) memiliki atasan di PT AMK (Server 1), data mencatat `supervisor_nik = [NIK_SPV_AMK]`.</a:t>
+            </a:r>
+          </a:p>
+        </p:txBody>
+      </p:sp>
+      <p:sp>
+        <p:nvSpPr>
+          <p:cNvPr id="7" name="Rounded Rectangle 6"/>
+          <p:cNvSpPr/>
+          <p:nvPr/>
+        </p:nvSpPr>
+        <p:spPr>
+          <a:xfrm>
+            <a:off x="6217920" y="1645920"/>
+            <a:ext cx="5212080" cy="2103120"/>
+          </a:xfrm>
+          <a:prstGeom prst="roundRect">
+            <a:avLst/>
+          </a:prstGeom>
+          <a:solidFill>
+            <a:srgbClr val="14203C"/>
+          </a:solidFill>
+          <a:ln w="15240">
+            <a:solidFill>
+              <a:srgbClr val="34D399"/>
+            </a:solidFill>
+          </a:ln>
+        </p:spPr>
+        <p:style>
+          <a:lnRef idx="1">
+            <a:schemeClr val="accent1"/>
+          </a:lnRef>
+          <a:fillRef idx="3">
+            <a:schemeClr val="accent1"/>
+          </a:fillRef>
+          <a:effectRef idx="2">
+            <a:schemeClr val="accent1"/>
+          </a:effectRef>
+          <a:fontRef idx="minor">
+            <a:schemeClr val="lt1"/>
+          </a:fontRef>
+        </p:style>
+        <p:txBody>
+          <a:bodyPr rtlCol="0" anchor="ctr" wrap="square" lIns="274320" tIns="228600" rIns="274320"/>
+          <a:lstStyle/>
+          <a:p>
+            <a:pPr algn="ctr">
+              <a:defRPr sz="1250" b="1">
+                <a:solidFill>
+                  <a:srgbClr val="34D399"/>
+                </a:solidFill>
+              </a:defRPr>
+            </a:pPr>
+            <a:r>
+              <a:t>2. Delegasi Notifikasi Approval</a:t>
+            </a:r>
+          </a:p>
+          <a:p>
+            <a:pPr>
+              <a:spcBef>
+                <a:spcPts val="800"/>
+              </a:spcBef>
+              <a:defRPr sz="1000">
+                <a:solidFill>
+                  <a:srgbClr val="E2E8F0"/>
+                </a:solidFill>
+              </a:defRPr>
+            </a:pPr>
+            <a:r>
+              <a:t>Saat staf mengajukan Izin/Cuti/Lembur, event approval diteruskan ke SPV via jalur Private Network (Inter-VPC). Notifikasi langsung muncul di aplikasi mobile SPV secara real-time.</a:t>
+            </a:r>
+          </a:p>
+        </p:txBody>
+      </p:sp>
+      <p:sp>
+        <p:nvSpPr>
+          <p:cNvPr id="8" name="Rounded Rectangle 7"/>
+          <p:cNvSpPr/>
+          <p:nvPr/>
+        </p:nvSpPr>
+        <p:spPr>
+          <a:xfrm>
+            <a:off x="731520" y="4023360"/>
+            <a:ext cx="5212080" cy="2103120"/>
+          </a:xfrm>
+          <a:prstGeom prst="roundRect">
+            <a:avLst/>
+          </a:prstGeom>
+          <a:solidFill>
+            <a:srgbClr val="14203C"/>
+          </a:solidFill>
+          <a:ln w="15240">
+            <a:solidFill>
+              <a:srgbClr val="FBBF24"/>
+            </a:solidFill>
+          </a:ln>
+        </p:spPr>
+        <p:style>
+          <a:lnRef idx="1">
+            <a:schemeClr val="accent1"/>
+          </a:lnRef>
+          <a:fillRef idx="3">
+            <a:schemeClr val="accent1"/>
+          </a:fillRef>
+          <a:effectRef idx="2">
+            <a:schemeClr val="accent1"/>
+          </a:effectRef>
+          <a:fontRef idx="minor">
+            <a:schemeClr val="lt1"/>
+          </a:fontRef>
+        </p:style>
+        <p:txBody>
+          <a:bodyPr rtlCol="0" anchor="ctr" wrap="square" lIns="274320" tIns="228600" rIns="274320"/>
+          <a:lstStyle/>
+          <a:p>
+            <a:pPr algn="ctr">
+              <a:defRPr sz="1250" b="1">
+                <a:solidFill>
+                  <a:srgbClr val="FBBF24"/>
+                </a:solidFill>
+              </a:defRPr>
+            </a:pPr>
+            <a:r>
+              <a:t>3. Single Dashboard Tim bagi SPV</a:t>
+            </a:r>
+          </a:p>
+          <a:p>
+            <a:pPr>
+              <a:spcBef>
+                <a:spcPts val="800"/>
+              </a:spcBef>
+              <a:defRPr sz="1000">
+                <a:solidFill>
+                  <a:srgbClr val="E2E8F0"/>
+                </a:solidFill>
+              </a:defRPr>
+            </a:pPr>
+            <a:r>
+              <a:t>SPV di Server 1 dapat melihat daftar kehadiran dan live tracking seluruh anggotanya (baik anggota dari AMK, ATB, maupun AKP) dalam 1 layar dashboard terpadu tanpa harus berganti akun.</a:t>
+            </a:r>
+          </a:p>
+        </p:txBody>
+      </p:sp>
+      <p:sp>
+        <p:nvSpPr>
+          <p:cNvPr id="9" name="Rounded Rectangle 8"/>
+          <p:cNvSpPr/>
+          <p:nvPr/>
+        </p:nvSpPr>
+        <p:spPr>
+          <a:xfrm>
+            <a:off x="6217920" y="4023360"/>
+            <a:ext cx="5212080" cy="2103120"/>
+          </a:xfrm>
+          <a:prstGeom prst="roundRect">
+            <a:avLst/>
+          </a:prstGeom>
+          <a:solidFill>
+            <a:srgbClr val="14203C"/>
+          </a:solidFill>
+          <a:ln w="15240">
+            <a:solidFill>
+              <a:srgbClr val="A855F7"/>
+            </a:solidFill>
+          </a:ln>
+        </p:spPr>
+        <p:style>
+          <a:lnRef idx="1">
+            <a:schemeClr val="accent1"/>
+          </a:lnRef>
+          <a:fillRef idx="3">
+            <a:schemeClr val="accent1"/>
+          </a:fillRef>
+          <a:effectRef idx="2">
+            <a:schemeClr val="accent1"/>
+          </a:effectRef>
+          <a:fontRef idx="minor">
+            <a:schemeClr val="lt1"/>
+          </a:fontRef>
+        </p:style>
+        <p:txBody>
+          <a:bodyPr rtlCol="0" anchor="ctr" wrap="square" lIns="274320" tIns="228600" rIns="274320"/>
+          <a:lstStyle/>
+          <a:p>
+            <a:pPr algn="ctr">
+              <a:defRPr sz="1250" b="1">
+                <a:solidFill>
+                  <a:srgbClr val="A855F7"/>
+                </a:solidFill>
+              </a:defRPr>
+            </a:pPr>
+            <a:r>
+              <a:t>4. Callback Status Otomatis</a:t>
+            </a:r>
+          </a:p>
+          <a:p>
+            <a:pPr>
+              <a:spcBef>
+                <a:spcPts val="800"/>
+              </a:spcBef>
+              <a:defRPr sz="1000">
+                <a:solidFill>
+                  <a:srgbClr val="E2E8F0"/>
+                </a:solidFill>
+              </a:defRPr>
+            </a:pPr>
+            <a:r>
+              <a:t>Ketika SPV mengklik tombol Approve / Reject, sistem mengupdate status presensi bawahan di server asalnya seketika dan mengirimkan push notification ke staf.</a:t>
+            </a:r>
+          </a:p>
+        </p:txBody>
+      </p:sp>
+    </p:spTree>
+  </p:cSld>
+  <p:clrMapOvr>
+    <a:masterClrMapping/>
+  </p:clrMapOvr>
+</p:sld>
+</file>
+
+<file path=ppt/slides/slide7.xml><?xml version="1.0" encoding="utf-8"?>
+<p:sld xmlns:a="http://schemas.openxmlformats.org/drawingml/2006/main" xmlns:p="http://schemas.openxmlformats.org/presentationml/2006/main" xmlns:r="http://schemas.openxmlformats.org/officeDocument/2006/relationships">
+  <p:cSld>
+    <p:spTree>
+      <p:nvGrpSpPr>
+        <p:cNvPr id="1" name=""/>
+        <p:cNvGrpSpPr/>
+        <p:nvPr/>
+      </p:nvGrpSpPr>
+      <p:grpSpPr/>
+      <p:sp>
+        <p:nvSpPr>
+          <p:cNvPr id="2" name="Rectangle 1"/>
+          <p:cNvSpPr/>
+          <p:nvPr/>
+        </p:nvSpPr>
+        <p:spPr>
+          <a:xfrm>
+            <a:off x="0" y="0"/>
+            <a:ext cx="12191695" cy="6858000"/>
+          </a:xfrm>
+          <a:prstGeom prst="rect">
+            <a:avLst/>
+          </a:prstGeom>
+          <a:solidFill>
+            <a:srgbClr val="0B132B"/>
+          </a:solidFill>
+          <a:ln>
+            <a:noFill/>
+          </a:ln>
+        </p:spPr>
+        <p:style>
+          <a:lnRef idx="1">
+            <a:schemeClr val="accent1"/>
+          </a:lnRef>
+          <a:fillRef idx="3">
+            <a:schemeClr val="accent1"/>
+          </a:fillRef>
+          <a:effectRef idx="2">
+            <a:schemeClr val="accent1"/>
+          </a:effectRef>
+          <a:fontRef idx="minor">
+            <a:schemeClr val="lt1"/>
+          </a:fontRef>
+        </p:style>
+        <p:txBody>
+          <a:bodyPr rtlCol="0" anchor="ctr"/>
+          <a:lstStyle/>
+          <a:p>
+            <a:pPr algn="ctr"/>
+          </a:p>
+        </p:txBody>
+      </p:sp>
+      <p:sp>
+        <p:nvSpPr>
+          <p:cNvPr id="3" name="TextBox 2"/>
+          <p:cNvSpPr txBox="1"/>
+          <p:nvPr/>
+        </p:nvSpPr>
+        <p:spPr>
+          <a:xfrm>
+            <a:off x="731520" y="365760"/>
+            <a:ext cx="10698480" cy="274320"/>
+          </a:xfrm>
+          <a:prstGeom prst="rect">
+            <a:avLst/>
+          </a:prstGeom>
+          <a:noFill/>
+        </p:spPr>
+        <p:txBody>
+          <a:bodyPr wrap="square" lIns="0" tIns="0" rIns="0" bIns="0">
+            <a:spAutoFit/>
+          </a:bodyPr>
+          <a:lstStyle/>
+          <a:p>
+            <a:pPr>
+              <a:defRPr sz="1000" b="1">
+                <a:solidFill>
+                  <a:srgbClr val="38BDF8"/>
+                </a:solidFill>
+              </a:defRPr>
+            </a:pPr>
+            <a:r>
+              <a:t>CLIENT REPORTING PORTAL</a:t>
+            </a:r>
+          </a:p>
+        </p:txBody>
+      </p:sp>
+      <p:sp>
+        <p:nvSpPr>
+          <p:cNvPr id="4" name="TextBox 3"/>
+          <p:cNvSpPr txBox="1"/>
+          <p:nvPr/>
+        </p:nvSpPr>
+        <p:spPr>
+          <a:xfrm>
+            <a:off x="731520" y="640080"/>
+            <a:ext cx="10698480" cy="548640"/>
+          </a:xfrm>
+          <a:prstGeom prst="rect">
+            <a:avLst/>
+          </a:prstGeom>
+          <a:noFill/>
+        </p:spPr>
+        <p:txBody>
+          <a:bodyPr wrap="square" lIns="0" tIns="0" rIns="0" bIns="0">
+            <a:spAutoFit/>
+          </a:bodyPr>
+          <a:lstStyle/>
+          <a:p>
+            <a:pPr>
+              <a:defRPr sz="2200" b="1">
+                <a:solidFill>
+                  <a:srgbClr val="FFFFFF"/>
+                </a:solidFill>
+              </a:defRPr>
+            </a:pPr>
+            <a:r>
+              <a:t>Subdomain Khusus Pelaporan &amp; Monitoring Prinsiple</a:t>
+            </a:r>
+          </a:p>
+        </p:txBody>
+      </p:sp>
+      <p:sp>
+        <p:nvSpPr>
+          <p:cNvPr id="5" name="TextBox 4"/>
+          <p:cNvSpPr txBox="1"/>
+          <p:nvPr/>
+        </p:nvSpPr>
+        <p:spPr>
+          <a:xfrm>
+            <a:off x="731520" y="1188720"/>
+            <a:ext cx="10698480" cy="320040"/>
+          </a:xfrm>
+          <a:prstGeom prst="rect">
+            <a:avLst/>
+          </a:prstGeom>
+          <a:noFill/>
+        </p:spPr>
+        <p:txBody>
+          <a:bodyPr wrap="square" lIns="0" tIns="0" rIns="0" bIns="0">
+            <a:spAutoFit/>
+          </a:bodyPr>
+          <a:lstStyle/>
+          <a:p>
+            <a:pPr>
+              <a:defRPr sz="1100">
+                <a:solidFill>
+                  <a:srgbClr val="94A3B8"/>
+                </a:solidFill>
+              </a:defRPr>
+            </a:pPr>
+            <a:r>
+              <a:t>Portal white-label mandiri bagi prinsiple/klien (Dulux, Fonterra, Wings, dll) dengan akses data terisolasi.</a:t>
+            </a:r>
+          </a:p>
+        </p:txBody>
+      </p:sp>
+      <p:sp>
+        <p:nvSpPr>
+          <p:cNvPr id="6" name="Rounded Rectangle 5"/>
+          <p:cNvSpPr/>
+          <p:nvPr/>
+        </p:nvSpPr>
+        <p:spPr>
+          <a:xfrm>
+            <a:off x="731520" y="1645920"/>
+            <a:ext cx="5669280" cy="4754880"/>
+          </a:xfrm>
+          <a:prstGeom prst="roundRect">
+            <a:avLst/>
+          </a:prstGeom>
+          <a:solidFill>
+            <a:srgbClr val="14203C"/>
+          </a:solidFill>
+          <a:ln w="19050">
+            <a:solidFill>
+              <a:srgbClr val="34D399"/>
+            </a:solidFill>
+          </a:ln>
+        </p:spPr>
+        <p:style>
+          <a:lnRef idx="1">
+            <a:schemeClr val="accent1"/>
+          </a:lnRef>
+          <a:fillRef idx="3">
+            <a:schemeClr val="accent1"/>
+          </a:fillRef>
+          <a:effectRef idx="2">
+            <a:schemeClr val="accent1"/>
+          </a:effectRef>
+          <a:fontRef idx="minor">
+            <a:schemeClr val="lt1"/>
+          </a:fontRef>
+        </p:style>
+        <p:txBody>
+          <a:bodyPr rtlCol="0" anchor="ctr" wrap="square" lIns="274320" tIns="228600" rIns="274320"/>
+          <a:lstStyle/>
+          <a:p>
+            <a:pPr algn="ctr">
+              <a:defRPr sz="1200" b="1">
+                <a:solidFill>
+                  <a:srgbClr val="34D399"/>
+                </a:solidFill>
+              </a:defRPr>
+            </a:pPr>
+            <a:r>
+              <a:t>FITUR PORTAL SUBDOMAIN PRINSIPLE:</a:t>
+            </a:r>
+          </a:p>
+          <a:p>
+            <a:pPr>
+              <a:spcBef>
+                <a:spcPts val="800"/>
+              </a:spcBef>
+              <a:defRPr sz="1050" b="1">
+                <a:solidFill>
+                  <a:srgbClr val="FFFFFF"/>
+                </a:solidFill>
+              </a:defRPr>
+            </a:pPr>
+            <a:r>
+              <a:t>• Wildcard DNS (*.esagroups.id)</a:t>
             </a:r>
           </a:p>
           <a:p>
@@ -5695,12 +6108,102 @@
               </a:spcBef>
               <a:defRPr sz="950">
                 <a:solidFill>
-                  <a:srgbClr val="E2E8F0"/>
-                </a:solidFill>
-              </a:defRPr>
-            </a:pPr>
-            <a:r>
-              <a:t>Instalasi Ubuntu 22.04 LTS 64-bit pada 3 Server Multiverse Ultra. Konfigurasi Private IP Inter-VPC (10.0.1.x) dan SSH Key Authentication.</a:t>
+                  <a:srgbClr val="94A3B8"/>
+                </a:solidFill>
+              </a:defRPr>
+            </a:pPr>
+            <a:r>
+              <a:t>   Cukup 1 konfigurasi DNS wildcard; setiap prinsiple baru otomatis langsung aktif subdomainnya tanpa konfigurasi DNS ulang.</a:t>
+            </a:r>
+          </a:p>
+          <a:p>
+            <a:pPr>
+              <a:spcBef>
+                <a:spcPts val="800"/>
+              </a:spcBef>
+              <a:defRPr sz="1050" b="1">
+                <a:solidFill>
+                  <a:srgbClr val="FFFFFF"/>
+                </a:solidFill>
+              </a:defRPr>
+            </a:pPr>
+            <a:r>
+              <a:t>• White-Label Branding Eksklusif</a:t>
+            </a:r>
+          </a:p>
+          <a:p>
+            <a:pPr>
+              <a:spcBef>
+                <a:spcPts val="200"/>
+              </a:spcBef>
+              <a:defRPr sz="950">
+                <a:solidFill>
+                  <a:srgbClr val="94A3B8"/>
+                </a:solidFill>
+              </a:defRPr>
+            </a:pPr>
+            <a:r>
+              <a:t>   Logo, tema warna, dan nama prinsiple disesuaikan otomatis saat subdomain dibuka (misal: dulux.esagroups.id atau fonterra.esagroups.id).</a:t>
+            </a:r>
+          </a:p>
+          <a:p>
+            <a:pPr>
+              <a:spcBef>
+                <a:spcPts val="800"/>
+              </a:spcBef>
+              <a:defRPr sz="1050" b="1">
+                <a:solidFill>
+                  <a:srgbClr val="FFFFFF"/>
+                </a:solidFill>
+              </a:defRPr>
+            </a:pPr>
+            <a:r>
+              <a:t>• Data Privacy &amp; Strict Isolation</a:t>
+            </a:r>
+          </a:p>
+          <a:p>
+            <a:pPr>
+              <a:spcBef>
+                <a:spcPts val="200"/>
+              </a:spcBef>
+              <a:defRPr sz="950">
+                <a:solidFill>
+                  <a:srgbClr val="94A3B8"/>
+                </a:solidFill>
+              </a:defRPr>
+            </a:pPr>
+            <a:r>
+              <a:t>   Klien HANYA dapat melihat absensi, rute kunjungan toko, dan laporan sales karyawan yang ditempatkan di produk mereka.</a:t>
+            </a:r>
+          </a:p>
+          <a:p>
+            <a:pPr>
+              <a:spcBef>
+                <a:spcPts val="800"/>
+              </a:spcBef>
+              <a:defRPr sz="1050" b="1">
+                <a:solidFill>
+                  <a:srgbClr val="FFFFFF"/>
+                </a:solidFill>
+              </a:defRPr>
+            </a:pPr>
+            <a:r>
+              <a:t>• Self-Service Export Excel / PDF</a:t>
+            </a:r>
+          </a:p>
+          <a:p>
+            <a:pPr>
+              <a:spcBef>
+                <a:spcPts val="200"/>
+              </a:spcBef>
+              <a:defRPr sz="950">
+                <a:solidFill>
+                  <a:srgbClr val="94A3B8"/>
+                </a:solidFill>
+              </a:defRPr>
+            </a:pPr>
+            <a:r>
+              <a:t>   Prinsiple dapat mengunduh rekapitulasi kehadiran dan bukti foto display toko secara mandiri kapan saja.</a:t>
             </a:r>
           </a:p>
         </p:txBody>
@@ -5713,8 +6216,8 @@
         </p:nvSpPr>
         <p:spPr>
           <a:xfrm>
-            <a:off x="731520" y="2606040"/>
-            <a:ext cx="10728655" cy="868680"/>
+            <a:off x="6583680" y="1645920"/>
+            <a:ext cx="4876495" cy="4754880"/>
           </a:xfrm>
           <a:prstGeom prst="roundRect">
             <a:avLst/>
@@ -5743,7 +6246,7 @@
           </a:fontRef>
         </p:style>
         <p:txBody>
-          <a:bodyPr rtlCol="0" anchor="ctr" wrap="square" lIns="228600" tIns="109728"/>
+          <a:bodyPr rtlCol="0" anchor="ctr" wrap="square" lIns="274320" tIns="228600" rIns="274320"/>
           <a:lstStyle/>
           <a:p>
             <a:pPr algn="ctr">
@@ -5754,229 +6257,169 @@
               </a:defRPr>
             </a:pPr>
             <a:r>
-              <a:t>Langkah 2: Web Server &amp; PHP Stack</a:t>
+              <a:t>CONTOH PEMETAAN SUBDOMAIN KLIEN:</a:t>
             </a:r>
           </a:p>
           <a:p>
             <a:pPr>
               <a:spcBef>
-                <a:spcPts val="200"/>
+                <a:spcPts val="700"/>
               </a:spcBef>
-              <a:defRPr sz="950">
-                <a:solidFill>
-                  <a:srgbClr val="E2E8F0"/>
-                </a:solidFill>
-              </a:defRPr>
-            </a:pPr>
-            <a:r>
-              <a:t>Instalasi Nginx Web Server, PHP 8.2-FPM (dengan ekstensi pgsql, redis, gd, zip, xmlrpc, bcmath), dan Supervisor Process Manager.</a:t>
-            </a:r>
-          </a:p>
-        </p:txBody>
-      </p:sp>
-      <p:sp>
-        <p:nvSpPr>
-          <p:cNvPr id="8" name="Rounded Rectangle 7"/>
-          <p:cNvSpPr/>
-          <p:nvPr/>
-        </p:nvSpPr>
-        <p:spPr>
-          <a:xfrm>
-            <a:off x="731520" y="3566160"/>
-            <a:ext cx="10728655" cy="868680"/>
-          </a:xfrm>
-          <a:prstGeom prst="roundRect">
-            <a:avLst/>
-          </a:prstGeom>
-          <a:solidFill>
-            <a:srgbClr val="14203C"/>
-          </a:solidFill>
-          <a:ln>
-            <a:solidFill>
-              <a:srgbClr val="2D4473"/>
-            </a:solidFill>
-          </a:ln>
-        </p:spPr>
-        <p:style>
-          <a:lnRef idx="1">
-            <a:schemeClr val="accent1"/>
-          </a:lnRef>
-          <a:fillRef idx="3">
-            <a:schemeClr val="accent1"/>
-          </a:fillRef>
-          <a:effectRef idx="2">
-            <a:schemeClr val="accent1"/>
-          </a:effectRef>
-          <a:fontRef idx="minor">
-            <a:schemeClr val="lt1"/>
-          </a:fontRef>
-        </p:style>
-        <p:txBody>
-          <a:bodyPr rtlCol="0" anchor="ctr" wrap="square" lIns="228600" tIns="109728"/>
-          <a:lstStyle/>
-          <a:p>
-            <a:pPr algn="ctr">
-              <a:defRPr sz="1100" b="1">
+              <a:defRPr sz="1000" b="1">
                 <a:solidFill>
                   <a:srgbClr val="38BDF8"/>
                 </a:solidFill>
               </a:defRPr>
             </a:pPr>
             <a:r>
-              <a:t>Langkah 3: Database &amp; Caching</a:t>
+              <a:t>🌐 https://dulux.esagroups.id</a:t>
+            </a:r>
+          </a:p>
+          <a:p>
+            <a:pPr>
+              <a:defRPr sz="900">
+                <a:solidFill>
+                  <a:srgbClr val="FFFFFF"/>
+                </a:solidFill>
+              </a:defRPr>
+            </a:pPr>
+            <a:r>
+              <a:t>   Portal Reporting Khusus AkzoNobel / Dulux</a:t>
             </a:r>
           </a:p>
           <a:p>
             <a:pPr>
               <a:spcBef>
-                <a:spcPts val="200"/>
+                <a:spcPts val="700"/>
               </a:spcBef>
-              <a:defRPr sz="950">
-                <a:solidFill>
-                  <a:srgbClr val="E2E8F0"/>
-                </a:solidFill>
-              </a:defRPr>
-            </a:pPr>
-            <a:r>
-              <a:t>Instalasi PostgreSQL 15 / MySQL 8 &amp; Redis Server. Konfigurasi `shared_buffers` 8GB di Server 1 &amp; 2, serta 4GB di Server 3. Optimasi max_connections 500.</a:t>
-            </a:r>
-          </a:p>
-        </p:txBody>
-      </p:sp>
-      <p:sp>
-        <p:nvSpPr>
-          <p:cNvPr id="9" name="Rounded Rectangle 8"/>
-          <p:cNvSpPr/>
-          <p:nvPr/>
-        </p:nvSpPr>
-        <p:spPr>
-          <a:xfrm>
-            <a:off x="731520" y="4526280"/>
-            <a:ext cx="10728655" cy="868680"/>
-          </a:xfrm>
-          <a:prstGeom prst="roundRect">
-            <a:avLst/>
-          </a:prstGeom>
-          <a:solidFill>
-            <a:srgbClr val="0F172A"/>
-          </a:solidFill>
-          <a:ln>
-            <a:solidFill>
-              <a:srgbClr val="2D4473"/>
-            </a:solidFill>
-          </a:ln>
-        </p:spPr>
-        <p:style>
-          <a:lnRef idx="1">
-            <a:schemeClr val="accent1"/>
-          </a:lnRef>
-          <a:fillRef idx="3">
-            <a:schemeClr val="accent1"/>
-          </a:fillRef>
-          <a:effectRef idx="2">
-            <a:schemeClr val="accent1"/>
-          </a:effectRef>
-          <a:fontRef idx="minor">
-            <a:schemeClr val="lt1"/>
-          </a:fontRef>
-        </p:style>
-        <p:txBody>
-          <a:bodyPr rtlCol="0" anchor="ctr" wrap="square" lIns="228600" tIns="109728"/>
-          <a:lstStyle/>
-          <a:p>
-            <a:pPr algn="ctr">
-              <a:defRPr sz="1100" b="1">
+              <a:defRPr sz="1000" b="1">
                 <a:solidFill>
                   <a:srgbClr val="38BDF8"/>
                 </a:solidFill>
               </a:defRPr>
             </a:pPr>
             <a:r>
-              <a:t>Langkah 4: Deploy Script &amp; SSL</a:t>
+              <a:t>🌐 https://fonterra.esagroups.id</a:t>
+            </a:r>
+          </a:p>
+          <a:p>
+            <a:pPr>
+              <a:defRPr sz="900">
+                <a:solidFill>
+                  <a:srgbClr val="FFFFFF"/>
+                </a:solidFill>
+              </a:defRPr>
+            </a:pPr>
+            <a:r>
+              <a:t>   Portal Reporting Anchor, Anlene, Boneeto</a:t>
             </a:r>
           </a:p>
           <a:p>
             <a:pPr>
               <a:spcBef>
-                <a:spcPts val="200"/>
+                <a:spcPts val="700"/>
               </a:spcBef>
-              <a:defRPr sz="950">
-                <a:solidFill>
-                  <a:srgbClr val="E2E8F0"/>
-                </a:solidFill>
-              </a:defRPr>
-            </a:pPr>
-            <a:r>
-              <a:t>Clone repository `att-admin-v12`, jalankan composer install &amp; migration, aktifkan SSL Let's Encrypt Wildcard (*.esagroups.id), dan tes Odoo Sync.</a:t>
-            </a:r>
-          </a:p>
-        </p:txBody>
-      </p:sp>
-      <p:sp>
-        <p:nvSpPr>
-          <p:cNvPr id="10" name="Rounded Rectangle 9"/>
-          <p:cNvSpPr/>
-          <p:nvPr/>
-        </p:nvSpPr>
-        <p:spPr>
-          <a:xfrm>
-            <a:off x="731520" y="5486400"/>
-            <a:ext cx="10728655" cy="868680"/>
-          </a:xfrm>
-          <a:prstGeom prst="roundRect">
-            <a:avLst/>
-          </a:prstGeom>
-          <a:solidFill>
-            <a:srgbClr val="14203C"/>
-          </a:solidFill>
-          <a:ln>
-            <a:solidFill>
-              <a:srgbClr val="2D4473"/>
-            </a:solidFill>
-          </a:ln>
-        </p:spPr>
-        <p:style>
-          <a:lnRef idx="1">
-            <a:schemeClr val="accent1"/>
-          </a:lnRef>
-          <a:fillRef idx="3">
-            <a:schemeClr val="accent1"/>
-          </a:fillRef>
-          <a:effectRef idx="2">
-            <a:schemeClr val="accent1"/>
-          </a:effectRef>
-          <a:fontRef idx="minor">
-            <a:schemeClr val="lt1"/>
-          </a:fontRef>
-        </p:style>
-        <p:txBody>
-          <a:bodyPr rtlCol="0" anchor="ctr" wrap="square" lIns="228600" tIns="109728"/>
-          <a:lstStyle/>
-          <a:p>
-            <a:pPr algn="ctr">
-              <a:defRPr sz="1100" b="1">
+              <a:defRPr sz="1000" b="1">
                 <a:solidFill>
                   <a:srgbClr val="38BDF8"/>
                 </a:solidFill>
               </a:defRPr>
             </a:pPr>
             <a:r>
-              <a:t>Langkah 5: Cron &amp; Object Storage</a:t>
+              <a:t>🌐 https://wings.esagroups.id</a:t>
+            </a:r>
+          </a:p>
+          <a:p>
+            <a:pPr>
+              <a:defRPr sz="900">
+                <a:solidFill>
+                  <a:srgbClr val="FFFFFF"/>
+                </a:solidFill>
+              </a:defRPr>
+            </a:pPr>
+            <a:r>
+              <a:t>   Portal Reporting Multi-Entitas Wings Group</a:t>
             </a:r>
           </a:p>
           <a:p>
             <a:pPr>
               <a:spcBef>
-                <a:spcPts val="200"/>
+                <a:spcPts val="700"/>
               </a:spcBef>
-              <a:defRPr sz="950">
-                <a:solidFill>
-                  <a:srgbClr val="E2E8F0"/>
-                </a:solidFill>
-              </a:defRPr>
-            </a:pPr>
-            <a:r>
-              <a:t>Setting Cron Job harian (01:00 WIB Odoo Sync, 00:05 Auto Reset Roster), hubungkan S3 Object Storage API, dan verifikasi upload selfie kamera.</a:t>
+              <a:defRPr sz="1000" b="1">
+                <a:solidFill>
+                  <a:srgbClr val="38BDF8"/>
+                </a:solidFill>
+              </a:defRPr>
+            </a:pPr>
+            <a:r>
+              <a:t>🌐 https://sidomuncul.esagroups.id</a:t>
+            </a:r>
+          </a:p>
+          <a:p>
+            <a:pPr>
+              <a:defRPr sz="900">
+                <a:solidFill>
+                  <a:srgbClr val="FFFFFF"/>
+                </a:solidFill>
+              </a:defRPr>
+            </a:pPr>
+            <a:r>
+              <a:t>   Portal Reporting PT Sido Muncul</a:t>
+            </a:r>
+          </a:p>
+          <a:p>
+            <a:pPr>
+              <a:spcBef>
+                <a:spcPts val="700"/>
+              </a:spcBef>
+              <a:defRPr sz="1000" b="1">
+                <a:solidFill>
+                  <a:srgbClr val="38BDF8"/>
+                </a:solidFill>
+              </a:defRPr>
+            </a:pPr>
+            <a:r>
+              <a:t>🌐 https://unilever.esagroups.id</a:t>
+            </a:r>
+          </a:p>
+          <a:p>
+            <a:pPr>
+              <a:defRPr sz="900">
+                <a:solidFill>
+                  <a:srgbClr val="FFFFFF"/>
+                </a:solidFill>
+              </a:defRPr>
+            </a:pPr>
+            <a:r>
+              <a:t>   Portal Reporting FMCG Unilever</a:t>
+            </a:r>
+          </a:p>
+          <a:p>
+            <a:pPr>
+              <a:spcBef>
+                <a:spcPts val="700"/>
+              </a:spcBef>
+              <a:defRPr sz="1000" b="1">
+                <a:solidFill>
+                  <a:srgbClr val="38BDF8"/>
+                </a:solidFill>
+              </a:defRPr>
+            </a:pPr>
+            <a:r>
+              <a:t>🌐 https://kalbe.esagroups.id</a:t>
+            </a:r>
+          </a:p>
+          <a:p>
+            <a:pPr>
+              <a:defRPr sz="900">
+                <a:solidFill>
+                  <a:srgbClr val="FFFFFF"/>
+                </a:solidFill>
+              </a:defRPr>
+            </a:pPr>
+            <a:r>
+              <a:t>   Portal Reporting Divisi Pharma &amp; Nutrition</a:t>
             </a:r>
           </a:p>
         </p:txBody>
@@ -5989,7 +6432,7 @@
 </p:sld>
 </file>
 
-<file path=ppt/slides/slide7.xml><?xml version="1.0" encoding="utf-8"?>
+<file path=ppt/slides/slide8.xml><?xml version="1.0" encoding="utf-8"?>
 <p:sld xmlns:a="http://schemas.openxmlformats.org/drawingml/2006/main" xmlns:p="http://schemas.openxmlformats.org/presentationml/2006/main" xmlns:r="http://schemas.openxmlformats.org/officeDocument/2006/relationships">
   <p:cSld>
     <p:spTree>

</xml_diff>

<commit_message>
Fix principal column in report templates and add master auto-deploy script
</commit_message>
<xml_diff>
--- a/Panduan_Arsitektur_dan_Setting_Production_3_Server_ESA.pptx
+++ b/Panduan_Arsitektur_dan_Setting_Production_3_Server_ESA.pptx
@@ -5,16 +5,21 @@
     <p:sldMasterId id="2147483648" r:id="rId1"/>
   </p:sldMasterIdLst>
   <p:sldIdLst>
-    <p:sldId id="256" r:id="rId7"/>
-    <p:sldId id="257" r:id="rId8"/>
-    <p:sldId id="258" r:id="rId9"/>
-    <p:sldId id="259" r:id="rId10"/>
-    <p:sldId id="260" r:id="rId11"/>
-    <p:sldId id="261" r:id="rId12"/>
-    <p:sldId id="262" r:id="rId13"/>
-    <p:sldId id="263" r:id="rId14"/>
+    <p:sldId id="256" r:id="rId2"/>
+    <p:sldId id="257" r:id="rId3"/>
+    <p:sldId id="258" r:id="rId4"/>
+    <p:sldId id="259" r:id="rId5"/>
+    <p:sldId id="260" r:id="rId6"/>
+    <p:sldId id="261" r:id="rId7"/>
+    <p:sldId id="262" r:id="rId8"/>
+    <p:sldId id="263" r:id="rId9"/>
+    <p:sldId id="264" r:id="rId10"/>
+    <p:sldId id="265" r:id="rId11"/>
+    <p:sldId id="266" r:id="rId12"/>
+    <p:sldId id="267" r:id="rId13"/>
+    <p:sldId id="268" r:id="rId14"/>
   </p:sldIdLst>
-  <p:sldSz cx="12191695" cy="6858000" type="screen4x3"/>
+  <p:sldSz cx="12192000" cy="6858000"/>
   <p:notesSz cx="6858000" cy="9144000"/>
   <p:defaultTextStyle>
     <a:defPPr>
@@ -111,6 +116,22 @@
       </a:defRPr>
     </a:lvl9pPr>
   </p:defaultTextStyle>
+  <p:extLst>
+    <p:ext uri="{EFAFB233-063F-42B5-8137-9DF3F51BA10A}">
+      <p15:sldGuideLst xmlns:p15="http://schemas.microsoft.com/office/powerpoint/2012/main">
+        <p15:guide id="1" orient="horz" pos="2160">
+          <p15:clr>
+            <a:srgbClr val="A4A3A4"/>
+          </p15:clr>
+        </p15:guide>
+        <p15:guide id="2" pos="2880">
+          <p15:clr>
+            <a:srgbClr val="A4A3A4"/>
+          </p15:clr>
+        </p15:guide>
+      </p15:sldGuideLst>
+    </p:ext>
+  </p:extLst>
 </p:presentation>
 </file>
 
@@ -152,10 +173,9 @@
           <a:lstStyle/>
           <a:p>
             <a:r>
-              <a:rPr lang="en-US" smtClean="0"/>
+              <a:rPr lang="en-US"/>
               <a:t>Click to edit Master title style</a:t>
             </a:r>
-            <a:endParaRPr lang="en-US"/>
           </a:p>
         </p:txBody>
       </p:sp>
@@ -271,10 +291,9 @@
           </a:lstStyle>
           <a:p>
             <a:r>
-              <a:rPr lang="en-US" smtClean="0"/>
+              <a:rPr lang="en-US"/>
               <a:t>Click to edit Master subtitle style</a:t>
             </a:r>
-            <a:endParaRPr lang="en-US"/>
           </a:p>
         </p:txBody>
       </p:sp>
@@ -295,7 +314,7 @@
           <a:p>
             <a:fld id="{5BCAD085-E8A6-8845-BD4E-CB4CCA059FC4}" type="datetimeFigureOut">
               <a:rPr lang="en-US" smtClean="0"/>
-              <a:t>1/27/13</a:t>
+              <a:t>9/2/2026</a:t>
             </a:fld>
             <a:endParaRPr lang="en-US"/>
           </a:p>
@@ -389,10 +408,9 @@
           <a:lstStyle/>
           <a:p>
             <a:r>
-              <a:rPr lang="en-US" smtClean="0"/>
+              <a:rPr lang="en-US"/>
               <a:t>Click to edit Master title style</a:t>
             </a:r>
-            <a:endParaRPr lang="en-US"/>
           </a:p>
         </p:txBody>
       </p:sp>
@@ -413,38 +431,37 @@
           <a:p>
             <a:pPr lvl="0"/>
             <a:r>
-              <a:rPr lang="en-US" smtClean="0"/>
+              <a:rPr lang="en-US"/>
               <a:t>Click to edit Master text styles</a:t>
             </a:r>
           </a:p>
           <a:p>
             <a:pPr lvl="1"/>
             <a:r>
-              <a:rPr lang="en-US" smtClean="0"/>
+              <a:rPr lang="en-US"/>
               <a:t>Second level</a:t>
             </a:r>
           </a:p>
           <a:p>
             <a:pPr lvl="2"/>
             <a:r>
-              <a:rPr lang="en-US" smtClean="0"/>
+              <a:rPr lang="en-US"/>
               <a:t>Third level</a:t>
             </a:r>
           </a:p>
           <a:p>
             <a:pPr lvl="3"/>
             <a:r>
-              <a:rPr lang="en-US" smtClean="0"/>
+              <a:rPr lang="en-US"/>
               <a:t>Fourth level</a:t>
             </a:r>
           </a:p>
           <a:p>
             <a:pPr lvl="4"/>
             <a:r>
-              <a:rPr lang="en-US" smtClean="0"/>
+              <a:rPr lang="en-US"/>
               <a:t>Fifth level</a:t>
             </a:r>
-            <a:endParaRPr lang="en-US"/>
           </a:p>
         </p:txBody>
       </p:sp>
@@ -465,7 +482,7 @@
           <a:p>
             <a:fld id="{5BCAD085-E8A6-8845-BD4E-CB4CCA059FC4}" type="datetimeFigureOut">
               <a:rPr lang="en-US" smtClean="0"/>
-              <a:t>1/27/13</a:t>
+              <a:t>9/2/2026</a:t>
             </a:fld>
             <a:endParaRPr lang="en-US"/>
           </a:p>
@@ -564,10 +581,9 @@
           <a:lstStyle/>
           <a:p>
             <a:r>
-              <a:rPr lang="en-US" smtClean="0"/>
+              <a:rPr lang="en-US"/>
               <a:t>Click to edit Master title style</a:t>
             </a:r>
-            <a:endParaRPr lang="en-US"/>
           </a:p>
         </p:txBody>
       </p:sp>
@@ -593,38 +609,37 @@
           <a:p>
             <a:pPr lvl="0"/>
             <a:r>
-              <a:rPr lang="en-US" smtClean="0"/>
+              <a:rPr lang="en-US"/>
               <a:t>Click to edit Master text styles</a:t>
             </a:r>
           </a:p>
           <a:p>
             <a:pPr lvl="1"/>
             <a:r>
-              <a:rPr lang="en-US" smtClean="0"/>
+              <a:rPr lang="en-US"/>
               <a:t>Second level</a:t>
             </a:r>
           </a:p>
           <a:p>
             <a:pPr lvl="2"/>
             <a:r>
-              <a:rPr lang="en-US" smtClean="0"/>
+              <a:rPr lang="en-US"/>
               <a:t>Third level</a:t>
             </a:r>
           </a:p>
           <a:p>
             <a:pPr lvl="3"/>
             <a:r>
-              <a:rPr lang="en-US" smtClean="0"/>
+              <a:rPr lang="en-US"/>
               <a:t>Fourth level</a:t>
             </a:r>
           </a:p>
           <a:p>
             <a:pPr lvl="4"/>
             <a:r>
-              <a:rPr lang="en-US" smtClean="0"/>
+              <a:rPr lang="en-US"/>
               <a:t>Fifth level</a:t>
             </a:r>
-            <a:endParaRPr lang="en-US"/>
           </a:p>
         </p:txBody>
       </p:sp>
@@ -645,7 +660,7 @@
           <a:p>
             <a:fld id="{5BCAD085-E8A6-8845-BD4E-CB4CCA059FC4}" type="datetimeFigureOut">
               <a:rPr lang="en-US" smtClean="0"/>
-              <a:t>1/27/13</a:t>
+              <a:t>9/2/2026</a:t>
             </a:fld>
             <a:endParaRPr lang="en-US"/>
           </a:p>
@@ -739,10 +754,9 @@
           <a:lstStyle/>
           <a:p>
             <a:r>
-              <a:rPr lang="en-US" smtClean="0"/>
+              <a:rPr lang="en-US"/>
               <a:t>Click to edit Master title style</a:t>
             </a:r>
-            <a:endParaRPr lang="en-US"/>
           </a:p>
         </p:txBody>
       </p:sp>
@@ -763,38 +777,37 @@
           <a:p>
             <a:pPr lvl="0"/>
             <a:r>
-              <a:rPr lang="en-US" smtClean="0"/>
+              <a:rPr lang="en-US"/>
               <a:t>Click to edit Master text styles</a:t>
             </a:r>
           </a:p>
           <a:p>
             <a:pPr lvl="1"/>
             <a:r>
-              <a:rPr lang="en-US" smtClean="0"/>
+              <a:rPr lang="en-US"/>
               <a:t>Second level</a:t>
             </a:r>
           </a:p>
           <a:p>
             <a:pPr lvl="2"/>
             <a:r>
-              <a:rPr lang="en-US" smtClean="0"/>
+              <a:rPr lang="en-US"/>
               <a:t>Third level</a:t>
             </a:r>
           </a:p>
           <a:p>
             <a:pPr lvl="3"/>
             <a:r>
-              <a:rPr lang="en-US" smtClean="0"/>
+              <a:rPr lang="en-US"/>
               <a:t>Fourth level</a:t>
             </a:r>
           </a:p>
           <a:p>
             <a:pPr lvl="4"/>
             <a:r>
-              <a:rPr lang="en-US" smtClean="0"/>
+              <a:rPr lang="en-US"/>
               <a:t>Fifth level</a:t>
             </a:r>
-            <a:endParaRPr lang="en-US"/>
           </a:p>
         </p:txBody>
       </p:sp>
@@ -815,7 +828,7 @@
           <a:p>
             <a:fld id="{5BCAD085-E8A6-8845-BD4E-CB4CCA059FC4}" type="datetimeFigureOut">
               <a:rPr lang="en-US" smtClean="0"/>
-              <a:t>1/27/13</a:t>
+              <a:t>9/2/2026</a:t>
             </a:fld>
             <a:endParaRPr lang="en-US"/>
           </a:p>
@@ -918,10 +931,9 @@
           </a:lstStyle>
           <a:p>
             <a:r>
-              <a:rPr lang="en-US" smtClean="0"/>
+              <a:rPr lang="en-US"/>
               <a:t>Click to edit Master title style</a:t>
             </a:r>
-            <a:endParaRPr lang="en-US"/>
           </a:p>
         </p:txBody>
       </p:sp>
@@ -1038,7 +1050,7 @@
           <a:p>
             <a:pPr lvl="0"/>
             <a:r>
-              <a:rPr lang="en-US" smtClean="0"/>
+              <a:rPr lang="en-US"/>
               <a:t>Click to edit Master text styles</a:t>
             </a:r>
           </a:p>
@@ -1061,7 +1073,7 @@
           <a:p>
             <a:fld id="{5BCAD085-E8A6-8845-BD4E-CB4CCA059FC4}" type="datetimeFigureOut">
               <a:rPr lang="en-US" smtClean="0"/>
-              <a:t>1/27/13</a:t>
+              <a:t>9/2/2026</a:t>
             </a:fld>
             <a:endParaRPr lang="en-US"/>
           </a:p>
@@ -1155,10 +1167,9 @@
           <a:lstStyle/>
           <a:p>
             <a:r>
-              <a:rPr lang="en-US" smtClean="0"/>
+              <a:rPr lang="en-US"/>
               <a:t>Click to edit Master title style</a:t>
             </a:r>
-            <a:endParaRPr lang="en-US"/>
           </a:p>
         </p:txBody>
       </p:sp>
@@ -1212,38 +1223,37 @@
           <a:p>
             <a:pPr lvl="0"/>
             <a:r>
-              <a:rPr lang="en-US" smtClean="0"/>
+              <a:rPr lang="en-US"/>
               <a:t>Click to edit Master text styles</a:t>
             </a:r>
           </a:p>
           <a:p>
             <a:pPr lvl="1"/>
             <a:r>
-              <a:rPr lang="en-US" smtClean="0"/>
+              <a:rPr lang="en-US"/>
               <a:t>Second level</a:t>
             </a:r>
           </a:p>
           <a:p>
             <a:pPr lvl="2"/>
             <a:r>
-              <a:rPr lang="en-US" smtClean="0"/>
+              <a:rPr lang="en-US"/>
               <a:t>Third level</a:t>
             </a:r>
           </a:p>
           <a:p>
             <a:pPr lvl="3"/>
             <a:r>
-              <a:rPr lang="en-US" smtClean="0"/>
+              <a:rPr lang="en-US"/>
               <a:t>Fourth level</a:t>
             </a:r>
           </a:p>
           <a:p>
             <a:pPr lvl="4"/>
             <a:r>
-              <a:rPr lang="en-US" smtClean="0"/>
+              <a:rPr lang="en-US"/>
               <a:t>Fifth level</a:t>
             </a:r>
-            <a:endParaRPr lang="en-US"/>
           </a:p>
         </p:txBody>
       </p:sp>
@@ -1297,38 +1307,37 @@
           <a:p>
             <a:pPr lvl="0"/>
             <a:r>
-              <a:rPr lang="en-US" smtClean="0"/>
+              <a:rPr lang="en-US"/>
               <a:t>Click to edit Master text styles</a:t>
             </a:r>
           </a:p>
           <a:p>
             <a:pPr lvl="1"/>
             <a:r>
-              <a:rPr lang="en-US" smtClean="0"/>
+              <a:rPr lang="en-US"/>
               <a:t>Second level</a:t>
             </a:r>
           </a:p>
           <a:p>
             <a:pPr lvl="2"/>
             <a:r>
-              <a:rPr lang="en-US" smtClean="0"/>
+              <a:rPr lang="en-US"/>
               <a:t>Third level</a:t>
             </a:r>
           </a:p>
           <a:p>
             <a:pPr lvl="3"/>
             <a:r>
-              <a:rPr lang="en-US" smtClean="0"/>
+              <a:rPr lang="en-US"/>
               <a:t>Fourth level</a:t>
             </a:r>
           </a:p>
           <a:p>
             <a:pPr lvl="4"/>
             <a:r>
-              <a:rPr lang="en-US" smtClean="0"/>
+              <a:rPr lang="en-US"/>
               <a:t>Fifth level</a:t>
             </a:r>
-            <a:endParaRPr lang="en-US"/>
           </a:p>
         </p:txBody>
       </p:sp>
@@ -1349,7 +1358,7 @@
           <a:p>
             <a:fld id="{5BCAD085-E8A6-8845-BD4E-CB4CCA059FC4}" type="datetimeFigureOut">
               <a:rPr lang="en-US" smtClean="0"/>
-              <a:t>1/27/13</a:t>
+              <a:t>9/2/2026</a:t>
             </a:fld>
             <a:endParaRPr lang="en-US"/>
           </a:p>
@@ -1447,10 +1456,9 @@
           </a:lstStyle>
           <a:p>
             <a:r>
-              <a:rPr lang="en-US" smtClean="0"/>
+              <a:rPr lang="en-US"/>
               <a:t>Click to edit Master title style</a:t>
             </a:r>
-            <a:endParaRPr lang="en-US"/>
           </a:p>
         </p:txBody>
       </p:sp>
@@ -1513,7 +1521,7 @@
           <a:p>
             <a:pPr lvl="0"/>
             <a:r>
-              <a:rPr lang="en-US" smtClean="0"/>
+              <a:rPr lang="en-US"/>
               <a:t>Click to edit Master text styles</a:t>
             </a:r>
           </a:p>
@@ -1569,38 +1577,37 @@
           <a:p>
             <a:pPr lvl="0"/>
             <a:r>
-              <a:rPr lang="en-US" smtClean="0"/>
+              <a:rPr lang="en-US"/>
               <a:t>Click to edit Master text styles</a:t>
             </a:r>
           </a:p>
           <a:p>
             <a:pPr lvl="1"/>
             <a:r>
-              <a:rPr lang="en-US" smtClean="0"/>
+              <a:rPr lang="en-US"/>
               <a:t>Second level</a:t>
             </a:r>
           </a:p>
           <a:p>
             <a:pPr lvl="2"/>
             <a:r>
-              <a:rPr lang="en-US" smtClean="0"/>
+              <a:rPr lang="en-US"/>
               <a:t>Third level</a:t>
             </a:r>
           </a:p>
           <a:p>
             <a:pPr lvl="3"/>
             <a:r>
-              <a:rPr lang="en-US" smtClean="0"/>
+              <a:rPr lang="en-US"/>
               <a:t>Fourth level</a:t>
             </a:r>
           </a:p>
           <a:p>
             <a:pPr lvl="4"/>
             <a:r>
-              <a:rPr lang="en-US" smtClean="0"/>
+              <a:rPr lang="en-US"/>
               <a:t>Fifth level</a:t>
             </a:r>
-            <a:endParaRPr lang="en-US"/>
           </a:p>
         </p:txBody>
       </p:sp>
@@ -1663,7 +1670,7 @@
           <a:p>
             <a:pPr lvl="0"/>
             <a:r>
-              <a:rPr lang="en-US" smtClean="0"/>
+              <a:rPr lang="en-US"/>
               <a:t>Click to edit Master text styles</a:t>
             </a:r>
           </a:p>
@@ -1719,38 +1726,37 @@
           <a:p>
             <a:pPr lvl="0"/>
             <a:r>
-              <a:rPr lang="en-US" smtClean="0"/>
+              <a:rPr lang="en-US"/>
               <a:t>Click to edit Master text styles</a:t>
             </a:r>
           </a:p>
           <a:p>
             <a:pPr lvl="1"/>
             <a:r>
-              <a:rPr lang="en-US" smtClean="0"/>
+              <a:rPr lang="en-US"/>
               <a:t>Second level</a:t>
             </a:r>
           </a:p>
           <a:p>
             <a:pPr lvl="2"/>
             <a:r>
-              <a:rPr lang="en-US" smtClean="0"/>
+              <a:rPr lang="en-US"/>
               <a:t>Third level</a:t>
             </a:r>
           </a:p>
           <a:p>
             <a:pPr lvl="3"/>
             <a:r>
-              <a:rPr lang="en-US" smtClean="0"/>
+              <a:rPr lang="en-US"/>
               <a:t>Fourth level</a:t>
             </a:r>
           </a:p>
           <a:p>
             <a:pPr lvl="4"/>
             <a:r>
-              <a:rPr lang="en-US" smtClean="0"/>
+              <a:rPr lang="en-US"/>
               <a:t>Fifth level</a:t>
             </a:r>
-            <a:endParaRPr lang="en-US"/>
           </a:p>
         </p:txBody>
       </p:sp>
@@ -1771,7 +1777,7 @@
           <a:p>
             <a:fld id="{5BCAD085-E8A6-8845-BD4E-CB4CCA059FC4}" type="datetimeFigureOut">
               <a:rPr lang="en-US" smtClean="0"/>
-              <a:t>1/27/13</a:t>
+              <a:t>9/2/2026</a:t>
             </a:fld>
             <a:endParaRPr lang="en-US"/>
           </a:p>
@@ -1865,10 +1871,9 @@
           <a:lstStyle/>
           <a:p>
             <a:r>
-              <a:rPr lang="en-US" smtClean="0"/>
+              <a:rPr lang="en-US"/>
               <a:t>Click to edit Master title style</a:t>
             </a:r>
-            <a:endParaRPr lang="en-US"/>
           </a:p>
         </p:txBody>
       </p:sp>
@@ -1889,7 +1894,7 @@
           <a:p>
             <a:fld id="{5BCAD085-E8A6-8845-BD4E-CB4CCA059FC4}" type="datetimeFigureOut">
               <a:rPr lang="en-US" smtClean="0"/>
-              <a:t>1/27/13</a:t>
+              <a:t>9/2/2026</a:t>
             </a:fld>
             <a:endParaRPr lang="en-US"/>
           </a:p>
@@ -1984,7 +1989,7 @@
           <a:p>
             <a:fld id="{5BCAD085-E8A6-8845-BD4E-CB4CCA059FC4}" type="datetimeFigureOut">
               <a:rPr lang="en-US" smtClean="0"/>
-              <a:t>1/27/13</a:t>
+              <a:t>9/2/2026</a:t>
             </a:fld>
             <a:endParaRPr lang="en-US"/>
           </a:p>
@@ -2087,10 +2092,9 @@
           </a:lstStyle>
           <a:p>
             <a:r>
-              <a:rPr lang="en-US" smtClean="0"/>
+              <a:rPr lang="en-US"/>
               <a:t>Click to edit Master title style</a:t>
             </a:r>
-            <a:endParaRPr lang="en-US"/>
           </a:p>
         </p:txBody>
       </p:sp>
@@ -2144,38 +2148,37 @@
           <a:p>
             <a:pPr lvl="0"/>
             <a:r>
-              <a:rPr lang="en-US" smtClean="0"/>
+              <a:rPr lang="en-US"/>
               <a:t>Click to edit Master text styles</a:t>
             </a:r>
           </a:p>
           <a:p>
             <a:pPr lvl="1"/>
             <a:r>
-              <a:rPr lang="en-US" smtClean="0"/>
+              <a:rPr lang="en-US"/>
               <a:t>Second level</a:t>
             </a:r>
           </a:p>
           <a:p>
             <a:pPr lvl="2"/>
             <a:r>
-              <a:rPr lang="en-US" smtClean="0"/>
+              <a:rPr lang="en-US"/>
               <a:t>Third level</a:t>
             </a:r>
           </a:p>
           <a:p>
             <a:pPr lvl="3"/>
             <a:r>
-              <a:rPr lang="en-US" smtClean="0"/>
+              <a:rPr lang="en-US"/>
               <a:t>Fourth level</a:t>
             </a:r>
           </a:p>
           <a:p>
             <a:pPr lvl="4"/>
             <a:r>
-              <a:rPr lang="en-US" smtClean="0"/>
+              <a:rPr lang="en-US"/>
               <a:t>Fifth level</a:t>
             </a:r>
-            <a:endParaRPr lang="en-US"/>
           </a:p>
         </p:txBody>
       </p:sp>
@@ -2238,7 +2241,7 @@
           <a:p>
             <a:pPr lvl="0"/>
             <a:r>
-              <a:rPr lang="en-US" smtClean="0"/>
+              <a:rPr lang="en-US"/>
               <a:t>Click to edit Master text styles</a:t>
             </a:r>
           </a:p>
@@ -2261,7 +2264,7 @@
           <a:p>
             <a:fld id="{5BCAD085-E8A6-8845-BD4E-CB4CCA059FC4}" type="datetimeFigureOut">
               <a:rPr lang="en-US" smtClean="0"/>
-              <a:t>1/27/13</a:t>
+              <a:t>9/2/2026</a:t>
             </a:fld>
             <a:endParaRPr lang="en-US"/>
           </a:p>
@@ -2364,10 +2367,9 @@
           </a:lstStyle>
           <a:p>
             <a:r>
-              <a:rPr lang="en-US" smtClean="0"/>
+              <a:rPr lang="en-US"/>
               <a:t>Click to edit Master title style</a:t>
             </a:r>
-            <a:endParaRPr lang="en-US"/>
           </a:p>
         </p:txBody>
       </p:sp>
@@ -2491,7 +2493,7 @@
           <a:p>
             <a:pPr lvl="0"/>
             <a:r>
-              <a:rPr lang="en-US" smtClean="0"/>
+              <a:rPr lang="en-US"/>
               <a:t>Click to edit Master text styles</a:t>
             </a:r>
           </a:p>
@@ -2514,7 +2516,7 @@
           <a:p>
             <a:fld id="{5BCAD085-E8A6-8845-BD4E-CB4CCA059FC4}" type="datetimeFigureOut">
               <a:rPr lang="en-US" smtClean="0"/>
-              <a:t>1/27/13</a:t>
+              <a:t>9/2/2026</a:t>
             </a:fld>
             <a:endParaRPr lang="en-US"/>
           </a:p>
@@ -2623,10 +2625,9 @@
           <a:lstStyle/>
           <a:p>
             <a:r>
-              <a:rPr lang="en-US" smtClean="0"/>
+              <a:rPr lang="en-US"/>
               <a:t>Click to edit Master title style</a:t>
             </a:r>
-            <a:endParaRPr lang="en-US"/>
           </a:p>
         </p:txBody>
       </p:sp>
@@ -2657,38 +2658,37 @@
           <a:p>
             <a:pPr lvl="0"/>
             <a:r>
-              <a:rPr lang="en-US" smtClean="0"/>
+              <a:rPr lang="en-US"/>
               <a:t>Click to edit Master text styles</a:t>
             </a:r>
           </a:p>
           <a:p>
             <a:pPr lvl="1"/>
             <a:r>
-              <a:rPr lang="en-US" smtClean="0"/>
+              <a:rPr lang="en-US"/>
               <a:t>Second level</a:t>
             </a:r>
           </a:p>
           <a:p>
             <a:pPr lvl="2"/>
             <a:r>
-              <a:rPr lang="en-US" smtClean="0"/>
+              <a:rPr lang="en-US"/>
               <a:t>Third level</a:t>
             </a:r>
           </a:p>
           <a:p>
             <a:pPr lvl="3"/>
             <a:r>
-              <a:rPr lang="en-US" smtClean="0"/>
+              <a:rPr lang="en-US"/>
               <a:t>Fourth level</a:t>
             </a:r>
           </a:p>
           <a:p>
             <a:pPr lvl="4"/>
             <a:r>
-              <a:rPr lang="en-US" smtClean="0"/>
+              <a:rPr lang="en-US"/>
               <a:t>Fifth level</a:t>
             </a:r>
-            <a:endParaRPr lang="en-US"/>
           </a:p>
         </p:txBody>
       </p:sp>
@@ -2727,7 +2727,7 @@
           <a:p>
             <a:fld id="{5BCAD085-E8A6-8845-BD4E-CB4CCA059FC4}" type="datetimeFigureOut">
               <a:rPr lang="en-US" smtClean="0"/>
-              <a:t>1/27/13</a:t>
+              <a:t>9/2/2026</a:t>
             </a:fld>
             <a:endParaRPr lang="en-US"/>
           </a:p>
@@ -3086,7 +3086,7 @@
 </file>
 
 <file path=ppt/slides/slide1.xml><?xml version="1.0" encoding="utf-8"?>
-<p:sld xmlns:a="http://schemas.openxmlformats.org/drawingml/2006/main" xmlns:p="http://schemas.openxmlformats.org/presentationml/2006/main" xmlns:r="http://schemas.openxmlformats.org/officeDocument/2006/relationships">
+<p:sld xmlns:a="http://schemas.openxmlformats.org/drawingml/2006/main" xmlns:r="http://schemas.openxmlformats.org/officeDocument/2006/relationships" xmlns:p="http://schemas.openxmlformats.org/presentationml/2006/main">
   <p:cSld>
     <p:spTree>
       <p:nvGrpSpPr>
@@ -3094,7 +3094,14 @@
         <p:cNvGrpSpPr/>
         <p:nvPr/>
       </p:nvGrpSpPr>
-      <p:grpSpPr/>
+      <p:grpSpPr>
+        <a:xfrm>
+          <a:off x="0" y="0"/>
+          <a:ext cx="0" cy="0"/>
+          <a:chOff x="0" y="0"/>
+          <a:chExt cx="0" cy="0"/>
+        </a:xfrm>
+      </p:grpSpPr>
       <p:sp>
         <p:nvSpPr>
           <p:cNvPr id="2" name="Rectangle 1"/>
@@ -3135,6 +3142,7 @@
           <a:lstStyle/>
           <a:p>
             <a:pPr algn="ctr"/>
+            <a:endParaRPr/>
           </a:p>
         </p:txBody>
       </p:sp>
@@ -3180,6 +3188,7 @@
           <a:lstStyle/>
           <a:p>
             <a:pPr algn="ctr"/>
+            <a:endParaRPr/>
           </a:p>
         </p:txBody>
       </p:sp>
@@ -3340,7 +3349,7 @@
           </a:fontRef>
         </p:style>
         <p:txBody>
-          <a:bodyPr rtlCol="0" anchor="ctr" wrap="square" lIns="274320" tIns="164592"/>
+          <a:bodyPr wrap="square" lIns="274320" tIns="164592" rtlCol="0" anchor="ctr"/>
           <a:lstStyle/>
           <a:p>
             <a:pPr algn="ctr">
@@ -3409,8 +3418,252 @@
 </p:sld>
 </file>
 
-<file path=ppt/slides/slide2.xml><?xml version="1.0" encoding="utf-8"?>
-<p:sld xmlns:a="http://schemas.openxmlformats.org/drawingml/2006/main" xmlns:p="http://schemas.openxmlformats.org/presentationml/2006/main" xmlns:r="http://schemas.openxmlformats.org/officeDocument/2006/relationships">
+<file path=ppt/slides/slide10.xml><?xml version="1.0" encoding="utf-8"?>
+<p:sld xmlns:a="http://schemas.openxmlformats.org/drawingml/2006/main" xmlns:r="http://schemas.openxmlformats.org/officeDocument/2006/relationships" xmlns:p="http://schemas.openxmlformats.org/presentationml/2006/main">
+  <p:cSld>
+    <p:spTree>
+      <p:nvGrpSpPr>
+        <p:cNvPr id="1" name="">
+          <a:extLst>
+            <a:ext uri="{FF2B5EF4-FFF2-40B4-BE49-F238E27FC236}">
+              <a16:creationId xmlns:a16="http://schemas.microsoft.com/office/drawing/2014/main" id="{D2DEC914-913C-46C0-9684-D729B58D1158}"/>
+            </a:ext>
+          </a:extLst>
+        </p:cNvPr>
+        <p:cNvGrpSpPr/>
+        <p:nvPr/>
+      </p:nvGrpSpPr>
+      <p:grpSpPr>
+        <a:xfrm>
+          <a:off x="0" y="0"/>
+          <a:ext cx="0" cy="0"/>
+          <a:chOff x="0" y="0"/>
+          <a:chExt cx="0" cy="0"/>
+        </a:xfrm>
+      </p:grpSpPr>
+      <p:pic>
+        <p:nvPicPr>
+          <p:cNvPr id="3" name="Picture 2">
+            <a:extLst>
+              <a:ext uri="{FF2B5EF4-FFF2-40B4-BE49-F238E27FC236}">
+                <a16:creationId xmlns:a16="http://schemas.microsoft.com/office/drawing/2014/main" id="{308258E7-D11F-629A-608F-6FC46A5BA869}"/>
+              </a:ext>
+            </a:extLst>
+          </p:cNvPr>
+          <p:cNvPicPr>
+            <a:picLocks noChangeAspect="1"/>
+          </p:cNvPicPr>
+          <p:nvPr/>
+        </p:nvPicPr>
+        <p:blipFill>
+          <a:blip r:embed="rId2"/>
+          <a:srcRect/>
+          <a:stretch/>
+        </p:blipFill>
+        <p:spPr>
+          <a:xfrm>
+            <a:off x="3139797" y="798117"/>
+            <a:ext cx="5893367" cy="5641671"/>
+          </a:xfrm>
+          <a:prstGeom prst="rect">
+            <a:avLst/>
+          </a:prstGeom>
+        </p:spPr>
+      </p:pic>
+      <p:sp>
+        <p:nvSpPr>
+          <p:cNvPr id="4" name="TextBox 3">
+            <a:extLst>
+              <a:ext uri="{FF2B5EF4-FFF2-40B4-BE49-F238E27FC236}">
+                <a16:creationId xmlns:a16="http://schemas.microsoft.com/office/drawing/2014/main" id="{896D59EB-1AE3-399B-DDC1-657FB7694007}"/>
+              </a:ext>
+            </a:extLst>
+          </p:cNvPr>
+          <p:cNvSpPr txBox="1"/>
+          <p:nvPr/>
+        </p:nvSpPr>
+        <p:spPr>
+          <a:xfrm>
+            <a:off x="371302" y="279203"/>
+            <a:ext cx="10698480" cy="338554"/>
+          </a:xfrm>
+          <a:prstGeom prst="rect">
+            <a:avLst/>
+          </a:prstGeom>
+          <a:noFill/>
+        </p:spPr>
+        <p:txBody>
+          <a:bodyPr wrap="square" lIns="0" tIns="0" rIns="0" bIns="0">
+            <a:spAutoFit/>
+          </a:bodyPr>
+          <a:lstStyle/>
+          <a:p>
+            <a:pPr>
+              <a:defRPr sz="2200" b="1">
+                <a:solidFill>
+                  <a:srgbClr val="FFFFFF"/>
+                </a:solidFill>
+              </a:defRPr>
+            </a:pPr>
+            <a:r>
+              <a:rPr lang="en-US" dirty="0">
+                <a:solidFill>
+                  <a:schemeClr val="tx1">
+                    <a:lumMod val="95000"/>
+                    <a:lumOff val="5000"/>
+                  </a:schemeClr>
+                </a:solidFill>
+              </a:rPr>
+              <a:t>Server 2 – PT ALVA KARYA PERKASA (AKP)</a:t>
+            </a:r>
+            <a:endParaRPr dirty="0">
+              <a:solidFill>
+                <a:schemeClr val="tx1">
+                  <a:lumMod val="95000"/>
+                  <a:lumOff val="5000"/>
+                </a:schemeClr>
+              </a:solidFill>
+            </a:endParaRPr>
+          </a:p>
+        </p:txBody>
+      </p:sp>
+    </p:spTree>
+    <p:extLst>
+      <p:ext uri="{BB962C8B-B14F-4D97-AF65-F5344CB8AC3E}">
+        <p14:creationId xmlns:p14="http://schemas.microsoft.com/office/powerpoint/2010/main" val="436214597"/>
+      </p:ext>
+    </p:extLst>
+  </p:cSld>
+  <p:clrMapOvr>
+    <a:masterClrMapping/>
+  </p:clrMapOvr>
+</p:sld>
+</file>
+
+<file path=ppt/slides/slide11.xml><?xml version="1.0" encoding="utf-8"?>
+<p:sld xmlns:a="http://schemas.openxmlformats.org/drawingml/2006/main" xmlns:r="http://schemas.openxmlformats.org/officeDocument/2006/relationships" xmlns:p="http://schemas.openxmlformats.org/presentationml/2006/main">
+  <p:cSld>
+    <p:spTree>
+      <p:nvGrpSpPr>
+        <p:cNvPr id="1" name="">
+          <a:extLst>
+            <a:ext uri="{FF2B5EF4-FFF2-40B4-BE49-F238E27FC236}">
+              <a16:creationId xmlns:a16="http://schemas.microsoft.com/office/drawing/2014/main" id="{DC93D9E3-B8CA-C9DC-255A-A51E284D0641}"/>
+            </a:ext>
+          </a:extLst>
+        </p:cNvPr>
+        <p:cNvGrpSpPr/>
+        <p:nvPr/>
+      </p:nvGrpSpPr>
+      <p:grpSpPr>
+        <a:xfrm>
+          <a:off x="0" y="0"/>
+          <a:ext cx="0" cy="0"/>
+          <a:chOff x="0" y="0"/>
+          <a:chExt cx="0" cy="0"/>
+        </a:xfrm>
+      </p:grpSpPr>
+      <p:pic>
+        <p:nvPicPr>
+          <p:cNvPr id="3" name="Picture 2">
+            <a:extLst>
+              <a:ext uri="{FF2B5EF4-FFF2-40B4-BE49-F238E27FC236}">
+                <a16:creationId xmlns:a16="http://schemas.microsoft.com/office/drawing/2014/main" id="{5B053F01-0879-8966-39F1-F395BA6D81AA}"/>
+              </a:ext>
+            </a:extLst>
+          </p:cNvPr>
+          <p:cNvPicPr>
+            <a:picLocks noChangeAspect="1"/>
+          </p:cNvPicPr>
+          <p:nvPr/>
+        </p:nvPicPr>
+        <p:blipFill>
+          <a:blip r:embed="rId2"/>
+          <a:srcRect/>
+          <a:stretch/>
+        </p:blipFill>
+        <p:spPr>
+          <a:xfrm>
+            <a:off x="3253667" y="798117"/>
+            <a:ext cx="5665627" cy="5641671"/>
+          </a:xfrm>
+          <a:prstGeom prst="rect">
+            <a:avLst/>
+          </a:prstGeom>
+        </p:spPr>
+      </p:pic>
+      <p:sp>
+        <p:nvSpPr>
+          <p:cNvPr id="4" name="TextBox 3">
+            <a:extLst>
+              <a:ext uri="{FF2B5EF4-FFF2-40B4-BE49-F238E27FC236}">
+                <a16:creationId xmlns:a16="http://schemas.microsoft.com/office/drawing/2014/main" id="{7854E9CE-CF1F-444F-3D6E-4B4F9A617D87}"/>
+              </a:ext>
+            </a:extLst>
+          </p:cNvPr>
+          <p:cNvSpPr txBox="1"/>
+          <p:nvPr/>
+        </p:nvSpPr>
+        <p:spPr>
+          <a:xfrm>
+            <a:off x="371302" y="279203"/>
+            <a:ext cx="10698480" cy="338554"/>
+          </a:xfrm>
+          <a:prstGeom prst="rect">
+            <a:avLst/>
+          </a:prstGeom>
+          <a:noFill/>
+        </p:spPr>
+        <p:txBody>
+          <a:bodyPr wrap="square" lIns="0" tIns="0" rIns="0" bIns="0">
+            <a:spAutoFit/>
+          </a:bodyPr>
+          <a:lstStyle/>
+          <a:p>
+            <a:pPr>
+              <a:defRPr sz="2200" b="1">
+                <a:solidFill>
+                  <a:srgbClr val="FFFFFF"/>
+                </a:solidFill>
+              </a:defRPr>
+            </a:pPr>
+            <a:r>
+              <a:rPr lang="en-US" dirty="0">
+                <a:solidFill>
+                  <a:schemeClr val="tx1">
+                    <a:lumMod val="95000"/>
+                    <a:lumOff val="5000"/>
+                  </a:schemeClr>
+                </a:solidFill>
+              </a:rPr>
+              <a:t>Server 3 – GABUNGAN (ATK, ABO, ATB)</a:t>
+            </a:r>
+            <a:endParaRPr dirty="0">
+              <a:solidFill>
+                <a:schemeClr val="tx1">
+                  <a:lumMod val="95000"/>
+                  <a:lumOff val="5000"/>
+                </a:schemeClr>
+              </a:solidFill>
+            </a:endParaRPr>
+          </a:p>
+        </p:txBody>
+      </p:sp>
+    </p:spTree>
+    <p:extLst>
+      <p:ext uri="{BB962C8B-B14F-4D97-AF65-F5344CB8AC3E}">
+        <p14:creationId xmlns:p14="http://schemas.microsoft.com/office/powerpoint/2010/main" val="4160778217"/>
+      </p:ext>
+    </p:extLst>
+  </p:cSld>
+  <p:clrMapOvr>
+    <a:masterClrMapping/>
+  </p:clrMapOvr>
+</p:sld>
+</file>
+
+<file path=ppt/slides/slide12.xml><?xml version="1.0" encoding="utf-8"?>
+<p:sld xmlns:a="http://schemas.openxmlformats.org/drawingml/2006/main" xmlns:r="http://schemas.openxmlformats.org/officeDocument/2006/relationships" xmlns:p="http://schemas.openxmlformats.org/presentationml/2006/main">
   <p:cSld>
     <p:spTree>
       <p:nvGrpSpPr>
@@ -3418,7 +3671,365 @@
         <p:cNvGrpSpPr/>
         <p:nvPr/>
       </p:nvGrpSpPr>
-      <p:grpSpPr/>
+      <p:grpSpPr>
+        <a:xfrm>
+          <a:off x="0" y="0"/>
+          <a:ext cx="0" cy="0"/>
+          <a:chOff x="0" y="0"/>
+          <a:chExt cx="0" cy="0"/>
+        </a:xfrm>
+      </p:grpSpPr>
+      <p:pic>
+        <p:nvPicPr>
+          <p:cNvPr id="3" name="Picture 2">
+            <a:extLst>
+              <a:ext uri="{FF2B5EF4-FFF2-40B4-BE49-F238E27FC236}">
+                <a16:creationId xmlns:a16="http://schemas.microsoft.com/office/drawing/2014/main" id="{C72805E2-96E3-F5D2-E0D0-86A7D904F410}"/>
+              </a:ext>
+            </a:extLst>
+          </p:cNvPr>
+          <p:cNvPicPr>
+            <a:picLocks noChangeAspect="1"/>
+          </p:cNvPicPr>
+          <p:nvPr/>
+        </p:nvPicPr>
+        <p:blipFill>
+          <a:blip r:embed="rId2"/>
+          <a:stretch>
+            <a:fillRect/>
+          </a:stretch>
+        </p:blipFill>
+        <p:spPr>
+          <a:xfrm>
+            <a:off x="0" y="613751"/>
+            <a:ext cx="12192000" cy="2268461"/>
+          </a:xfrm>
+          <a:prstGeom prst="rect">
+            <a:avLst/>
+          </a:prstGeom>
+        </p:spPr>
+      </p:pic>
+      <p:sp>
+        <p:nvSpPr>
+          <p:cNvPr id="4" name="TextBox 3">
+            <a:extLst>
+              <a:ext uri="{FF2B5EF4-FFF2-40B4-BE49-F238E27FC236}">
+                <a16:creationId xmlns:a16="http://schemas.microsoft.com/office/drawing/2014/main" id="{5F2F3C4C-DF11-11AB-153C-32EBCC8B6F72}"/>
+              </a:ext>
+            </a:extLst>
+          </p:cNvPr>
+          <p:cNvSpPr txBox="1"/>
+          <p:nvPr/>
+        </p:nvSpPr>
+        <p:spPr>
+          <a:xfrm>
+            <a:off x="149629" y="205312"/>
+            <a:ext cx="10698480" cy="338554"/>
+          </a:xfrm>
+          <a:prstGeom prst="rect">
+            <a:avLst/>
+          </a:prstGeom>
+          <a:noFill/>
+        </p:spPr>
+        <p:txBody>
+          <a:bodyPr wrap="square" lIns="0" tIns="0" rIns="0" bIns="0">
+            <a:spAutoFit/>
+          </a:bodyPr>
+          <a:lstStyle/>
+          <a:p>
+            <a:pPr>
+              <a:defRPr sz="2200" b="1">
+                <a:solidFill>
+                  <a:srgbClr val="FFFFFF"/>
+                </a:solidFill>
+              </a:defRPr>
+            </a:pPr>
+            <a:r>
+              <a:rPr lang="en-US" dirty="0">
+                <a:solidFill>
+                  <a:schemeClr val="tx1">
+                    <a:lumMod val="95000"/>
+                    <a:lumOff val="5000"/>
+                  </a:schemeClr>
+                </a:solidFill>
+              </a:rPr>
+              <a:t>Server 2 – PT ALVA KARYA PERKASA (AKP)</a:t>
+            </a:r>
+            <a:endParaRPr dirty="0">
+              <a:solidFill>
+                <a:schemeClr val="tx1">
+                  <a:lumMod val="95000"/>
+                  <a:lumOff val="5000"/>
+                </a:schemeClr>
+              </a:solidFill>
+            </a:endParaRPr>
+          </a:p>
+        </p:txBody>
+      </p:sp>
+      <p:pic>
+        <p:nvPicPr>
+          <p:cNvPr id="6" name="Picture 5">
+            <a:extLst>
+              <a:ext uri="{FF2B5EF4-FFF2-40B4-BE49-F238E27FC236}">
+                <a16:creationId xmlns:a16="http://schemas.microsoft.com/office/drawing/2014/main" id="{63129055-21BC-3E00-A1F0-50B34C8A9D1A}"/>
+              </a:ext>
+            </a:extLst>
+          </p:cNvPr>
+          <p:cNvPicPr>
+            <a:picLocks noChangeAspect="1"/>
+          </p:cNvPicPr>
+          <p:nvPr/>
+        </p:nvPicPr>
+        <p:blipFill>
+          <a:blip r:embed="rId3"/>
+          <a:stretch>
+            <a:fillRect/>
+          </a:stretch>
+        </p:blipFill>
+        <p:spPr>
+          <a:xfrm>
+            <a:off x="64971" y="3674898"/>
+            <a:ext cx="7868748" cy="2353003"/>
+          </a:xfrm>
+          <a:prstGeom prst="rect">
+            <a:avLst/>
+          </a:prstGeom>
+        </p:spPr>
+      </p:pic>
+      <p:sp>
+        <p:nvSpPr>
+          <p:cNvPr id="7" name="TextBox 6">
+            <a:extLst>
+              <a:ext uri="{FF2B5EF4-FFF2-40B4-BE49-F238E27FC236}">
+                <a16:creationId xmlns:a16="http://schemas.microsoft.com/office/drawing/2014/main" id="{ECE31C85-2FCD-062C-D25B-D1A33ABA12C6}"/>
+              </a:ext>
+            </a:extLst>
+          </p:cNvPr>
+          <p:cNvSpPr txBox="1"/>
+          <p:nvPr/>
+        </p:nvSpPr>
+        <p:spPr>
+          <a:xfrm>
+            <a:off x="74207" y="3336344"/>
+            <a:ext cx="10698480" cy="338554"/>
+          </a:xfrm>
+          <a:prstGeom prst="rect">
+            <a:avLst/>
+          </a:prstGeom>
+          <a:noFill/>
+        </p:spPr>
+        <p:txBody>
+          <a:bodyPr wrap="square" lIns="0" tIns="0" rIns="0" bIns="0">
+            <a:spAutoFit/>
+          </a:bodyPr>
+          <a:lstStyle/>
+          <a:p>
+            <a:pPr>
+              <a:defRPr sz="2200" b="1">
+                <a:solidFill>
+                  <a:srgbClr val="FFFFFF"/>
+                </a:solidFill>
+              </a:defRPr>
+            </a:pPr>
+            <a:r>
+              <a:rPr lang="en-US" dirty="0">
+                <a:solidFill>
+                  <a:schemeClr val="tx1">
+                    <a:lumMod val="95000"/>
+                    <a:lumOff val="5000"/>
+                  </a:schemeClr>
+                </a:solidFill>
+              </a:rPr>
+              <a:t>Server 3 – GABUNGAN (ATK, ABO, ATB)</a:t>
+            </a:r>
+            <a:endParaRPr dirty="0">
+              <a:solidFill>
+                <a:schemeClr val="tx1">
+                  <a:lumMod val="95000"/>
+                  <a:lumOff val="5000"/>
+                </a:schemeClr>
+              </a:solidFill>
+            </a:endParaRPr>
+          </a:p>
+        </p:txBody>
+      </p:sp>
+    </p:spTree>
+    <p:extLst>
+      <p:ext uri="{BB962C8B-B14F-4D97-AF65-F5344CB8AC3E}">
+        <p14:creationId xmlns:p14="http://schemas.microsoft.com/office/powerpoint/2010/main" val="1486709787"/>
+      </p:ext>
+    </p:extLst>
+  </p:cSld>
+  <p:clrMapOvr>
+    <a:masterClrMapping/>
+  </p:clrMapOvr>
+</p:sld>
+</file>
+
+<file path=ppt/slides/slide13.xml><?xml version="1.0" encoding="utf-8"?>
+<p:sld xmlns:a="http://schemas.openxmlformats.org/drawingml/2006/main" xmlns:r="http://schemas.openxmlformats.org/officeDocument/2006/relationships" xmlns:p="http://schemas.openxmlformats.org/presentationml/2006/main">
+  <p:cSld>
+    <p:spTree>
+      <p:nvGrpSpPr>
+        <p:cNvPr id="1" name=""/>
+        <p:cNvGrpSpPr/>
+        <p:nvPr/>
+      </p:nvGrpSpPr>
+      <p:grpSpPr>
+        <a:xfrm>
+          <a:off x="0" y="0"/>
+          <a:ext cx="0" cy="0"/>
+          <a:chOff x="0" y="0"/>
+          <a:chExt cx="0" cy="0"/>
+        </a:xfrm>
+      </p:grpSpPr>
+      <p:pic>
+        <p:nvPicPr>
+          <p:cNvPr id="3" name="Picture 2">
+            <a:extLst>
+              <a:ext uri="{FF2B5EF4-FFF2-40B4-BE49-F238E27FC236}">
+                <a16:creationId xmlns:a16="http://schemas.microsoft.com/office/drawing/2014/main" id="{E3CC8905-2E2B-26E7-D851-3C52B7F3EC6B}"/>
+              </a:ext>
+            </a:extLst>
+          </p:cNvPr>
+          <p:cNvPicPr>
+            <a:picLocks noChangeAspect="1"/>
+          </p:cNvPicPr>
+          <p:nvPr/>
+        </p:nvPicPr>
+        <p:blipFill>
+          <a:blip r:embed="rId2"/>
+          <a:stretch>
+            <a:fillRect/>
+          </a:stretch>
+        </p:blipFill>
+        <p:spPr>
+          <a:xfrm>
+            <a:off x="103823" y="986827"/>
+            <a:ext cx="7440063" cy="2372056"/>
+          </a:xfrm>
+          <a:prstGeom prst="rect">
+            <a:avLst/>
+          </a:prstGeom>
+        </p:spPr>
+      </p:pic>
+      <p:sp>
+        <p:nvSpPr>
+          <p:cNvPr id="4" name="TextBox 3">
+            <a:extLst>
+              <a:ext uri="{FF2B5EF4-FFF2-40B4-BE49-F238E27FC236}">
+                <a16:creationId xmlns:a16="http://schemas.microsoft.com/office/drawing/2014/main" id="{E59DB9D8-423F-7348-B63A-CB5AFF19E383}"/>
+              </a:ext>
+            </a:extLst>
+          </p:cNvPr>
+          <p:cNvSpPr txBox="1"/>
+          <p:nvPr/>
+        </p:nvSpPr>
+        <p:spPr>
+          <a:xfrm>
+            <a:off x="103823" y="543866"/>
+            <a:ext cx="10698480" cy="338554"/>
+          </a:xfrm>
+          <a:prstGeom prst="rect">
+            <a:avLst/>
+          </a:prstGeom>
+          <a:noFill/>
+        </p:spPr>
+        <p:txBody>
+          <a:bodyPr wrap="square" lIns="0" tIns="0" rIns="0" bIns="0">
+            <a:spAutoFit/>
+          </a:bodyPr>
+          <a:lstStyle/>
+          <a:p>
+            <a:pPr>
+              <a:defRPr sz="2200" b="1">
+                <a:solidFill>
+                  <a:srgbClr val="FFFFFF"/>
+                </a:solidFill>
+              </a:defRPr>
+            </a:pPr>
+            <a:r>
+              <a:rPr lang="en-US" dirty="0">
+                <a:solidFill>
+                  <a:schemeClr val="tx1">
+                    <a:lumMod val="95000"/>
+                    <a:lumOff val="5000"/>
+                  </a:schemeClr>
+                </a:solidFill>
+              </a:rPr>
+              <a:t>Server 1 – AMK</a:t>
+            </a:r>
+            <a:endParaRPr dirty="0">
+              <a:solidFill>
+                <a:schemeClr val="tx1">
+                  <a:lumMod val="95000"/>
+                  <a:lumOff val="5000"/>
+                </a:schemeClr>
+              </a:solidFill>
+            </a:endParaRPr>
+          </a:p>
+        </p:txBody>
+      </p:sp>
+      <p:pic>
+        <p:nvPicPr>
+          <p:cNvPr id="6" name="Picture 5">
+            <a:extLst>
+              <a:ext uri="{FF2B5EF4-FFF2-40B4-BE49-F238E27FC236}">
+                <a16:creationId xmlns:a16="http://schemas.microsoft.com/office/drawing/2014/main" id="{C20E3891-8BBC-B6E4-495A-40CDB91BA1F7}"/>
+              </a:ext>
+            </a:extLst>
+          </p:cNvPr>
+          <p:cNvPicPr>
+            <a:picLocks noChangeAspect="1"/>
+          </p:cNvPicPr>
+          <p:nvPr/>
+        </p:nvPicPr>
+        <p:blipFill>
+          <a:blip r:embed="rId3"/>
+          <a:stretch>
+            <a:fillRect/>
+          </a:stretch>
+        </p:blipFill>
+        <p:spPr>
+          <a:xfrm>
+            <a:off x="146898" y="3392675"/>
+            <a:ext cx="5306165" cy="1362265"/>
+          </a:xfrm>
+          <a:prstGeom prst="rect">
+            <a:avLst/>
+          </a:prstGeom>
+        </p:spPr>
+      </p:pic>
+    </p:spTree>
+    <p:extLst>
+      <p:ext uri="{BB962C8B-B14F-4D97-AF65-F5344CB8AC3E}">
+        <p14:creationId xmlns:p14="http://schemas.microsoft.com/office/powerpoint/2010/main" val="255776576"/>
+      </p:ext>
+    </p:extLst>
+  </p:cSld>
+  <p:clrMapOvr>
+    <a:masterClrMapping/>
+  </p:clrMapOvr>
+</p:sld>
+</file>
+
+<file path=ppt/slides/slide2.xml><?xml version="1.0" encoding="utf-8"?>
+<p:sld xmlns:a="http://schemas.openxmlformats.org/drawingml/2006/main" xmlns:r="http://schemas.openxmlformats.org/officeDocument/2006/relationships" xmlns:p="http://schemas.openxmlformats.org/presentationml/2006/main">
+  <p:cSld>
+    <p:spTree>
+      <p:nvGrpSpPr>
+        <p:cNvPr id="1" name=""/>
+        <p:cNvGrpSpPr/>
+        <p:nvPr/>
+      </p:nvGrpSpPr>
+      <p:grpSpPr>
+        <a:xfrm>
+          <a:off x="0" y="0"/>
+          <a:ext cx="0" cy="0"/>
+          <a:chOff x="0" y="0"/>
+          <a:chExt cx="0" cy="0"/>
+        </a:xfrm>
+      </p:grpSpPr>
       <p:sp>
         <p:nvSpPr>
           <p:cNvPr id="2" name="Rectangle 1"/>
@@ -3459,6 +4070,7 @@
           <a:lstStyle/>
           <a:p>
             <a:pPr algn="ctr"/>
+            <a:endParaRPr/>
           </a:p>
         </p:txBody>
       </p:sp>
@@ -3605,7 +4217,7 @@
           </a:fontRef>
         </p:style>
         <p:txBody>
-          <a:bodyPr rtlCol="0" anchor="ctr" wrap="square" lIns="228600" tIns="228600" rIns="228600"/>
+          <a:bodyPr wrap="square" lIns="228600" tIns="228600" rIns="228600" rtlCol="0" anchor="ctr"/>
           <a:lstStyle/>
           <a:p>
             <a:pPr algn="ctr">
@@ -3720,7 +4332,7 @@
           </a:fontRef>
         </p:style>
         <p:txBody>
-          <a:bodyPr rtlCol="0" anchor="ctr" wrap="square" lIns="228600" tIns="228600" rIns="228600"/>
+          <a:bodyPr wrap="square" lIns="228600" tIns="228600" rIns="228600" rtlCol="0" anchor="ctr"/>
           <a:lstStyle/>
           <a:p>
             <a:pPr algn="ctr">
@@ -3835,7 +4447,7 @@
           </a:fontRef>
         </p:style>
         <p:txBody>
-          <a:bodyPr rtlCol="0" anchor="ctr" wrap="square" lIns="228600" tIns="228600" rIns="228600"/>
+          <a:bodyPr wrap="square" lIns="228600" tIns="228600" rIns="228600" rtlCol="0" anchor="ctr"/>
           <a:lstStyle/>
           <a:p>
             <a:pPr algn="ctr">
@@ -3950,7 +4562,7 @@
           </a:fontRef>
         </p:style>
         <p:txBody>
-          <a:bodyPr rtlCol="0" anchor="ctr" wrap="square" lIns="274320" tIns="137160"/>
+          <a:bodyPr wrap="square" lIns="274320" tIns="137160" rtlCol="0" anchor="ctr"/>
           <a:lstStyle/>
           <a:p>
             <a:pPr algn="ctr">
@@ -4005,7 +4617,7 @@
 </file>
 
 <file path=ppt/slides/slide3.xml><?xml version="1.0" encoding="utf-8"?>
-<p:sld xmlns:a="http://schemas.openxmlformats.org/drawingml/2006/main" xmlns:p="http://schemas.openxmlformats.org/presentationml/2006/main" xmlns:r="http://schemas.openxmlformats.org/officeDocument/2006/relationships">
+<p:sld xmlns:a="http://schemas.openxmlformats.org/drawingml/2006/main" xmlns:r="http://schemas.openxmlformats.org/officeDocument/2006/relationships" xmlns:p="http://schemas.openxmlformats.org/presentationml/2006/main">
   <p:cSld>
     <p:spTree>
       <p:nvGrpSpPr>
@@ -4013,7 +4625,14 @@
         <p:cNvGrpSpPr/>
         <p:nvPr/>
       </p:nvGrpSpPr>
-      <p:grpSpPr/>
+      <p:grpSpPr>
+        <a:xfrm>
+          <a:off x="0" y="0"/>
+          <a:ext cx="0" cy="0"/>
+          <a:chOff x="0" y="0"/>
+          <a:chExt cx="0" cy="0"/>
+        </a:xfrm>
+      </p:grpSpPr>
       <p:sp>
         <p:nvSpPr>
           <p:cNvPr id="2" name="Rectangle 1"/>
@@ -4054,6 +4673,7 @@
           <a:lstStyle/>
           <a:p>
             <a:pPr algn="ctr"/>
+            <a:endParaRPr/>
           </a:p>
         </p:txBody>
       </p:sp>
@@ -4200,7 +4820,7 @@
           </a:fontRef>
         </p:style>
         <p:txBody>
-          <a:bodyPr rtlCol="0" anchor="ctr" wrap="square" lIns="274320" tIns="164592"/>
+          <a:bodyPr wrap="square" lIns="274320" tIns="164592" rtlCol="0" anchor="ctr"/>
           <a:lstStyle/>
           <a:p>
             <a:pPr algn="ctr">
@@ -4269,7 +4889,7 @@
           </a:fontRef>
         </p:style>
         <p:txBody>
-          <a:bodyPr rtlCol="0" anchor="ctr" wrap="square" lIns="274320" tIns="164592"/>
+          <a:bodyPr wrap="square" lIns="274320" tIns="164592" rtlCol="0" anchor="ctr"/>
           <a:lstStyle/>
           <a:p>
             <a:pPr algn="ctr">
@@ -4338,7 +4958,7 @@
           </a:fontRef>
         </p:style>
         <p:txBody>
-          <a:bodyPr rtlCol="0" anchor="ctr" wrap="square" lIns="274320" tIns="164592"/>
+          <a:bodyPr wrap="square" lIns="274320" tIns="164592" rtlCol="0" anchor="ctr"/>
           <a:lstStyle/>
           <a:p>
             <a:pPr algn="ctr">
@@ -4407,7 +5027,7 @@
           </a:fontRef>
         </p:style>
         <p:txBody>
-          <a:bodyPr rtlCol="0" anchor="ctr" wrap="square" lIns="274320" tIns="164592"/>
+          <a:bodyPr wrap="square" lIns="274320" tIns="164592" rtlCol="0" anchor="ctr"/>
           <a:lstStyle/>
           <a:p>
             <a:pPr algn="ctr">
@@ -4447,7 +5067,7 @@
 </file>
 
 <file path=ppt/slides/slide4.xml><?xml version="1.0" encoding="utf-8"?>
-<p:sld xmlns:a="http://schemas.openxmlformats.org/drawingml/2006/main" xmlns:p="http://schemas.openxmlformats.org/presentationml/2006/main" xmlns:r="http://schemas.openxmlformats.org/officeDocument/2006/relationships">
+<p:sld xmlns:a="http://schemas.openxmlformats.org/drawingml/2006/main" xmlns:r="http://schemas.openxmlformats.org/officeDocument/2006/relationships" xmlns:p="http://schemas.openxmlformats.org/presentationml/2006/main">
   <p:cSld>
     <p:spTree>
       <p:nvGrpSpPr>
@@ -4455,7 +5075,14 @@
         <p:cNvGrpSpPr/>
         <p:nvPr/>
       </p:nvGrpSpPr>
-      <p:grpSpPr/>
+      <p:grpSpPr>
+        <a:xfrm>
+          <a:off x="0" y="0"/>
+          <a:ext cx="0" cy="0"/>
+          <a:chOff x="0" y="0"/>
+          <a:chExt cx="0" cy="0"/>
+        </a:xfrm>
+      </p:grpSpPr>
       <p:sp>
         <p:nvSpPr>
           <p:cNvPr id="2" name="Rectangle 1"/>
@@ -4496,6 +5123,7 @@
           <a:lstStyle/>
           <a:p>
             <a:pPr algn="ctr"/>
+            <a:endParaRPr/>
           </a:p>
         </p:txBody>
       </p:sp>
@@ -4642,7 +5270,7 @@
           </a:fontRef>
         </p:style>
         <p:txBody>
-          <a:bodyPr rtlCol="0" anchor="ctr" wrap="square" lIns="228600" tIns="109728"/>
+          <a:bodyPr wrap="square" lIns="228600" tIns="109728" rtlCol="0" anchor="ctr"/>
           <a:lstStyle/>
           <a:p>
             <a:pPr algn="ctr">
@@ -4711,7 +5339,7 @@
           </a:fontRef>
         </p:style>
         <p:txBody>
-          <a:bodyPr rtlCol="0" anchor="ctr" wrap="square" lIns="228600" tIns="109728"/>
+          <a:bodyPr wrap="square" lIns="228600" tIns="109728" rtlCol="0" anchor="ctr"/>
           <a:lstStyle/>
           <a:p>
             <a:pPr algn="ctr">
@@ -4780,7 +5408,7 @@
           </a:fontRef>
         </p:style>
         <p:txBody>
-          <a:bodyPr rtlCol="0" anchor="ctr" wrap="square" lIns="228600" tIns="109728"/>
+          <a:bodyPr wrap="square" lIns="228600" tIns="109728" rtlCol="0" anchor="ctr"/>
           <a:lstStyle/>
           <a:p>
             <a:pPr algn="ctr">
@@ -4849,7 +5477,7 @@
           </a:fontRef>
         </p:style>
         <p:txBody>
-          <a:bodyPr rtlCol="0" anchor="ctr" wrap="square" lIns="228600" tIns="109728"/>
+          <a:bodyPr wrap="square" lIns="228600" tIns="109728" rtlCol="0" anchor="ctr"/>
           <a:lstStyle/>
           <a:p>
             <a:pPr algn="ctr">
@@ -4918,7 +5546,7 @@
           </a:fontRef>
         </p:style>
         <p:txBody>
-          <a:bodyPr rtlCol="0" anchor="ctr" wrap="square" lIns="228600" tIns="109728"/>
+          <a:bodyPr wrap="square" lIns="228600" tIns="109728" rtlCol="0" anchor="ctr"/>
           <a:lstStyle/>
           <a:p>
             <a:pPr algn="ctr">
@@ -4958,7 +5586,7 @@
 </file>
 
 <file path=ppt/slides/slide5.xml><?xml version="1.0" encoding="utf-8"?>
-<p:sld xmlns:a="http://schemas.openxmlformats.org/drawingml/2006/main" xmlns:p="http://schemas.openxmlformats.org/presentationml/2006/main" xmlns:r="http://schemas.openxmlformats.org/officeDocument/2006/relationships">
+<p:sld xmlns:a="http://schemas.openxmlformats.org/drawingml/2006/main" xmlns:r="http://schemas.openxmlformats.org/officeDocument/2006/relationships" xmlns:p="http://schemas.openxmlformats.org/presentationml/2006/main">
   <p:cSld>
     <p:spTree>
       <p:nvGrpSpPr>
@@ -4966,7 +5594,14 @@
         <p:cNvGrpSpPr/>
         <p:nvPr/>
       </p:nvGrpSpPr>
-      <p:grpSpPr/>
+      <p:grpSpPr>
+        <a:xfrm>
+          <a:off x="0" y="0"/>
+          <a:ext cx="0" cy="0"/>
+          <a:chOff x="0" y="0"/>
+          <a:chExt cx="0" cy="0"/>
+        </a:xfrm>
+      </p:grpSpPr>
       <p:sp>
         <p:nvSpPr>
           <p:cNvPr id="2" name="Rectangle 1"/>
@@ -5007,6 +5642,7 @@
           <a:lstStyle/>
           <a:p>
             <a:pPr algn="ctr"/>
+            <a:endParaRPr/>
           </a:p>
         </p:txBody>
       </p:sp>
@@ -5153,7 +5789,7 @@
           </a:fontRef>
         </p:style>
         <p:txBody>
-          <a:bodyPr rtlCol="0" anchor="ctr" wrap="square" lIns="274320" tIns="228600" rIns="274320"/>
+          <a:bodyPr wrap="square" lIns="274320" tIns="228600" rIns="274320" rtlCol="0" anchor="ctr"/>
           <a:lstStyle/>
           <a:p>
             <a:pPr algn="ctr">
@@ -5327,7 +5963,7 @@
           </a:fontRef>
         </p:style>
         <p:txBody>
-          <a:bodyPr rtlCol="0" anchor="ctr" wrap="square" lIns="228600" tIns="228600" rIns="228600"/>
+          <a:bodyPr wrap="square" lIns="228600" tIns="228600" rIns="228600" rtlCol="0" anchor="ctr"/>
           <a:lstStyle/>
           <a:p>
             <a:pPr algn="ctr">
@@ -5435,7 +6071,7 @@
 </file>
 
 <file path=ppt/slides/slide6.xml><?xml version="1.0" encoding="utf-8"?>
-<p:sld xmlns:a="http://schemas.openxmlformats.org/drawingml/2006/main" xmlns:p="http://schemas.openxmlformats.org/presentationml/2006/main" xmlns:r="http://schemas.openxmlformats.org/officeDocument/2006/relationships">
+<p:sld xmlns:a="http://schemas.openxmlformats.org/drawingml/2006/main" xmlns:r="http://schemas.openxmlformats.org/officeDocument/2006/relationships" xmlns:p="http://schemas.openxmlformats.org/presentationml/2006/main">
   <p:cSld>
     <p:spTree>
       <p:nvGrpSpPr>
@@ -5443,7 +6079,14 @@
         <p:cNvGrpSpPr/>
         <p:nvPr/>
       </p:nvGrpSpPr>
-      <p:grpSpPr/>
+      <p:grpSpPr>
+        <a:xfrm>
+          <a:off x="0" y="0"/>
+          <a:ext cx="0" cy="0"/>
+          <a:chOff x="0" y="0"/>
+          <a:chExt cx="0" cy="0"/>
+        </a:xfrm>
+      </p:grpSpPr>
       <p:sp>
         <p:nvSpPr>
           <p:cNvPr id="2" name="Rectangle 1"/>
@@ -5484,6 +6127,7 @@
           <a:lstStyle/>
           <a:p>
             <a:pPr algn="ctr"/>
+            <a:endParaRPr/>
           </a:p>
         </p:txBody>
       </p:sp>
@@ -5630,7 +6274,7 @@
           </a:fontRef>
         </p:style>
         <p:txBody>
-          <a:bodyPr rtlCol="0" anchor="ctr" wrap="square" lIns="274320" tIns="228600" rIns="274320"/>
+          <a:bodyPr wrap="square" lIns="274320" tIns="228600" rIns="274320" rtlCol="0" anchor="ctr"/>
           <a:lstStyle/>
           <a:p>
             <a:pPr algn="ctr">
@@ -5699,7 +6343,7 @@
           </a:fontRef>
         </p:style>
         <p:txBody>
-          <a:bodyPr rtlCol="0" anchor="ctr" wrap="square" lIns="274320" tIns="228600" rIns="274320"/>
+          <a:bodyPr wrap="square" lIns="274320" tIns="228600" rIns="274320" rtlCol="0" anchor="ctr"/>
           <a:lstStyle/>
           <a:p>
             <a:pPr algn="ctr">
@@ -5768,7 +6412,7 @@
           </a:fontRef>
         </p:style>
         <p:txBody>
-          <a:bodyPr rtlCol="0" anchor="ctr" wrap="square" lIns="274320" tIns="228600" rIns="274320"/>
+          <a:bodyPr wrap="square" lIns="274320" tIns="228600" rIns="274320" rtlCol="0" anchor="ctr"/>
           <a:lstStyle/>
           <a:p>
             <a:pPr algn="ctr">
@@ -5837,7 +6481,7 @@
           </a:fontRef>
         </p:style>
         <p:txBody>
-          <a:bodyPr rtlCol="0" anchor="ctr" wrap="square" lIns="274320" tIns="228600" rIns="274320"/>
+          <a:bodyPr wrap="square" lIns="274320" tIns="228600" rIns="274320" rtlCol="0" anchor="ctr"/>
           <a:lstStyle/>
           <a:p>
             <a:pPr algn="ctr">
@@ -5877,7 +6521,7 @@
 </file>
 
 <file path=ppt/slides/slide7.xml><?xml version="1.0" encoding="utf-8"?>
-<p:sld xmlns:a="http://schemas.openxmlformats.org/drawingml/2006/main" xmlns:p="http://schemas.openxmlformats.org/presentationml/2006/main" xmlns:r="http://schemas.openxmlformats.org/officeDocument/2006/relationships">
+<p:sld xmlns:a="http://schemas.openxmlformats.org/drawingml/2006/main" xmlns:r="http://schemas.openxmlformats.org/officeDocument/2006/relationships" xmlns:p="http://schemas.openxmlformats.org/presentationml/2006/main">
   <p:cSld>
     <p:spTree>
       <p:nvGrpSpPr>
@@ -5885,7 +6529,14 @@
         <p:cNvGrpSpPr/>
         <p:nvPr/>
       </p:nvGrpSpPr>
-      <p:grpSpPr/>
+      <p:grpSpPr>
+        <a:xfrm>
+          <a:off x="0" y="0"/>
+          <a:ext cx="0" cy="0"/>
+          <a:chOff x="0" y="0"/>
+          <a:chExt cx="0" cy="0"/>
+        </a:xfrm>
+      </p:grpSpPr>
       <p:sp>
         <p:nvSpPr>
           <p:cNvPr id="2" name="Rectangle 1"/>
@@ -5926,6 +6577,7 @@
           <a:lstStyle/>
           <a:p>
             <a:pPr algn="ctr"/>
+            <a:endParaRPr/>
           </a:p>
         </p:txBody>
       </p:sp>
@@ -6072,7 +6724,7 @@
           </a:fontRef>
         </p:style>
         <p:txBody>
-          <a:bodyPr rtlCol="0" anchor="ctr" wrap="square" lIns="274320" tIns="228600" rIns="274320"/>
+          <a:bodyPr wrap="square" lIns="274320" tIns="228600" rIns="274320" rtlCol="0" anchor="ctr"/>
           <a:lstStyle/>
           <a:p>
             <a:pPr algn="ctr">
@@ -6246,7 +6898,7 @@
           </a:fontRef>
         </p:style>
         <p:txBody>
-          <a:bodyPr rtlCol="0" anchor="ctr" wrap="square" lIns="274320" tIns="228600" rIns="274320"/>
+          <a:bodyPr wrap="square" lIns="274320" tIns="228600" rIns="274320" rtlCol="0" anchor="ctr"/>
           <a:lstStyle/>
           <a:p>
             <a:pPr algn="ctr">
@@ -6433,7 +7085,7 @@
 </file>
 
 <file path=ppt/slides/slide8.xml><?xml version="1.0" encoding="utf-8"?>
-<p:sld xmlns:a="http://schemas.openxmlformats.org/drawingml/2006/main" xmlns:p="http://schemas.openxmlformats.org/presentationml/2006/main" xmlns:r="http://schemas.openxmlformats.org/officeDocument/2006/relationships">
+<p:sld xmlns:a="http://schemas.openxmlformats.org/drawingml/2006/main" xmlns:r="http://schemas.openxmlformats.org/officeDocument/2006/relationships" xmlns:p="http://schemas.openxmlformats.org/presentationml/2006/main">
   <p:cSld>
     <p:spTree>
       <p:nvGrpSpPr>
@@ -6441,7 +7093,14 @@
         <p:cNvGrpSpPr/>
         <p:nvPr/>
       </p:nvGrpSpPr>
-      <p:grpSpPr/>
+      <p:grpSpPr>
+        <a:xfrm>
+          <a:off x="0" y="0"/>
+          <a:ext cx="0" cy="0"/>
+          <a:chOff x="0" y="0"/>
+          <a:chExt cx="0" cy="0"/>
+        </a:xfrm>
+      </p:grpSpPr>
       <p:sp>
         <p:nvSpPr>
           <p:cNvPr id="2" name="Rectangle 1"/>
@@ -6482,6 +7141,7 @@
           <a:lstStyle/>
           <a:p>
             <a:pPr algn="ctr"/>
+            <a:endParaRPr/>
           </a:p>
         </p:txBody>
       </p:sp>
@@ -6550,7 +7210,24 @@
               </a:defRPr>
             </a:pPr>
             <a:r>
-              <a:t>Rangkuman Eksekutif &amp; Rencana Tindak Lanjut</a:t>
+              <a:rPr dirty="0"/>
+              <a:t>Rangkuman </a:t>
+            </a:r>
+            <a:r>
+              <a:rPr dirty="0" err="1"/>
+              <a:t>Eksekutif</a:t>
+            </a:r>
+            <a:r>
+              <a:rPr dirty="0"/>
+              <a:t> &amp; Rencana </a:t>
+            </a:r>
+            <a:r>
+              <a:rPr dirty="0" err="1"/>
+              <a:t>Tindak</a:t>
+            </a:r>
+            <a:r>
+              <a:rPr dirty="0"/>
+              <a:t> Lanjut</a:t>
             </a:r>
           </a:p>
         </p:txBody>
@@ -6628,7 +7305,7 @@
           </a:fontRef>
         </p:style>
         <p:txBody>
-          <a:bodyPr rtlCol="0" anchor="ctr" wrap="square" lIns="274320" tIns="228600" rIns="274320"/>
+          <a:bodyPr wrap="square" lIns="274320" tIns="228600" rIns="274320" rtlCol="0" anchor="ctr"/>
           <a:lstStyle/>
           <a:p>
             <a:pPr algn="ctr">
@@ -6697,7 +7374,7 @@
           </a:fontRef>
         </p:style>
         <p:txBody>
-          <a:bodyPr rtlCol="0" anchor="ctr" wrap="square" lIns="274320" tIns="228600" rIns="274320"/>
+          <a:bodyPr wrap="square" lIns="274320" tIns="228600" rIns="274320" rtlCol="0" anchor="ctr"/>
           <a:lstStyle/>
           <a:p>
             <a:pPr algn="ctr">
@@ -6766,7 +7443,7 @@
           </a:fontRef>
         </p:style>
         <p:txBody>
-          <a:bodyPr rtlCol="0" anchor="ctr" wrap="square" lIns="274320" tIns="228600" rIns="274320"/>
+          <a:bodyPr wrap="square" lIns="274320" tIns="228600" rIns="274320" rtlCol="0" anchor="ctr"/>
           <a:lstStyle/>
           <a:p>
             <a:pPr algn="ctr">
@@ -6835,7 +7512,7 @@
           </a:fontRef>
         </p:style>
         <p:txBody>
-          <a:bodyPr rtlCol="0" anchor="ctr" wrap="square" lIns="274320" tIns="228600" rIns="274320"/>
+          <a:bodyPr wrap="square" lIns="274320" tIns="228600" rIns="274320" rtlCol="0" anchor="ctr"/>
           <a:lstStyle/>
           <a:p>
             <a:pPr algn="ctr">
@@ -6867,6 +7544,123 @@
         </p:txBody>
       </p:sp>
     </p:spTree>
+  </p:cSld>
+  <p:clrMapOvr>
+    <a:masterClrMapping/>
+  </p:clrMapOvr>
+</p:sld>
+</file>
+
+<file path=ppt/slides/slide9.xml><?xml version="1.0" encoding="utf-8"?>
+<p:sld xmlns:a="http://schemas.openxmlformats.org/drawingml/2006/main" xmlns:r="http://schemas.openxmlformats.org/officeDocument/2006/relationships" xmlns:p="http://schemas.openxmlformats.org/presentationml/2006/main">
+  <p:cSld>
+    <p:spTree>
+      <p:nvGrpSpPr>
+        <p:cNvPr id="1" name=""/>
+        <p:cNvGrpSpPr/>
+        <p:nvPr/>
+      </p:nvGrpSpPr>
+      <p:grpSpPr>
+        <a:xfrm>
+          <a:off x="0" y="0"/>
+          <a:ext cx="0" cy="0"/>
+          <a:chOff x="0" y="0"/>
+          <a:chExt cx="0" cy="0"/>
+        </a:xfrm>
+      </p:grpSpPr>
+      <p:pic>
+        <p:nvPicPr>
+          <p:cNvPr id="3" name="Picture 2">
+            <a:extLst>
+              <a:ext uri="{FF2B5EF4-FFF2-40B4-BE49-F238E27FC236}">
+                <a16:creationId xmlns:a16="http://schemas.microsoft.com/office/drawing/2014/main" id="{D8580DDC-B6F6-E4EF-6FE4-2F5E26CF450A}"/>
+              </a:ext>
+            </a:extLst>
+          </p:cNvPr>
+          <p:cNvPicPr>
+            <a:picLocks noChangeAspect="1"/>
+          </p:cNvPicPr>
+          <p:nvPr/>
+        </p:nvPicPr>
+        <p:blipFill>
+          <a:blip r:embed="rId2"/>
+          <a:stretch>
+            <a:fillRect/>
+          </a:stretch>
+        </p:blipFill>
+        <p:spPr>
+          <a:xfrm>
+            <a:off x="3139797" y="662805"/>
+            <a:ext cx="5893367" cy="5912296"/>
+          </a:xfrm>
+          <a:prstGeom prst="rect">
+            <a:avLst/>
+          </a:prstGeom>
+        </p:spPr>
+      </p:pic>
+      <p:sp>
+        <p:nvSpPr>
+          <p:cNvPr id="4" name="TextBox 3">
+            <a:extLst>
+              <a:ext uri="{FF2B5EF4-FFF2-40B4-BE49-F238E27FC236}">
+                <a16:creationId xmlns:a16="http://schemas.microsoft.com/office/drawing/2014/main" id="{55CCDE8E-B0EA-39DF-6506-B0FAD4CB3D1B}"/>
+              </a:ext>
+            </a:extLst>
+          </p:cNvPr>
+          <p:cNvSpPr txBox="1"/>
+          <p:nvPr/>
+        </p:nvSpPr>
+        <p:spPr>
+          <a:xfrm>
+            <a:off x="371302" y="279203"/>
+            <a:ext cx="10698480" cy="338554"/>
+          </a:xfrm>
+          <a:prstGeom prst="rect">
+            <a:avLst/>
+          </a:prstGeom>
+          <a:noFill/>
+        </p:spPr>
+        <p:txBody>
+          <a:bodyPr wrap="square" lIns="0" tIns="0" rIns="0" bIns="0">
+            <a:spAutoFit/>
+          </a:bodyPr>
+          <a:lstStyle/>
+          <a:p>
+            <a:pPr>
+              <a:defRPr sz="2200" b="1">
+                <a:solidFill>
+                  <a:srgbClr val="FFFFFF"/>
+                </a:solidFill>
+              </a:defRPr>
+            </a:pPr>
+            <a:r>
+              <a:rPr lang="en-US" dirty="0">
+                <a:solidFill>
+                  <a:schemeClr val="tx1">
+                    <a:lumMod val="95000"/>
+                    <a:lumOff val="5000"/>
+                  </a:schemeClr>
+                </a:solidFill>
+              </a:rPr>
+              <a:t>Server 1 – PT ARINA MULTI KARYA (AMK)</a:t>
+            </a:r>
+            <a:endParaRPr dirty="0">
+              <a:solidFill>
+                <a:schemeClr val="tx1">
+                  <a:lumMod val="95000"/>
+                  <a:lumOff val="5000"/>
+                </a:schemeClr>
+              </a:solidFill>
+            </a:endParaRPr>
+          </a:p>
+        </p:txBody>
+      </p:sp>
+    </p:spTree>
+    <p:extLst>
+      <p:ext uri="{BB962C8B-B14F-4D97-AF65-F5344CB8AC3E}">
+        <p14:creationId xmlns:p14="http://schemas.microsoft.com/office/powerpoint/2010/main" val="264822662"/>
+      </p:ext>
+    </p:extLst>
   </p:cSld>
   <p:clrMapOvr>
     <a:masterClrMapping/>

</xml_diff>

<commit_message>
feat: add 2026 Dulux Offtake dataset (439k rows) and support --year in importer & deployers
</commit_message>
<xml_diff>
--- a/Panduan_Arsitektur_dan_Setting_Production_3_Server_ESA.pptx
+++ b/Panduan_Arsitektur_dan_Setting_Production_3_Server_ESA.pptx
@@ -4,6 +4,9 @@
   <p:sldMasterIdLst>
     <p:sldMasterId id="2147483648" r:id="rId1"/>
   </p:sldMasterIdLst>
+  <p:notesMasterIdLst>
+    <p:notesMasterId r:id="rId18"/>
+  </p:notesMasterIdLst>
   <p:sldIdLst>
     <p:sldId id="256" r:id="rId2"/>
     <p:sldId id="257" r:id="rId3"/>
@@ -18,6 +21,9 @@
     <p:sldId id="266" r:id="rId12"/>
     <p:sldId id="267" r:id="rId13"/>
     <p:sldId id="268" r:id="rId14"/>
+    <p:sldId id="269" r:id="rId15"/>
+    <p:sldId id="270" r:id="rId16"/>
+    <p:sldId id="271" r:id="rId17"/>
   </p:sldIdLst>
   <p:sldSz cx="12192000" cy="6858000"/>
   <p:notesSz cx="6858000" cy="9144000"/>
@@ -133,6 +139,548 @@
     </p:ext>
   </p:extLst>
 </p:presentation>
+</file>
+
+<file path=ppt/notesMasters/notesMaster1.xml><?xml version="1.0" encoding="utf-8"?>
+<p:notesMaster xmlns:a="http://schemas.openxmlformats.org/drawingml/2006/main" xmlns:r="http://schemas.openxmlformats.org/officeDocument/2006/relationships" xmlns:p="http://schemas.openxmlformats.org/presentationml/2006/main">
+  <p:cSld>
+    <p:bg>
+      <p:bgRef idx="1001">
+        <a:schemeClr val="bg1"/>
+      </p:bgRef>
+    </p:bg>
+    <p:spTree>
+      <p:nvGrpSpPr>
+        <p:cNvPr id="1" name=""/>
+        <p:cNvGrpSpPr/>
+        <p:nvPr/>
+      </p:nvGrpSpPr>
+      <p:grpSpPr>
+        <a:xfrm>
+          <a:off x="0" y="0"/>
+          <a:ext cx="0" cy="0"/>
+          <a:chOff x="0" y="0"/>
+          <a:chExt cx="0" cy="0"/>
+        </a:xfrm>
+      </p:grpSpPr>
+      <p:sp>
+        <p:nvSpPr>
+          <p:cNvPr id="2" name="Header Placeholder 1"/>
+          <p:cNvSpPr>
+            <a:spLocks noGrp="1"/>
+          </p:cNvSpPr>
+          <p:nvPr>
+            <p:ph type="hdr" sz="quarter"/>
+          </p:nvPr>
+        </p:nvSpPr>
+        <p:spPr>
+          <a:xfrm>
+            <a:off x="0" y="0"/>
+            <a:ext cx="2971800" cy="458788"/>
+          </a:xfrm>
+          <a:prstGeom prst="rect">
+            <a:avLst/>
+          </a:prstGeom>
+        </p:spPr>
+        <p:txBody>
+          <a:bodyPr vert="horz" lIns="91440" tIns="45720" rIns="91440" bIns="45720" rtlCol="0"/>
+          <a:lstStyle>
+            <a:lvl1pPr algn="l">
+              <a:defRPr sz="1200"/>
+            </a:lvl1pPr>
+          </a:lstStyle>
+          <a:p>
+            <a:endParaRPr lang="id-ID"/>
+          </a:p>
+        </p:txBody>
+      </p:sp>
+      <p:sp>
+        <p:nvSpPr>
+          <p:cNvPr id="3" name="Date Placeholder 2"/>
+          <p:cNvSpPr>
+            <a:spLocks noGrp="1"/>
+          </p:cNvSpPr>
+          <p:nvPr>
+            <p:ph type="dt" idx="1"/>
+          </p:nvPr>
+        </p:nvSpPr>
+        <p:spPr>
+          <a:xfrm>
+            <a:off x="3884613" y="0"/>
+            <a:ext cx="2971800" cy="458788"/>
+          </a:xfrm>
+          <a:prstGeom prst="rect">
+            <a:avLst/>
+          </a:prstGeom>
+        </p:spPr>
+        <p:txBody>
+          <a:bodyPr vert="horz" lIns="91440" tIns="45720" rIns="91440" bIns="45720" rtlCol="0"/>
+          <a:lstStyle>
+            <a:lvl1pPr algn="r">
+              <a:defRPr sz="1200"/>
+            </a:lvl1pPr>
+          </a:lstStyle>
+          <a:p>
+            <a:fld id="{D487E582-DAB4-403B-92F8-E877117794FA}" type="datetimeFigureOut">
+              <a:rPr lang="id-ID" smtClean="0"/>
+              <a:t>02/09/2026</a:t>
+            </a:fld>
+            <a:endParaRPr lang="id-ID"/>
+          </a:p>
+        </p:txBody>
+      </p:sp>
+      <p:sp>
+        <p:nvSpPr>
+          <p:cNvPr id="4" name="Slide Image Placeholder 3"/>
+          <p:cNvSpPr>
+            <a:spLocks noGrp="1" noRot="1" noChangeAspect="1"/>
+          </p:cNvSpPr>
+          <p:nvPr>
+            <p:ph type="sldImg" idx="2"/>
+          </p:nvPr>
+        </p:nvSpPr>
+        <p:spPr>
+          <a:xfrm>
+            <a:off x="685800" y="1143000"/>
+            <a:ext cx="5486400" cy="3086100"/>
+          </a:xfrm>
+          <a:prstGeom prst="rect">
+            <a:avLst/>
+          </a:prstGeom>
+          <a:noFill/>
+          <a:ln w="12700">
+            <a:solidFill>
+              <a:prstClr val="black"/>
+            </a:solidFill>
+          </a:ln>
+        </p:spPr>
+        <p:txBody>
+          <a:bodyPr vert="horz" lIns="91440" tIns="45720" rIns="91440" bIns="45720" rtlCol="0" anchor="ctr"/>
+          <a:lstStyle/>
+          <a:p>
+            <a:endParaRPr lang="id-ID"/>
+          </a:p>
+        </p:txBody>
+      </p:sp>
+      <p:sp>
+        <p:nvSpPr>
+          <p:cNvPr id="5" name="Notes Placeholder 4"/>
+          <p:cNvSpPr>
+            <a:spLocks noGrp="1"/>
+          </p:cNvSpPr>
+          <p:nvPr>
+            <p:ph type="body" sz="quarter" idx="3"/>
+          </p:nvPr>
+        </p:nvSpPr>
+        <p:spPr>
+          <a:xfrm>
+            <a:off x="685800" y="4400550"/>
+            <a:ext cx="5486400" cy="3600450"/>
+          </a:xfrm>
+          <a:prstGeom prst="rect">
+            <a:avLst/>
+          </a:prstGeom>
+        </p:spPr>
+        <p:txBody>
+          <a:bodyPr vert="horz" lIns="91440" tIns="45720" rIns="91440" bIns="45720" rtlCol="0"/>
+          <a:lstStyle/>
+          <a:p>
+            <a:pPr lvl="0"/>
+            <a:r>
+              <a:rPr lang="en-US"/>
+              <a:t>Click to edit Master text styles</a:t>
+            </a:r>
+          </a:p>
+          <a:p>
+            <a:pPr lvl="1"/>
+            <a:r>
+              <a:rPr lang="en-US"/>
+              <a:t>Second level</a:t>
+            </a:r>
+          </a:p>
+          <a:p>
+            <a:pPr lvl="2"/>
+            <a:r>
+              <a:rPr lang="en-US"/>
+              <a:t>Third level</a:t>
+            </a:r>
+          </a:p>
+          <a:p>
+            <a:pPr lvl="3"/>
+            <a:r>
+              <a:rPr lang="en-US"/>
+              <a:t>Fourth level</a:t>
+            </a:r>
+          </a:p>
+          <a:p>
+            <a:pPr lvl="4"/>
+            <a:r>
+              <a:rPr lang="en-US"/>
+              <a:t>Fifth level</a:t>
+            </a:r>
+            <a:endParaRPr lang="id-ID"/>
+          </a:p>
+        </p:txBody>
+      </p:sp>
+      <p:sp>
+        <p:nvSpPr>
+          <p:cNvPr id="6" name="Footer Placeholder 5"/>
+          <p:cNvSpPr>
+            <a:spLocks noGrp="1"/>
+          </p:cNvSpPr>
+          <p:nvPr>
+            <p:ph type="ftr" sz="quarter" idx="4"/>
+          </p:nvPr>
+        </p:nvSpPr>
+        <p:spPr>
+          <a:xfrm>
+            <a:off x="0" y="8685213"/>
+            <a:ext cx="2971800" cy="458787"/>
+          </a:xfrm>
+          <a:prstGeom prst="rect">
+            <a:avLst/>
+          </a:prstGeom>
+        </p:spPr>
+        <p:txBody>
+          <a:bodyPr vert="horz" lIns="91440" tIns="45720" rIns="91440" bIns="45720" rtlCol="0" anchor="b"/>
+          <a:lstStyle>
+            <a:lvl1pPr algn="l">
+              <a:defRPr sz="1200"/>
+            </a:lvl1pPr>
+          </a:lstStyle>
+          <a:p>
+            <a:endParaRPr lang="id-ID"/>
+          </a:p>
+        </p:txBody>
+      </p:sp>
+      <p:sp>
+        <p:nvSpPr>
+          <p:cNvPr id="7" name="Slide Number Placeholder 6"/>
+          <p:cNvSpPr>
+            <a:spLocks noGrp="1"/>
+          </p:cNvSpPr>
+          <p:nvPr>
+            <p:ph type="sldNum" sz="quarter" idx="5"/>
+          </p:nvPr>
+        </p:nvSpPr>
+        <p:spPr>
+          <a:xfrm>
+            <a:off x="3884613" y="8685213"/>
+            <a:ext cx="2971800" cy="458787"/>
+          </a:xfrm>
+          <a:prstGeom prst="rect">
+            <a:avLst/>
+          </a:prstGeom>
+        </p:spPr>
+        <p:txBody>
+          <a:bodyPr vert="horz" lIns="91440" tIns="45720" rIns="91440" bIns="45720" rtlCol="0" anchor="b"/>
+          <a:lstStyle>
+            <a:lvl1pPr algn="r">
+              <a:defRPr sz="1200"/>
+            </a:lvl1pPr>
+          </a:lstStyle>
+          <a:p>
+            <a:fld id="{8EEFE1F5-6C2B-4C70-97D1-A362E8D6A10B}" type="slidenum">
+              <a:rPr lang="id-ID" smtClean="0"/>
+              <a:t>‹#›</a:t>
+            </a:fld>
+            <a:endParaRPr lang="id-ID"/>
+          </a:p>
+        </p:txBody>
+      </p:sp>
+    </p:spTree>
+    <p:extLst>
+      <p:ext uri="{BB962C8B-B14F-4D97-AF65-F5344CB8AC3E}">
+        <p14:creationId xmlns:p14="http://schemas.microsoft.com/office/powerpoint/2010/main" val="1180906191"/>
+      </p:ext>
+    </p:extLst>
+  </p:cSld>
+  <p:clrMap bg1="lt1" tx1="dk1" bg2="lt2" tx2="dk2" accent1="accent1" accent2="accent2" accent3="accent3" accent4="accent4" accent5="accent5" accent6="accent6" hlink="hlink" folHlink="folHlink"/>
+  <p:notesStyle>
+    <a:lvl1pPr marL="0" algn="l" defTabSz="914400" rtl="0" eaLnBrk="1" latinLnBrk="0" hangingPunct="1">
+      <a:defRPr sz="1200" kern="1200">
+        <a:solidFill>
+          <a:schemeClr val="tx1"/>
+        </a:solidFill>
+        <a:latin typeface="+mn-lt"/>
+        <a:ea typeface="+mn-ea"/>
+        <a:cs typeface="+mn-cs"/>
+      </a:defRPr>
+    </a:lvl1pPr>
+    <a:lvl2pPr marL="457200" algn="l" defTabSz="914400" rtl="0" eaLnBrk="1" latinLnBrk="0" hangingPunct="1">
+      <a:defRPr sz="1200" kern="1200">
+        <a:solidFill>
+          <a:schemeClr val="tx1"/>
+        </a:solidFill>
+        <a:latin typeface="+mn-lt"/>
+        <a:ea typeface="+mn-ea"/>
+        <a:cs typeface="+mn-cs"/>
+      </a:defRPr>
+    </a:lvl2pPr>
+    <a:lvl3pPr marL="914400" algn="l" defTabSz="914400" rtl="0" eaLnBrk="1" latinLnBrk="0" hangingPunct="1">
+      <a:defRPr sz="1200" kern="1200">
+        <a:solidFill>
+          <a:schemeClr val="tx1"/>
+        </a:solidFill>
+        <a:latin typeface="+mn-lt"/>
+        <a:ea typeface="+mn-ea"/>
+        <a:cs typeface="+mn-cs"/>
+      </a:defRPr>
+    </a:lvl3pPr>
+    <a:lvl4pPr marL="1371600" algn="l" defTabSz="914400" rtl="0" eaLnBrk="1" latinLnBrk="0" hangingPunct="1">
+      <a:defRPr sz="1200" kern="1200">
+        <a:solidFill>
+          <a:schemeClr val="tx1"/>
+        </a:solidFill>
+        <a:latin typeface="+mn-lt"/>
+        <a:ea typeface="+mn-ea"/>
+        <a:cs typeface="+mn-cs"/>
+      </a:defRPr>
+    </a:lvl4pPr>
+    <a:lvl5pPr marL="1828800" algn="l" defTabSz="914400" rtl="0" eaLnBrk="1" latinLnBrk="0" hangingPunct="1">
+      <a:defRPr sz="1200" kern="1200">
+        <a:solidFill>
+          <a:schemeClr val="tx1"/>
+        </a:solidFill>
+        <a:latin typeface="+mn-lt"/>
+        <a:ea typeface="+mn-ea"/>
+        <a:cs typeface="+mn-cs"/>
+      </a:defRPr>
+    </a:lvl5pPr>
+    <a:lvl6pPr marL="2286000" algn="l" defTabSz="914400" rtl="0" eaLnBrk="1" latinLnBrk="0" hangingPunct="1">
+      <a:defRPr sz="1200" kern="1200">
+        <a:solidFill>
+          <a:schemeClr val="tx1"/>
+        </a:solidFill>
+        <a:latin typeface="+mn-lt"/>
+        <a:ea typeface="+mn-ea"/>
+        <a:cs typeface="+mn-cs"/>
+      </a:defRPr>
+    </a:lvl6pPr>
+    <a:lvl7pPr marL="2743200" algn="l" defTabSz="914400" rtl="0" eaLnBrk="1" latinLnBrk="0" hangingPunct="1">
+      <a:defRPr sz="1200" kern="1200">
+        <a:solidFill>
+          <a:schemeClr val="tx1"/>
+        </a:solidFill>
+        <a:latin typeface="+mn-lt"/>
+        <a:ea typeface="+mn-ea"/>
+        <a:cs typeface="+mn-cs"/>
+      </a:defRPr>
+    </a:lvl7pPr>
+    <a:lvl8pPr marL="3200400" algn="l" defTabSz="914400" rtl="0" eaLnBrk="1" latinLnBrk="0" hangingPunct="1">
+      <a:defRPr sz="1200" kern="1200">
+        <a:solidFill>
+          <a:schemeClr val="tx1"/>
+        </a:solidFill>
+        <a:latin typeface="+mn-lt"/>
+        <a:ea typeface="+mn-ea"/>
+        <a:cs typeface="+mn-cs"/>
+      </a:defRPr>
+    </a:lvl8pPr>
+    <a:lvl9pPr marL="3657600" algn="l" defTabSz="914400" rtl="0" eaLnBrk="1" latinLnBrk="0" hangingPunct="1">
+      <a:defRPr sz="1200" kern="1200">
+        <a:solidFill>
+          <a:schemeClr val="tx1"/>
+        </a:solidFill>
+        <a:latin typeface="+mn-lt"/>
+        <a:ea typeface="+mn-ea"/>
+        <a:cs typeface="+mn-cs"/>
+      </a:defRPr>
+    </a:lvl9pPr>
+  </p:notesStyle>
+</p:notesMaster>
+</file>
+
+<file path=ppt/notesSlides/notesSlide1.xml><?xml version="1.0" encoding="utf-8"?>
+<p:notes xmlns:a="http://schemas.openxmlformats.org/drawingml/2006/main" xmlns:r="http://schemas.openxmlformats.org/officeDocument/2006/relationships" xmlns:p="http://schemas.openxmlformats.org/presentationml/2006/main">
+  <p:cSld>
+    <p:spTree>
+      <p:nvGrpSpPr>
+        <p:cNvPr id="1" name=""/>
+        <p:cNvGrpSpPr/>
+        <p:nvPr/>
+      </p:nvGrpSpPr>
+      <p:grpSpPr>
+        <a:xfrm>
+          <a:off x="0" y="0"/>
+          <a:ext cx="0" cy="0"/>
+          <a:chOff x="0" y="0"/>
+          <a:chExt cx="0" cy="0"/>
+        </a:xfrm>
+      </p:grpSpPr>
+      <p:sp>
+        <p:nvSpPr>
+          <p:cNvPr id="2" name="Slide Image Placeholder 1"/>
+          <p:cNvSpPr>
+            <a:spLocks noGrp="1" noRot="1" noChangeAspect="1"/>
+          </p:cNvSpPr>
+          <p:nvPr>
+            <p:ph type="sldImg"/>
+          </p:nvPr>
+        </p:nvSpPr>
+        <p:spPr/>
+      </p:sp>
+      <p:sp>
+        <p:nvSpPr>
+          <p:cNvPr id="3" name="Notes Placeholder 2"/>
+          <p:cNvSpPr>
+            <a:spLocks noGrp="1"/>
+          </p:cNvSpPr>
+          <p:nvPr>
+            <p:ph type="body" idx="1"/>
+          </p:nvPr>
+        </p:nvSpPr>
+        <p:spPr/>
+        <p:txBody>
+          <a:bodyPr/>
+          <a:lstStyle/>
+          <a:p>
+            <a:endParaRPr lang="id-ID" dirty="0"/>
+          </a:p>
+        </p:txBody>
+      </p:sp>
+      <p:sp>
+        <p:nvSpPr>
+          <p:cNvPr id="4" name="Slide Number Placeholder 3"/>
+          <p:cNvSpPr>
+            <a:spLocks noGrp="1"/>
+          </p:cNvSpPr>
+          <p:nvPr>
+            <p:ph type="sldNum" sz="quarter" idx="5"/>
+          </p:nvPr>
+        </p:nvSpPr>
+        <p:spPr/>
+        <p:txBody>
+          <a:bodyPr/>
+          <a:lstStyle/>
+          <a:p>
+            <a:fld id="{8EEFE1F5-6C2B-4C70-97D1-A362E8D6A10B}" type="slidenum">
+              <a:rPr lang="id-ID" smtClean="0"/>
+              <a:t>15</a:t>
+            </a:fld>
+            <a:endParaRPr lang="id-ID"/>
+          </a:p>
+        </p:txBody>
+      </p:sp>
+    </p:spTree>
+    <p:extLst>
+      <p:ext uri="{BB962C8B-B14F-4D97-AF65-F5344CB8AC3E}">
+        <p14:creationId xmlns:p14="http://schemas.microsoft.com/office/powerpoint/2010/main" val="4284061585"/>
+      </p:ext>
+    </p:extLst>
+  </p:cSld>
+  <p:clrMapOvr>
+    <a:masterClrMapping/>
+  </p:clrMapOvr>
+</p:notes>
+</file>
+
+<file path=ppt/notesSlides/notesSlide2.xml><?xml version="1.0" encoding="utf-8"?>
+<p:notes xmlns:a="http://schemas.openxmlformats.org/drawingml/2006/main" xmlns:r="http://schemas.openxmlformats.org/officeDocument/2006/relationships" xmlns:p="http://schemas.openxmlformats.org/presentationml/2006/main">
+  <p:cSld>
+    <p:spTree>
+      <p:nvGrpSpPr>
+        <p:cNvPr id="1" name="">
+          <a:extLst>
+            <a:ext uri="{FF2B5EF4-FFF2-40B4-BE49-F238E27FC236}">
+              <a16:creationId xmlns:a16="http://schemas.microsoft.com/office/drawing/2014/main" id="{ACEF85D8-A1D3-FD01-6B92-5E7677B91E5C}"/>
+            </a:ext>
+          </a:extLst>
+        </p:cNvPr>
+        <p:cNvGrpSpPr/>
+        <p:nvPr/>
+      </p:nvGrpSpPr>
+      <p:grpSpPr>
+        <a:xfrm>
+          <a:off x="0" y="0"/>
+          <a:ext cx="0" cy="0"/>
+          <a:chOff x="0" y="0"/>
+          <a:chExt cx="0" cy="0"/>
+        </a:xfrm>
+      </p:grpSpPr>
+      <p:sp>
+        <p:nvSpPr>
+          <p:cNvPr id="2" name="Slide Image Placeholder 1">
+            <a:extLst>
+              <a:ext uri="{FF2B5EF4-FFF2-40B4-BE49-F238E27FC236}">
+                <a16:creationId xmlns:a16="http://schemas.microsoft.com/office/drawing/2014/main" id="{FCD45895-CF0B-2C9F-1BFF-7360007495E7}"/>
+              </a:ext>
+            </a:extLst>
+          </p:cNvPr>
+          <p:cNvSpPr>
+            <a:spLocks noGrp="1" noRot="1" noChangeAspect="1"/>
+          </p:cNvSpPr>
+          <p:nvPr>
+            <p:ph type="sldImg"/>
+          </p:nvPr>
+        </p:nvSpPr>
+        <p:spPr/>
+      </p:sp>
+      <p:sp>
+        <p:nvSpPr>
+          <p:cNvPr id="3" name="Notes Placeholder 2">
+            <a:extLst>
+              <a:ext uri="{FF2B5EF4-FFF2-40B4-BE49-F238E27FC236}">
+                <a16:creationId xmlns:a16="http://schemas.microsoft.com/office/drawing/2014/main" id="{C465CEEF-A234-B593-301D-00D46E30CCFB}"/>
+              </a:ext>
+            </a:extLst>
+          </p:cNvPr>
+          <p:cNvSpPr>
+            <a:spLocks noGrp="1"/>
+          </p:cNvSpPr>
+          <p:nvPr>
+            <p:ph type="body" idx="1"/>
+          </p:nvPr>
+        </p:nvSpPr>
+        <p:spPr/>
+        <p:txBody>
+          <a:bodyPr/>
+          <a:lstStyle/>
+          <a:p>
+            <a:endParaRPr lang="id-ID" dirty="0"/>
+          </a:p>
+        </p:txBody>
+      </p:sp>
+      <p:sp>
+        <p:nvSpPr>
+          <p:cNvPr id="4" name="Slide Number Placeholder 3">
+            <a:extLst>
+              <a:ext uri="{FF2B5EF4-FFF2-40B4-BE49-F238E27FC236}">
+                <a16:creationId xmlns:a16="http://schemas.microsoft.com/office/drawing/2014/main" id="{FA0BCE21-C340-B07D-94EE-494CCC5591C9}"/>
+              </a:ext>
+            </a:extLst>
+          </p:cNvPr>
+          <p:cNvSpPr>
+            <a:spLocks noGrp="1"/>
+          </p:cNvSpPr>
+          <p:nvPr>
+            <p:ph type="sldNum" sz="quarter" idx="5"/>
+          </p:nvPr>
+        </p:nvSpPr>
+        <p:spPr/>
+        <p:txBody>
+          <a:bodyPr/>
+          <a:lstStyle/>
+          <a:p>
+            <a:fld id="{8EEFE1F5-6C2B-4C70-97D1-A362E8D6A10B}" type="slidenum">
+              <a:rPr lang="id-ID" smtClean="0"/>
+              <a:t>16</a:t>
+            </a:fld>
+            <a:endParaRPr lang="id-ID"/>
+          </a:p>
+        </p:txBody>
+      </p:sp>
+    </p:spTree>
+    <p:extLst>
+      <p:ext uri="{BB962C8B-B14F-4D97-AF65-F5344CB8AC3E}">
+        <p14:creationId xmlns:p14="http://schemas.microsoft.com/office/powerpoint/2010/main" val="3891701240"/>
+      </p:ext>
+    </p:extLst>
+  </p:cSld>
+  <p:clrMapOvr>
+    <a:masterClrMapping/>
+  </p:clrMapOvr>
+</p:notes>
 </file>
 
 <file path=ppt/slideLayouts/slideLayout1.xml><?xml version="1.0" encoding="utf-8"?>
@@ -4000,10 +4548,2696 @@
           </a:prstGeom>
         </p:spPr>
       </p:pic>
+      <p:sp>
+        <p:nvSpPr>
+          <p:cNvPr id="2" name="TextBox 1">
+            <a:extLst>
+              <a:ext uri="{FF2B5EF4-FFF2-40B4-BE49-F238E27FC236}">
+                <a16:creationId xmlns:a16="http://schemas.microsoft.com/office/drawing/2014/main" id="{938C402F-DEF1-72C6-7831-F93AE24C7730}"/>
+              </a:ext>
+            </a:extLst>
+          </p:cNvPr>
+          <p:cNvSpPr txBox="1"/>
+          <p:nvPr/>
+        </p:nvSpPr>
+        <p:spPr>
+          <a:xfrm>
+            <a:off x="914400" y="5329382"/>
+            <a:ext cx="1935145" cy="1200329"/>
+          </a:xfrm>
+          <a:prstGeom prst="rect">
+            <a:avLst/>
+          </a:prstGeom>
+          <a:noFill/>
+        </p:spPr>
+        <p:txBody>
+          <a:bodyPr wrap="none" rtlCol="0">
+            <a:spAutoFit/>
+          </a:bodyPr>
+          <a:lstStyle/>
+          <a:p>
+            <a:r>
+              <a:rPr lang="en-US" dirty="0"/>
+              <a:t>Password Root</a:t>
+            </a:r>
+          </a:p>
+          <a:p>
+            <a:r>
+              <a:rPr lang="en-US" dirty="0"/>
+              <a:t>AKP : esaakp@123</a:t>
+            </a:r>
+          </a:p>
+          <a:p>
+            <a:r>
+              <a:rPr lang="en-US" dirty="0"/>
+              <a:t>ATK : </a:t>
+            </a:r>
+            <a:r>
+              <a:rPr lang="en-US" dirty="0" err="1"/>
+              <a:t>serverATK</a:t>
+            </a:r>
+            <a:endParaRPr lang="en-US" dirty="0"/>
+          </a:p>
+          <a:p>
+            <a:r>
+              <a:rPr lang="en-US" dirty="0"/>
+              <a:t>AMK : </a:t>
+            </a:r>
+            <a:r>
+              <a:rPr lang="en-US" dirty="0" err="1"/>
+              <a:t>serverAMK</a:t>
+            </a:r>
+            <a:endParaRPr lang="id-ID" dirty="0"/>
+          </a:p>
+        </p:txBody>
+      </p:sp>
+      <p:sp>
+        <p:nvSpPr>
+          <p:cNvPr id="5" name="TextBox 4">
+            <a:extLst>
+              <a:ext uri="{FF2B5EF4-FFF2-40B4-BE49-F238E27FC236}">
+                <a16:creationId xmlns:a16="http://schemas.microsoft.com/office/drawing/2014/main" id="{1210C8F5-ECA3-5D86-FA52-570ECA803D25}"/>
+              </a:ext>
+            </a:extLst>
+          </p:cNvPr>
+          <p:cNvSpPr txBox="1"/>
+          <p:nvPr/>
+        </p:nvSpPr>
+        <p:spPr>
+          <a:xfrm>
+            <a:off x="3514725" y="4972492"/>
+            <a:ext cx="35325348" cy="1200329"/>
+          </a:xfrm>
+          <a:prstGeom prst="rect">
+            <a:avLst/>
+          </a:prstGeom>
+          <a:noFill/>
+        </p:spPr>
+        <p:txBody>
+          <a:bodyPr wrap="square" rtlCol="0">
+            <a:spAutoFit/>
+          </a:bodyPr>
+          <a:lstStyle/>
+          <a:p>
+            <a:r>
+              <a:rPr lang="id-ID" dirty="0" err="1"/>
+              <a:t>ssh-rsa</a:t>
+            </a:r>
+            <a:r>
+              <a:rPr lang="id-ID" dirty="0"/>
+              <a:t> AAAAB3NzaC1yc2EAAAADAQABAAACAQD6qEhIT7to1HOYxJozuiQZfvqBxYTFxl719kHSNHzYiviRA/480FlsLQW7a6/jvL91CjhWwba/gLxBpZvE9BcLiUsw3lrj20rCO9/4/</a:t>
+            </a:r>
+            <a:r>
+              <a:rPr lang="id-ID" dirty="0" err="1"/>
+              <a:t>XbfpQML</a:t>
+            </a:r>
+            <a:r>
+              <a:rPr lang="id-ID" dirty="0"/>
+              <a:t>/ZhDhYM71sb2RMEYOVgGqeKYA8n9H37pNJvq/0ETchnFfgD5YBK6YbDv61AE0FWrES0SDvaLgKP0jX5wYiRiqdtcxVVlAwFjYdjpiuL4PgcZ1MlrsMSZPE3XlP4Su7zMS9WFL+Rs4BPuYoicyYDq0mCHqoJm4UaKU53n+ks3/5bzfzBRUjDDc9veL+SUT+uzJT+tDcQoYyKLHj7cdODBFwKBqudCH3bmXob0iO/c+jRF0EtFrHioLAeu//dGyfDBq9q278oDfKAWDedvijatIWMRoCglS0GqcgOAmDlNmUmhnrQHW8FtPkcMQmLmU9Vu1wGrmE2kBePDoBuvQ0vdR4qLIiuFJkMWRDFOyX+1eIO5DRf3JOJjriRXwJzH6dMNNqod6KmTbiJB0UC2IMIta66nii/JYH3tBO2pPQr50Ghnmj0+ZTCKx9l1Ww0JzKOU+TPfoZ4Hd3muXzh7pf803eg9JDCDlusf5mv4u+ETcGUQn2if7j3B9KxkodAeOTbSRwGHELp8md8irtSzRDpzQ+J7UsDyUH4HTX+CmpLmxRsH67mKpSlszEvdUvDy7w== root@VM-17-89-debian</a:t>
+            </a:r>
+          </a:p>
+        </p:txBody>
+      </p:sp>
+      <p:sp>
+        <p:nvSpPr>
+          <p:cNvPr id="7" name="TextBox 6">
+            <a:extLst>
+              <a:ext uri="{FF2B5EF4-FFF2-40B4-BE49-F238E27FC236}">
+                <a16:creationId xmlns:a16="http://schemas.microsoft.com/office/drawing/2014/main" id="{DEF19C68-8188-C7D9-43A9-890E3ED2867F}"/>
+              </a:ext>
+            </a:extLst>
+          </p:cNvPr>
+          <p:cNvSpPr txBox="1"/>
+          <p:nvPr/>
+        </p:nvSpPr>
+        <p:spPr>
+          <a:xfrm>
+            <a:off x="6905625" y="3762375"/>
+            <a:ext cx="86981376" cy="1200329"/>
+          </a:xfrm>
+          <a:prstGeom prst="rect">
+            <a:avLst/>
+          </a:prstGeom>
+          <a:noFill/>
+        </p:spPr>
+        <p:txBody>
+          <a:bodyPr wrap="none" rtlCol="0">
+            <a:spAutoFit/>
+          </a:bodyPr>
+          <a:lstStyle/>
+          <a:p>
+            <a:r>
+              <a:rPr lang="id-ID" dirty="0" err="1"/>
+              <a:t>mkdir</a:t>
+            </a:r>
+            <a:r>
+              <a:rPr lang="id-ID" dirty="0"/>
+              <a:t> -p ~/.</a:t>
+            </a:r>
+            <a:r>
+              <a:rPr lang="id-ID" dirty="0" err="1"/>
+              <a:t>ssh</a:t>
+            </a:r>
+            <a:r>
+              <a:rPr lang="id-ID" dirty="0"/>
+              <a:t> &amp;&amp; </a:t>
+            </a:r>
+            <a:r>
+              <a:rPr lang="id-ID" dirty="0" err="1"/>
+              <a:t>chmod</a:t>
+            </a:r>
+            <a:r>
+              <a:rPr lang="id-ID" dirty="0"/>
+              <a:t> 700 ~/.</a:t>
+            </a:r>
+            <a:r>
+              <a:rPr lang="id-ID" dirty="0" err="1"/>
+              <a:t>ssh</a:t>
+            </a:r>
+            <a:endParaRPr lang="id-ID" dirty="0"/>
+          </a:p>
+          <a:p>
+            <a:r>
+              <a:rPr lang="id-ID" dirty="0" err="1"/>
+              <a:t>echo</a:t>
+            </a:r>
+            <a:r>
+              <a:rPr lang="id-ID" dirty="0"/>
+              <a:t> "</a:t>
+            </a:r>
+            <a:r>
+              <a:rPr lang="id-ID" dirty="0" err="1"/>
+              <a:t>ssh-rsa</a:t>
+            </a:r>
+            <a:r>
+              <a:rPr lang="id-ID" dirty="0"/>
+              <a:t> AAAAB3NzaC1yc2EAAAADAQABAAACAQD6qEhIT7to1HOYxJozuiQZfvqBxYTFxl719kHSNHzYiviRA/480FlsLQW7a6/jvL91CjhWwba/gLxBpZvE9BcLiUsw3lrj20rCO9/4/</a:t>
+            </a:r>
+            <a:r>
+              <a:rPr lang="id-ID" dirty="0" err="1"/>
+              <a:t>XbfpQML</a:t>
+            </a:r>
+            <a:r>
+              <a:rPr lang="id-ID" dirty="0"/>
+              <a:t>/ZhDhYM71sb2RMEYOVgGqeKYA8n9H37pNJvq/0ETchnFfgD5YBK6YbDv61AE0FWrES0SDvaLgKP0jX5wYiRiqdtcxVVlAwFjYdjpiuL4PgcZ1MlrsMSZPE3XlP4Su7zMS9WFL+Rs4BPuYoicyYDq0mCHqoJm4UaKU53n+ks3/5bzfzBRUjDDc9veL+SUT+uzJT+tDcQoYyKLHj7cdODBFwKBqudCH3bmXob0iO/c+jRF0EtFrHioLAeu//dGyfDBq9q278oDfKAWDedvijatIWMRoCglS0GqcgOAmDlNmUmhnrQHW8FtPkcMQmLmU9Vu1wGrmE2kBePDoBuvQ0vdR4qLIiuFJkMWRDFOyX+1eIO5DRf3JOJjriRXwJzH6dMNNqod6KmTbiJB0UC2IMIta66nii/JYH3tBO2pPQr50Ghnmj0+ZTCKx9l1Ww0JzKOU+TPfoZ4Hd3muXzh7pf803eg9JDCDlusf5mv4u+ETcGUQn2if7j3B9KxkodAeOTbSRwGHELp8md8irtSzRDpzQ+J7UsDyUH4HTX+CmpLmxRsH67mKpSlszEvdUvDy7w== root@VM-17-89-debian</a:t>
+            </a:r>
+          </a:p>
+          <a:p>
+            <a:r>
+              <a:rPr lang="id-ID" dirty="0"/>
+              <a:t>" &gt;&gt; ~/.</a:t>
+            </a:r>
+            <a:r>
+              <a:rPr lang="id-ID" dirty="0" err="1"/>
+              <a:t>ssh</a:t>
+            </a:r>
+            <a:r>
+              <a:rPr lang="id-ID" dirty="0"/>
+              <a:t>/</a:t>
+            </a:r>
+            <a:r>
+              <a:rPr lang="id-ID" dirty="0" err="1"/>
+              <a:t>authorized_keys</a:t>
+            </a:r>
+            <a:endParaRPr lang="id-ID" dirty="0"/>
+          </a:p>
+          <a:p>
+            <a:r>
+              <a:rPr lang="id-ID" dirty="0" err="1"/>
+              <a:t>chmod</a:t>
+            </a:r>
+            <a:r>
+              <a:rPr lang="id-ID" dirty="0"/>
+              <a:t> 600 ~/.</a:t>
+            </a:r>
+            <a:r>
+              <a:rPr lang="id-ID" dirty="0" err="1"/>
+              <a:t>ssh</a:t>
+            </a:r>
+            <a:r>
+              <a:rPr lang="id-ID" dirty="0"/>
+              <a:t>/</a:t>
+            </a:r>
+            <a:r>
+              <a:rPr lang="id-ID" dirty="0" err="1"/>
+              <a:t>authorized_keys</a:t>
+            </a:r>
+            <a:endParaRPr lang="id-ID" dirty="0"/>
+          </a:p>
+        </p:txBody>
+      </p:sp>
     </p:spTree>
     <p:extLst>
       <p:ext uri="{BB962C8B-B14F-4D97-AF65-F5344CB8AC3E}">
         <p14:creationId xmlns:p14="http://schemas.microsoft.com/office/powerpoint/2010/main" val="255776576"/>
+      </p:ext>
+    </p:extLst>
+  </p:cSld>
+  <p:clrMapOvr>
+    <a:masterClrMapping/>
+  </p:clrMapOvr>
+</p:sld>
+</file>
+
+<file path=ppt/slides/slide14.xml><?xml version="1.0" encoding="utf-8"?>
+<p:sld xmlns:a="http://schemas.openxmlformats.org/drawingml/2006/main" xmlns:r="http://schemas.openxmlformats.org/officeDocument/2006/relationships" xmlns:p="http://schemas.openxmlformats.org/presentationml/2006/main">
+  <p:cSld>
+    <p:spTree>
+      <p:nvGrpSpPr>
+        <p:cNvPr id="1" name=""/>
+        <p:cNvGrpSpPr/>
+        <p:nvPr/>
+      </p:nvGrpSpPr>
+      <p:grpSpPr>
+        <a:xfrm>
+          <a:off x="0" y="0"/>
+          <a:ext cx="0" cy="0"/>
+          <a:chOff x="0" y="0"/>
+          <a:chExt cx="0" cy="0"/>
+        </a:xfrm>
+      </p:grpSpPr>
+      <p:sp>
+        <p:nvSpPr>
+          <p:cNvPr id="2" name="TextBox 1">
+            <a:extLst>
+              <a:ext uri="{FF2B5EF4-FFF2-40B4-BE49-F238E27FC236}">
+                <a16:creationId xmlns:a16="http://schemas.microsoft.com/office/drawing/2014/main" id="{D981E43D-F63A-099A-D21D-3BF9EE169885}"/>
+              </a:ext>
+            </a:extLst>
+          </p:cNvPr>
+          <p:cNvSpPr txBox="1"/>
+          <p:nvPr/>
+        </p:nvSpPr>
+        <p:spPr>
+          <a:xfrm>
+            <a:off x="230909" y="314036"/>
+            <a:ext cx="11599650" cy="3416320"/>
+          </a:xfrm>
+          <a:prstGeom prst="rect">
+            <a:avLst/>
+          </a:prstGeom>
+          <a:noFill/>
+        </p:spPr>
+        <p:txBody>
+          <a:bodyPr wrap="none" rtlCol="0">
+            <a:spAutoFit/>
+          </a:bodyPr>
+          <a:lstStyle/>
+          <a:p>
+            <a:r>
+              <a:rPr lang="id-ID" dirty="0"/>
+              <a:t>cd /</a:t>
+            </a:r>
+            <a:r>
+              <a:rPr lang="id-ID" dirty="0" err="1"/>
+              <a:t>root</a:t>
+            </a:r>
+            <a:r>
+              <a:rPr lang="id-ID" dirty="0"/>
+              <a:t> &amp;&amp; </a:t>
+            </a:r>
+            <a:r>
+              <a:rPr lang="id-ID" dirty="0" err="1"/>
+              <a:t>rm</a:t>
+            </a:r>
+            <a:r>
+              <a:rPr lang="id-ID" dirty="0"/>
+              <a:t> -</a:t>
+            </a:r>
+            <a:r>
+              <a:rPr lang="id-ID" dirty="0" err="1"/>
+              <a:t>rf</a:t>
+            </a:r>
+            <a:r>
+              <a:rPr lang="id-ID" dirty="0"/>
+              <a:t> </a:t>
+            </a:r>
+            <a:r>
+              <a:rPr lang="id-ID" dirty="0" err="1"/>
+              <a:t>att-repo-update</a:t>
+            </a:r>
+            <a:r>
+              <a:rPr lang="id-ID" dirty="0"/>
+              <a:t> &amp;&amp; </a:t>
+            </a:r>
+            <a:r>
+              <a:rPr lang="id-ID" dirty="0" err="1"/>
+              <a:t>git</a:t>
+            </a:r>
+            <a:r>
+              <a:rPr lang="id-ID" dirty="0"/>
+              <a:t> </a:t>
+            </a:r>
+            <a:r>
+              <a:rPr lang="id-ID" dirty="0" err="1"/>
+              <a:t>clone</a:t>
+            </a:r>
+            <a:r>
+              <a:rPr lang="id-ID" dirty="0"/>
+              <a:t> https://github.com/digitalgalery-dgsoft/attendaceesa.git </a:t>
+            </a:r>
+            <a:r>
+              <a:rPr lang="id-ID" dirty="0" err="1"/>
+              <a:t>att-repo-update</a:t>
+            </a:r>
+            <a:endParaRPr lang="id-ID" dirty="0"/>
+          </a:p>
+          <a:p>
+            <a:r>
+              <a:rPr lang="id-ID" dirty="0"/>
+              <a:t>\</a:t>
+            </a:r>
+            <a:r>
+              <a:rPr lang="id-ID" dirty="0" err="1"/>
+              <a:t>cp</a:t>
+            </a:r>
+            <a:r>
+              <a:rPr lang="id-ID" dirty="0"/>
+              <a:t> -</a:t>
+            </a:r>
+            <a:r>
+              <a:rPr lang="id-ID" dirty="0" err="1"/>
+              <a:t>rf</a:t>
+            </a:r>
+            <a:r>
+              <a:rPr lang="id-ID" dirty="0"/>
+              <a:t> /</a:t>
+            </a:r>
+            <a:r>
+              <a:rPr lang="id-ID" dirty="0" err="1"/>
+              <a:t>root</a:t>
+            </a:r>
+            <a:r>
+              <a:rPr lang="id-ID" dirty="0"/>
+              <a:t>/</a:t>
+            </a:r>
+            <a:r>
+              <a:rPr lang="id-ID" dirty="0" err="1"/>
+              <a:t>att-repo-update</a:t>
+            </a:r>
+            <a:r>
+              <a:rPr lang="id-ID" dirty="0"/>
+              <a:t>/att-admin-v12/. /</a:t>
+            </a:r>
+            <a:r>
+              <a:rPr lang="id-ID" dirty="0" err="1"/>
+              <a:t>www</a:t>
+            </a:r>
+            <a:r>
+              <a:rPr lang="id-ID" dirty="0"/>
+              <a:t>/</a:t>
+            </a:r>
+            <a:r>
+              <a:rPr lang="id-ID" dirty="0" err="1"/>
+              <a:t>wwwroot</a:t>
+            </a:r>
+            <a:r>
+              <a:rPr lang="id-ID" dirty="0"/>
+              <a:t>/amk.dgsoft.web.id/</a:t>
+            </a:r>
+          </a:p>
+          <a:p>
+            <a:r>
+              <a:rPr lang="id-ID" dirty="0"/>
+              <a:t>cd /www/wwwroot/amk.dgsoft.web.id</a:t>
+            </a:r>
+          </a:p>
+          <a:p>
+            <a:r>
+              <a:rPr lang="id-ID" dirty="0"/>
+              <a:t>/</a:t>
+            </a:r>
+            <a:r>
+              <a:rPr lang="id-ID" dirty="0" err="1"/>
+              <a:t>www</a:t>
+            </a:r>
+            <a:r>
+              <a:rPr lang="id-ID" dirty="0"/>
+              <a:t>/server/</a:t>
+            </a:r>
+            <a:r>
+              <a:rPr lang="id-ID" dirty="0" err="1"/>
+              <a:t>php</a:t>
+            </a:r>
+            <a:r>
+              <a:rPr lang="id-ID" dirty="0"/>
+              <a:t>/83/bin/</a:t>
+            </a:r>
+            <a:r>
+              <a:rPr lang="id-ID" dirty="0" err="1"/>
+              <a:t>php</a:t>
+            </a:r>
+            <a:r>
+              <a:rPr lang="id-ID" dirty="0"/>
+              <a:t> artisan </a:t>
+            </a:r>
+            <a:r>
+              <a:rPr lang="id-ID" dirty="0" err="1"/>
+              <a:t>storage:link</a:t>
+            </a:r>
+            <a:r>
+              <a:rPr lang="id-ID" dirty="0"/>
+              <a:t> 2&gt;/</a:t>
+            </a:r>
+            <a:r>
+              <a:rPr lang="id-ID" dirty="0" err="1"/>
+              <a:t>dev</a:t>
+            </a:r>
+            <a:r>
+              <a:rPr lang="id-ID" dirty="0"/>
+              <a:t>/</a:t>
+            </a:r>
+            <a:r>
+              <a:rPr lang="id-ID" dirty="0" err="1"/>
+              <a:t>null</a:t>
+            </a:r>
+            <a:r>
+              <a:rPr lang="id-ID" dirty="0"/>
+              <a:t> || </a:t>
+            </a:r>
+            <a:r>
+              <a:rPr lang="id-ID" dirty="0" err="1"/>
+              <a:t>true</a:t>
+            </a:r>
+            <a:endParaRPr lang="id-ID" dirty="0"/>
+          </a:p>
+          <a:p>
+            <a:r>
+              <a:rPr lang="id-ID" dirty="0"/>
+              <a:t>/</a:t>
+            </a:r>
+            <a:r>
+              <a:rPr lang="id-ID" dirty="0" err="1"/>
+              <a:t>www</a:t>
+            </a:r>
+            <a:r>
+              <a:rPr lang="id-ID" dirty="0"/>
+              <a:t>/server/</a:t>
+            </a:r>
+            <a:r>
+              <a:rPr lang="id-ID" dirty="0" err="1"/>
+              <a:t>php</a:t>
+            </a:r>
+            <a:r>
+              <a:rPr lang="id-ID" dirty="0"/>
+              <a:t>/83/bin/</a:t>
+            </a:r>
+            <a:r>
+              <a:rPr lang="id-ID" dirty="0" err="1"/>
+              <a:t>php</a:t>
+            </a:r>
+            <a:r>
+              <a:rPr lang="id-ID" dirty="0"/>
+              <a:t> artisan </a:t>
+            </a:r>
+            <a:r>
+              <a:rPr lang="id-ID" dirty="0" err="1"/>
+              <a:t>livewire:publish</a:t>
+            </a:r>
+            <a:r>
+              <a:rPr lang="id-ID" dirty="0"/>
+              <a:t> --</a:t>
+            </a:r>
+            <a:r>
+              <a:rPr lang="id-ID" dirty="0" err="1"/>
+              <a:t>assets</a:t>
+            </a:r>
+            <a:r>
+              <a:rPr lang="id-ID" dirty="0"/>
+              <a:t> 2&gt;/</a:t>
+            </a:r>
+            <a:r>
+              <a:rPr lang="id-ID" dirty="0" err="1"/>
+              <a:t>dev</a:t>
+            </a:r>
+            <a:r>
+              <a:rPr lang="id-ID" dirty="0"/>
+              <a:t>/</a:t>
+            </a:r>
+            <a:r>
+              <a:rPr lang="id-ID" dirty="0" err="1"/>
+              <a:t>null</a:t>
+            </a:r>
+            <a:r>
+              <a:rPr lang="id-ID" dirty="0"/>
+              <a:t> || </a:t>
+            </a:r>
+            <a:r>
+              <a:rPr lang="id-ID" dirty="0" err="1"/>
+              <a:t>true</a:t>
+            </a:r>
+            <a:endParaRPr lang="id-ID" dirty="0"/>
+          </a:p>
+          <a:p>
+            <a:r>
+              <a:rPr lang="id-ID" dirty="0" err="1"/>
+              <a:t>mkdir</a:t>
+            </a:r>
+            <a:r>
+              <a:rPr lang="id-ID" dirty="0"/>
+              <a:t> -p </a:t>
+            </a:r>
+            <a:r>
+              <a:rPr lang="id-ID" dirty="0" err="1"/>
+              <a:t>public</a:t>
+            </a:r>
+            <a:r>
+              <a:rPr lang="id-ID" dirty="0"/>
+              <a:t>/</a:t>
+            </a:r>
+            <a:r>
+              <a:rPr lang="id-ID" dirty="0" err="1"/>
+              <a:t>livewire</a:t>
+            </a:r>
+            <a:r>
+              <a:rPr lang="id-ID" dirty="0"/>
+              <a:t> &amp;&amp; \</a:t>
+            </a:r>
+            <a:r>
+              <a:rPr lang="id-ID" dirty="0" err="1"/>
+              <a:t>cp</a:t>
+            </a:r>
+            <a:r>
+              <a:rPr lang="id-ID" dirty="0"/>
+              <a:t> -</a:t>
+            </a:r>
+            <a:r>
+              <a:rPr lang="id-ID" dirty="0" err="1"/>
+              <a:t>rf</a:t>
+            </a:r>
+            <a:r>
+              <a:rPr lang="id-ID" dirty="0"/>
+              <a:t> vendor/</a:t>
+            </a:r>
+            <a:r>
+              <a:rPr lang="id-ID" dirty="0" err="1"/>
+              <a:t>livewire</a:t>
+            </a:r>
+            <a:r>
+              <a:rPr lang="id-ID" dirty="0"/>
+              <a:t>/</a:t>
+            </a:r>
+            <a:r>
+              <a:rPr lang="id-ID" dirty="0" err="1"/>
+              <a:t>livewire</a:t>
+            </a:r>
+            <a:r>
+              <a:rPr lang="id-ID" dirty="0"/>
+              <a:t>/</a:t>
+            </a:r>
+            <a:r>
+              <a:rPr lang="id-ID" dirty="0" err="1"/>
+              <a:t>dist</a:t>
+            </a:r>
+            <a:r>
+              <a:rPr lang="id-ID" dirty="0"/>
+              <a:t>/* </a:t>
+            </a:r>
+            <a:r>
+              <a:rPr lang="id-ID" dirty="0" err="1"/>
+              <a:t>public</a:t>
+            </a:r>
+            <a:r>
+              <a:rPr lang="id-ID" dirty="0"/>
+              <a:t>/</a:t>
+            </a:r>
+            <a:r>
+              <a:rPr lang="id-ID" dirty="0" err="1"/>
+              <a:t>livewire</a:t>
+            </a:r>
+            <a:r>
+              <a:rPr lang="id-ID" dirty="0"/>
+              <a:t>/ 2&gt;/</a:t>
+            </a:r>
+            <a:r>
+              <a:rPr lang="id-ID" dirty="0" err="1"/>
+              <a:t>dev</a:t>
+            </a:r>
+            <a:r>
+              <a:rPr lang="id-ID" dirty="0"/>
+              <a:t>/</a:t>
+            </a:r>
+            <a:r>
+              <a:rPr lang="id-ID" dirty="0" err="1"/>
+              <a:t>null</a:t>
+            </a:r>
+            <a:r>
+              <a:rPr lang="id-ID" dirty="0"/>
+              <a:t> || </a:t>
+            </a:r>
+            <a:r>
+              <a:rPr lang="id-ID" dirty="0" err="1"/>
+              <a:t>true</a:t>
+            </a:r>
+            <a:endParaRPr lang="id-ID" dirty="0"/>
+          </a:p>
+          <a:p>
+            <a:r>
+              <a:rPr lang="id-ID" dirty="0" err="1"/>
+              <a:t>rm</a:t>
+            </a:r>
+            <a:r>
+              <a:rPr lang="id-ID" dirty="0"/>
+              <a:t> -f </a:t>
+            </a:r>
+            <a:r>
+              <a:rPr lang="id-ID" dirty="0" err="1"/>
+              <a:t>public</a:t>
+            </a:r>
+            <a:r>
+              <a:rPr lang="id-ID" dirty="0"/>
+              <a:t>/hot</a:t>
+            </a:r>
+          </a:p>
+          <a:p>
+            <a:r>
+              <a:rPr lang="id-ID" dirty="0"/>
+              <a:t>/</a:t>
+            </a:r>
+            <a:r>
+              <a:rPr lang="id-ID" dirty="0" err="1"/>
+              <a:t>www</a:t>
+            </a:r>
+            <a:r>
+              <a:rPr lang="id-ID" dirty="0"/>
+              <a:t>/server/</a:t>
+            </a:r>
+            <a:r>
+              <a:rPr lang="id-ID" dirty="0" err="1"/>
+              <a:t>php</a:t>
+            </a:r>
+            <a:r>
+              <a:rPr lang="id-ID" dirty="0"/>
+              <a:t>/83/bin/</a:t>
+            </a:r>
+            <a:r>
+              <a:rPr lang="id-ID" dirty="0" err="1"/>
+              <a:t>php</a:t>
+            </a:r>
+            <a:r>
+              <a:rPr lang="id-ID" dirty="0"/>
+              <a:t> artisan </a:t>
+            </a:r>
+            <a:r>
+              <a:rPr lang="id-ID" dirty="0" err="1"/>
+              <a:t>reporting:link-principals</a:t>
+            </a:r>
+            <a:endParaRPr lang="id-ID" dirty="0"/>
+          </a:p>
+          <a:p>
+            <a:r>
+              <a:rPr lang="id-ID" dirty="0"/>
+              <a:t>/</a:t>
+            </a:r>
+            <a:r>
+              <a:rPr lang="id-ID" dirty="0" err="1"/>
+              <a:t>www</a:t>
+            </a:r>
+            <a:r>
+              <a:rPr lang="id-ID" dirty="0"/>
+              <a:t>/server/</a:t>
+            </a:r>
+            <a:r>
+              <a:rPr lang="id-ID" dirty="0" err="1"/>
+              <a:t>php</a:t>
+            </a:r>
+            <a:r>
+              <a:rPr lang="id-ID" dirty="0"/>
+              <a:t>/83/bin/</a:t>
+            </a:r>
+            <a:r>
+              <a:rPr lang="id-ID" dirty="0" err="1"/>
+              <a:t>php</a:t>
+            </a:r>
+            <a:r>
+              <a:rPr lang="id-ID" dirty="0"/>
+              <a:t> artisan </a:t>
+            </a:r>
+            <a:r>
+              <a:rPr lang="id-ID" dirty="0" err="1"/>
+              <a:t>optimize:clear</a:t>
+            </a:r>
+            <a:endParaRPr lang="id-ID" dirty="0"/>
+          </a:p>
+          <a:p>
+            <a:r>
+              <a:rPr lang="id-ID" dirty="0" err="1"/>
+              <a:t>systemctl</a:t>
+            </a:r>
+            <a:r>
+              <a:rPr lang="id-ID" dirty="0"/>
+              <a:t> </a:t>
+            </a:r>
+            <a:r>
+              <a:rPr lang="id-ID" dirty="0" err="1"/>
+              <a:t>reload</a:t>
+            </a:r>
+            <a:r>
+              <a:rPr lang="id-ID" dirty="0"/>
+              <a:t> php-fpm-83 2&gt;/</a:t>
+            </a:r>
+            <a:r>
+              <a:rPr lang="id-ID" dirty="0" err="1"/>
+              <a:t>dev</a:t>
+            </a:r>
+            <a:r>
+              <a:rPr lang="id-ID" dirty="0"/>
+              <a:t>/</a:t>
+            </a:r>
+            <a:r>
+              <a:rPr lang="id-ID" dirty="0" err="1"/>
+              <a:t>null</a:t>
+            </a:r>
+            <a:r>
+              <a:rPr lang="id-ID" dirty="0"/>
+              <a:t> || /</a:t>
+            </a:r>
+            <a:r>
+              <a:rPr lang="id-ID" dirty="0" err="1"/>
+              <a:t>etc</a:t>
+            </a:r>
+            <a:r>
+              <a:rPr lang="id-ID" dirty="0"/>
+              <a:t>/</a:t>
+            </a:r>
+            <a:r>
+              <a:rPr lang="id-ID" dirty="0" err="1"/>
+              <a:t>init.d</a:t>
+            </a:r>
+            <a:r>
+              <a:rPr lang="id-ID" dirty="0"/>
+              <a:t>/php-fpm-83 </a:t>
+            </a:r>
+            <a:r>
+              <a:rPr lang="id-ID" dirty="0" err="1"/>
+              <a:t>reload</a:t>
+            </a:r>
+            <a:r>
+              <a:rPr lang="id-ID" dirty="0"/>
+              <a:t> 2&gt;/</a:t>
+            </a:r>
+            <a:r>
+              <a:rPr lang="id-ID" dirty="0" err="1"/>
+              <a:t>dev</a:t>
+            </a:r>
+            <a:r>
+              <a:rPr lang="id-ID" dirty="0"/>
+              <a:t>/</a:t>
+            </a:r>
+            <a:r>
+              <a:rPr lang="id-ID" dirty="0" err="1"/>
+              <a:t>null</a:t>
+            </a:r>
+            <a:r>
+              <a:rPr lang="id-ID" dirty="0"/>
+              <a:t> || </a:t>
+            </a:r>
+            <a:r>
+              <a:rPr lang="id-ID" dirty="0" err="1"/>
+              <a:t>true</a:t>
+            </a:r>
+            <a:endParaRPr lang="id-ID" dirty="0"/>
+          </a:p>
+          <a:p>
+            <a:r>
+              <a:rPr lang="id-ID" dirty="0" err="1"/>
+              <a:t>rm</a:t>
+            </a:r>
+            <a:r>
+              <a:rPr lang="id-ID" dirty="0"/>
+              <a:t> -</a:t>
+            </a:r>
+            <a:r>
+              <a:rPr lang="id-ID" dirty="0" err="1"/>
+              <a:t>rf</a:t>
+            </a:r>
+            <a:r>
+              <a:rPr lang="id-ID" dirty="0"/>
+              <a:t> /</a:t>
+            </a:r>
+            <a:r>
+              <a:rPr lang="id-ID" dirty="0" err="1"/>
+              <a:t>root</a:t>
+            </a:r>
+            <a:r>
+              <a:rPr lang="id-ID" dirty="0"/>
+              <a:t>/</a:t>
+            </a:r>
+            <a:r>
+              <a:rPr lang="id-ID" dirty="0" err="1"/>
+              <a:t>att-repo-update</a:t>
+            </a:r>
+            <a:endParaRPr lang="id-ID" dirty="0"/>
+          </a:p>
+          <a:p>
+            <a:r>
+              <a:rPr lang="id-ID" dirty="0" err="1"/>
+              <a:t>echo</a:t>
+            </a:r>
+            <a:r>
+              <a:rPr lang="id-ID" dirty="0"/>
+              <a:t> "✅ SERVER 1 (AMK) SELESAI DIPERBARUI!"</a:t>
+            </a:r>
+          </a:p>
+        </p:txBody>
+      </p:sp>
+      <p:sp>
+        <p:nvSpPr>
+          <p:cNvPr id="3" name="TextBox 2">
+            <a:extLst>
+              <a:ext uri="{FF2B5EF4-FFF2-40B4-BE49-F238E27FC236}">
+                <a16:creationId xmlns:a16="http://schemas.microsoft.com/office/drawing/2014/main" id="{8E378915-9CF6-6181-4BFC-4F080896ECC4}"/>
+              </a:ext>
+            </a:extLst>
+          </p:cNvPr>
+          <p:cNvSpPr txBox="1"/>
+          <p:nvPr/>
+        </p:nvSpPr>
+        <p:spPr>
+          <a:xfrm>
+            <a:off x="314036" y="4082473"/>
+            <a:ext cx="11599650" cy="3693319"/>
+          </a:xfrm>
+          <a:prstGeom prst="rect">
+            <a:avLst/>
+          </a:prstGeom>
+          <a:noFill/>
+        </p:spPr>
+        <p:txBody>
+          <a:bodyPr wrap="none" rtlCol="0">
+            <a:spAutoFit/>
+          </a:bodyPr>
+          <a:lstStyle/>
+          <a:p>
+            <a:r>
+              <a:rPr lang="id-ID" dirty="0"/>
+              <a:t>cd /</a:t>
+            </a:r>
+            <a:r>
+              <a:rPr lang="id-ID" dirty="0" err="1"/>
+              <a:t>root</a:t>
+            </a:r>
+            <a:r>
+              <a:rPr lang="id-ID" dirty="0"/>
+              <a:t> &amp;&amp; </a:t>
+            </a:r>
+            <a:r>
+              <a:rPr lang="id-ID" dirty="0" err="1"/>
+              <a:t>rm</a:t>
+            </a:r>
+            <a:r>
+              <a:rPr lang="id-ID" dirty="0"/>
+              <a:t> -</a:t>
+            </a:r>
+            <a:r>
+              <a:rPr lang="id-ID" dirty="0" err="1"/>
+              <a:t>rf</a:t>
+            </a:r>
+            <a:r>
+              <a:rPr lang="id-ID" dirty="0"/>
+              <a:t> </a:t>
+            </a:r>
+            <a:r>
+              <a:rPr lang="id-ID" dirty="0" err="1"/>
+              <a:t>att-repo-update</a:t>
+            </a:r>
+            <a:r>
+              <a:rPr lang="id-ID" dirty="0"/>
+              <a:t> &amp;&amp; </a:t>
+            </a:r>
+            <a:r>
+              <a:rPr lang="id-ID" dirty="0" err="1"/>
+              <a:t>git</a:t>
+            </a:r>
+            <a:r>
+              <a:rPr lang="id-ID" dirty="0"/>
+              <a:t> </a:t>
+            </a:r>
+            <a:r>
+              <a:rPr lang="id-ID" dirty="0" err="1"/>
+              <a:t>clone</a:t>
+            </a:r>
+            <a:r>
+              <a:rPr lang="id-ID" dirty="0"/>
+              <a:t> https://github.com/digitalgalery-dgsoft/attendaceesa.git </a:t>
+            </a:r>
+            <a:r>
+              <a:rPr lang="id-ID" dirty="0" err="1"/>
+              <a:t>att-repo-update</a:t>
+            </a:r>
+            <a:endParaRPr lang="id-ID" dirty="0"/>
+          </a:p>
+          <a:p>
+            <a:r>
+              <a:rPr lang="id-ID" dirty="0"/>
+              <a:t>\</a:t>
+            </a:r>
+            <a:r>
+              <a:rPr lang="id-ID" dirty="0" err="1"/>
+              <a:t>cp</a:t>
+            </a:r>
+            <a:r>
+              <a:rPr lang="id-ID" dirty="0"/>
+              <a:t> -</a:t>
+            </a:r>
+            <a:r>
+              <a:rPr lang="id-ID" dirty="0" err="1"/>
+              <a:t>rf</a:t>
+            </a:r>
+            <a:r>
+              <a:rPr lang="id-ID" dirty="0"/>
+              <a:t> /</a:t>
+            </a:r>
+            <a:r>
+              <a:rPr lang="id-ID" dirty="0" err="1"/>
+              <a:t>root</a:t>
+            </a:r>
+            <a:r>
+              <a:rPr lang="id-ID" dirty="0"/>
+              <a:t>/</a:t>
+            </a:r>
+            <a:r>
+              <a:rPr lang="id-ID" dirty="0" err="1"/>
+              <a:t>att-repo-update</a:t>
+            </a:r>
+            <a:r>
+              <a:rPr lang="id-ID" dirty="0"/>
+              <a:t>/att-admin-v12/. /</a:t>
+            </a:r>
+            <a:r>
+              <a:rPr lang="id-ID" dirty="0" err="1"/>
+              <a:t>www</a:t>
+            </a:r>
+            <a:r>
+              <a:rPr lang="id-ID" dirty="0"/>
+              <a:t>/</a:t>
+            </a:r>
+            <a:r>
+              <a:rPr lang="id-ID" dirty="0" err="1"/>
+              <a:t>wwwroot</a:t>
+            </a:r>
+            <a:r>
+              <a:rPr lang="id-ID" dirty="0"/>
+              <a:t>/akp.dgsoft.web.id/</a:t>
+            </a:r>
+          </a:p>
+          <a:p>
+            <a:r>
+              <a:rPr lang="id-ID" dirty="0"/>
+              <a:t>cd /www/wwwroot/akp.dgsoft.web.id</a:t>
+            </a:r>
+          </a:p>
+          <a:p>
+            <a:r>
+              <a:rPr lang="id-ID" dirty="0"/>
+              <a:t>/</a:t>
+            </a:r>
+            <a:r>
+              <a:rPr lang="id-ID" dirty="0" err="1"/>
+              <a:t>www</a:t>
+            </a:r>
+            <a:r>
+              <a:rPr lang="id-ID" dirty="0"/>
+              <a:t>/server/</a:t>
+            </a:r>
+            <a:r>
+              <a:rPr lang="id-ID" dirty="0" err="1"/>
+              <a:t>php</a:t>
+            </a:r>
+            <a:r>
+              <a:rPr lang="id-ID" dirty="0"/>
+              <a:t>/83/bin/</a:t>
+            </a:r>
+            <a:r>
+              <a:rPr lang="id-ID" dirty="0" err="1"/>
+              <a:t>php</a:t>
+            </a:r>
+            <a:r>
+              <a:rPr lang="id-ID" dirty="0"/>
+              <a:t> artisan </a:t>
+            </a:r>
+            <a:r>
+              <a:rPr lang="id-ID" dirty="0" err="1"/>
+              <a:t>storage:link</a:t>
+            </a:r>
+            <a:r>
+              <a:rPr lang="id-ID" dirty="0"/>
+              <a:t> 2&gt;/</a:t>
+            </a:r>
+            <a:r>
+              <a:rPr lang="id-ID" dirty="0" err="1"/>
+              <a:t>dev</a:t>
+            </a:r>
+            <a:r>
+              <a:rPr lang="id-ID" dirty="0"/>
+              <a:t>/</a:t>
+            </a:r>
+            <a:r>
+              <a:rPr lang="id-ID" dirty="0" err="1"/>
+              <a:t>null</a:t>
+            </a:r>
+            <a:r>
+              <a:rPr lang="id-ID" dirty="0"/>
+              <a:t> || </a:t>
+            </a:r>
+            <a:r>
+              <a:rPr lang="id-ID" dirty="0" err="1"/>
+              <a:t>true</a:t>
+            </a:r>
+            <a:endParaRPr lang="id-ID" dirty="0"/>
+          </a:p>
+          <a:p>
+            <a:r>
+              <a:rPr lang="id-ID" dirty="0"/>
+              <a:t>/</a:t>
+            </a:r>
+            <a:r>
+              <a:rPr lang="id-ID" dirty="0" err="1"/>
+              <a:t>www</a:t>
+            </a:r>
+            <a:r>
+              <a:rPr lang="id-ID" dirty="0"/>
+              <a:t>/server/</a:t>
+            </a:r>
+            <a:r>
+              <a:rPr lang="id-ID" dirty="0" err="1"/>
+              <a:t>php</a:t>
+            </a:r>
+            <a:r>
+              <a:rPr lang="id-ID" dirty="0"/>
+              <a:t>/83/bin/</a:t>
+            </a:r>
+            <a:r>
+              <a:rPr lang="id-ID" dirty="0" err="1"/>
+              <a:t>php</a:t>
+            </a:r>
+            <a:r>
+              <a:rPr lang="id-ID" dirty="0"/>
+              <a:t> artisan </a:t>
+            </a:r>
+            <a:r>
+              <a:rPr lang="id-ID" dirty="0" err="1"/>
+              <a:t>livewire:publish</a:t>
+            </a:r>
+            <a:r>
+              <a:rPr lang="id-ID" dirty="0"/>
+              <a:t> --</a:t>
+            </a:r>
+            <a:r>
+              <a:rPr lang="id-ID" dirty="0" err="1"/>
+              <a:t>assets</a:t>
+            </a:r>
+            <a:r>
+              <a:rPr lang="id-ID" dirty="0"/>
+              <a:t> 2&gt;/</a:t>
+            </a:r>
+            <a:r>
+              <a:rPr lang="id-ID" dirty="0" err="1"/>
+              <a:t>dev</a:t>
+            </a:r>
+            <a:r>
+              <a:rPr lang="id-ID" dirty="0"/>
+              <a:t>/</a:t>
+            </a:r>
+            <a:r>
+              <a:rPr lang="id-ID" dirty="0" err="1"/>
+              <a:t>null</a:t>
+            </a:r>
+            <a:r>
+              <a:rPr lang="id-ID" dirty="0"/>
+              <a:t> || </a:t>
+            </a:r>
+            <a:r>
+              <a:rPr lang="id-ID" dirty="0" err="1"/>
+              <a:t>true</a:t>
+            </a:r>
+            <a:endParaRPr lang="id-ID" dirty="0"/>
+          </a:p>
+          <a:p>
+            <a:r>
+              <a:rPr lang="id-ID" dirty="0" err="1"/>
+              <a:t>mkdir</a:t>
+            </a:r>
+            <a:r>
+              <a:rPr lang="id-ID" dirty="0"/>
+              <a:t> -p </a:t>
+            </a:r>
+            <a:r>
+              <a:rPr lang="id-ID" dirty="0" err="1"/>
+              <a:t>public</a:t>
+            </a:r>
+            <a:r>
+              <a:rPr lang="id-ID" dirty="0"/>
+              <a:t>/</a:t>
+            </a:r>
+            <a:r>
+              <a:rPr lang="id-ID" dirty="0" err="1"/>
+              <a:t>livewire</a:t>
+            </a:r>
+            <a:r>
+              <a:rPr lang="id-ID" dirty="0"/>
+              <a:t> &amp;&amp; \</a:t>
+            </a:r>
+            <a:r>
+              <a:rPr lang="id-ID" dirty="0" err="1"/>
+              <a:t>cp</a:t>
+            </a:r>
+            <a:r>
+              <a:rPr lang="id-ID" dirty="0"/>
+              <a:t> -</a:t>
+            </a:r>
+            <a:r>
+              <a:rPr lang="id-ID" dirty="0" err="1"/>
+              <a:t>rf</a:t>
+            </a:r>
+            <a:r>
+              <a:rPr lang="id-ID" dirty="0"/>
+              <a:t> vendor/</a:t>
+            </a:r>
+            <a:r>
+              <a:rPr lang="id-ID" dirty="0" err="1"/>
+              <a:t>livewire</a:t>
+            </a:r>
+            <a:r>
+              <a:rPr lang="id-ID" dirty="0"/>
+              <a:t>/</a:t>
+            </a:r>
+            <a:r>
+              <a:rPr lang="id-ID" dirty="0" err="1"/>
+              <a:t>livewire</a:t>
+            </a:r>
+            <a:r>
+              <a:rPr lang="id-ID" dirty="0"/>
+              <a:t>/</a:t>
+            </a:r>
+            <a:r>
+              <a:rPr lang="id-ID" dirty="0" err="1"/>
+              <a:t>dist</a:t>
+            </a:r>
+            <a:r>
+              <a:rPr lang="id-ID" dirty="0"/>
+              <a:t>/* </a:t>
+            </a:r>
+            <a:r>
+              <a:rPr lang="id-ID" dirty="0" err="1"/>
+              <a:t>public</a:t>
+            </a:r>
+            <a:r>
+              <a:rPr lang="id-ID" dirty="0"/>
+              <a:t>/</a:t>
+            </a:r>
+            <a:r>
+              <a:rPr lang="id-ID" dirty="0" err="1"/>
+              <a:t>livewire</a:t>
+            </a:r>
+            <a:r>
+              <a:rPr lang="id-ID" dirty="0"/>
+              <a:t>/ 2&gt;/</a:t>
+            </a:r>
+            <a:r>
+              <a:rPr lang="id-ID" dirty="0" err="1"/>
+              <a:t>dev</a:t>
+            </a:r>
+            <a:r>
+              <a:rPr lang="id-ID" dirty="0"/>
+              <a:t>/</a:t>
+            </a:r>
+            <a:r>
+              <a:rPr lang="id-ID" dirty="0" err="1"/>
+              <a:t>null</a:t>
+            </a:r>
+            <a:r>
+              <a:rPr lang="id-ID" dirty="0"/>
+              <a:t> || </a:t>
+            </a:r>
+            <a:r>
+              <a:rPr lang="id-ID" dirty="0" err="1"/>
+              <a:t>true</a:t>
+            </a:r>
+            <a:endParaRPr lang="id-ID" dirty="0"/>
+          </a:p>
+          <a:p>
+            <a:r>
+              <a:rPr lang="id-ID" dirty="0" err="1"/>
+              <a:t>rm</a:t>
+            </a:r>
+            <a:r>
+              <a:rPr lang="id-ID" dirty="0"/>
+              <a:t> -f </a:t>
+            </a:r>
+            <a:r>
+              <a:rPr lang="id-ID" dirty="0" err="1"/>
+              <a:t>public</a:t>
+            </a:r>
+            <a:r>
+              <a:rPr lang="id-ID" dirty="0"/>
+              <a:t>/hot</a:t>
+            </a:r>
+          </a:p>
+          <a:p>
+            <a:r>
+              <a:rPr lang="id-ID" dirty="0"/>
+              <a:t>/</a:t>
+            </a:r>
+            <a:r>
+              <a:rPr lang="id-ID" dirty="0" err="1"/>
+              <a:t>www</a:t>
+            </a:r>
+            <a:r>
+              <a:rPr lang="id-ID" dirty="0"/>
+              <a:t>/server/</a:t>
+            </a:r>
+            <a:r>
+              <a:rPr lang="id-ID" dirty="0" err="1"/>
+              <a:t>php</a:t>
+            </a:r>
+            <a:r>
+              <a:rPr lang="id-ID" dirty="0"/>
+              <a:t>/83/bin/</a:t>
+            </a:r>
+            <a:r>
+              <a:rPr lang="id-ID" dirty="0" err="1"/>
+              <a:t>php</a:t>
+            </a:r>
+            <a:r>
+              <a:rPr lang="id-ID" dirty="0"/>
+              <a:t> artisan </a:t>
+            </a:r>
+            <a:r>
+              <a:rPr lang="id-ID" dirty="0" err="1"/>
+              <a:t>reporting:link-principals</a:t>
+            </a:r>
+            <a:endParaRPr lang="id-ID" dirty="0"/>
+          </a:p>
+          <a:p>
+            <a:r>
+              <a:rPr lang="id-ID" dirty="0"/>
+              <a:t>/</a:t>
+            </a:r>
+            <a:r>
+              <a:rPr lang="id-ID" dirty="0" err="1"/>
+              <a:t>www</a:t>
+            </a:r>
+            <a:r>
+              <a:rPr lang="id-ID" dirty="0"/>
+              <a:t>/server/</a:t>
+            </a:r>
+            <a:r>
+              <a:rPr lang="id-ID" dirty="0" err="1"/>
+              <a:t>php</a:t>
+            </a:r>
+            <a:r>
+              <a:rPr lang="id-ID" dirty="0"/>
+              <a:t>/83/bin/</a:t>
+            </a:r>
+            <a:r>
+              <a:rPr lang="id-ID" dirty="0" err="1"/>
+              <a:t>php</a:t>
+            </a:r>
+            <a:r>
+              <a:rPr lang="id-ID" dirty="0"/>
+              <a:t> artisan </a:t>
+            </a:r>
+            <a:r>
+              <a:rPr lang="id-ID" dirty="0" err="1"/>
+              <a:t>optimize:clear</a:t>
+            </a:r>
+            <a:endParaRPr lang="id-ID" dirty="0"/>
+          </a:p>
+          <a:p>
+            <a:r>
+              <a:rPr lang="id-ID" dirty="0" err="1"/>
+              <a:t>systemctl</a:t>
+            </a:r>
+            <a:r>
+              <a:rPr lang="id-ID" dirty="0"/>
+              <a:t> </a:t>
+            </a:r>
+            <a:r>
+              <a:rPr lang="id-ID" dirty="0" err="1"/>
+              <a:t>reload</a:t>
+            </a:r>
+            <a:r>
+              <a:rPr lang="id-ID" dirty="0"/>
+              <a:t> php-fpm-83 2&gt;/</a:t>
+            </a:r>
+            <a:r>
+              <a:rPr lang="id-ID" dirty="0" err="1"/>
+              <a:t>dev</a:t>
+            </a:r>
+            <a:r>
+              <a:rPr lang="id-ID" dirty="0"/>
+              <a:t>/</a:t>
+            </a:r>
+            <a:r>
+              <a:rPr lang="id-ID" dirty="0" err="1"/>
+              <a:t>null</a:t>
+            </a:r>
+            <a:r>
+              <a:rPr lang="id-ID" dirty="0"/>
+              <a:t> || /</a:t>
+            </a:r>
+            <a:r>
+              <a:rPr lang="id-ID" dirty="0" err="1"/>
+              <a:t>etc</a:t>
+            </a:r>
+            <a:r>
+              <a:rPr lang="id-ID" dirty="0"/>
+              <a:t>/</a:t>
+            </a:r>
+            <a:r>
+              <a:rPr lang="id-ID" dirty="0" err="1"/>
+              <a:t>init.d</a:t>
+            </a:r>
+            <a:r>
+              <a:rPr lang="id-ID" dirty="0"/>
+              <a:t>/php-fpm-83 </a:t>
+            </a:r>
+            <a:r>
+              <a:rPr lang="id-ID" dirty="0" err="1"/>
+              <a:t>reload</a:t>
+            </a:r>
+            <a:r>
+              <a:rPr lang="id-ID" dirty="0"/>
+              <a:t> 2&gt;/</a:t>
+            </a:r>
+            <a:r>
+              <a:rPr lang="id-ID" dirty="0" err="1"/>
+              <a:t>dev</a:t>
+            </a:r>
+            <a:r>
+              <a:rPr lang="id-ID" dirty="0"/>
+              <a:t>/</a:t>
+            </a:r>
+            <a:r>
+              <a:rPr lang="id-ID" dirty="0" err="1"/>
+              <a:t>null</a:t>
+            </a:r>
+            <a:r>
+              <a:rPr lang="id-ID" dirty="0"/>
+              <a:t> || </a:t>
+            </a:r>
+            <a:r>
+              <a:rPr lang="id-ID" dirty="0" err="1"/>
+              <a:t>true</a:t>
+            </a:r>
+            <a:endParaRPr lang="id-ID" dirty="0"/>
+          </a:p>
+          <a:p>
+            <a:r>
+              <a:rPr lang="id-ID" dirty="0" err="1"/>
+              <a:t>rm</a:t>
+            </a:r>
+            <a:r>
+              <a:rPr lang="id-ID" dirty="0"/>
+              <a:t> -</a:t>
+            </a:r>
+            <a:r>
+              <a:rPr lang="id-ID" dirty="0" err="1"/>
+              <a:t>rf</a:t>
+            </a:r>
+            <a:r>
+              <a:rPr lang="id-ID" dirty="0"/>
+              <a:t> /</a:t>
+            </a:r>
+            <a:r>
+              <a:rPr lang="id-ID" dirty="0" err="1"/>
+              <a:t>root</a:t>
+            </a:r>
+            <a:r>
+              <a:rPr lang="id-ID" dirty="0"/>
+              <a:t>/</a:t>
+            </a:r>
+            <a:r>
+              <a:rPr lang="id-ID" dirty="0" err="1"/>
+              <a:t>att-repo-update</a:t>
+            </a:r>
+            <a:endParaRPr lang="id-ID" dirty="0"/>
+          </a:p>
+          <a:p>
+            <a:r>
+              <a:rPr lang="id-ID" dirty="0" err="1"/>
+              <a:t>echo</a:t>
+            </a:r>
+            <a:r>
+              <a:rPr lang="id-ID" dirty="0"/>
+              <a:t> "✅ SERVER 2 (AKP) SELESAI DIPERBARUI!"</a:t>
+            </a:r>
+          </a:p>
+          <a:p>
+            <a:endParaRPr lang="id-ID" dirty="0"/>
+          </a:p>
+        </p:txBody>
+      </p:sp>
+    </p:spTree>
+    <p:extLst>
+      <p:ext uri="{BB962C8B-B14F-4D97-AF65-F5344CB8AC3E}">
+        <p14:creationId xmlns:p14="http://schemas.microsoft.com/office/powerpoint/2010/main" val="262421517"/>
+      </p:ext>
+    </p:extLst>
+  </p:cSld>
+  <p:clrMapOvr>
+    <a:masterClrMapping/>
+  </p:clrMapOvr>
+</p:sld>
+</file>
+
+<file path=ppt/slides/slide15.xml><?xml version="1.0" encoding="utf-8"?>
+<p:sld xmlns:a="http://schemas.openxmlformats.org/drawingml/2006/main" xmlns:r="http://schemas.openxmlformats.org/officeDocument/2006/relationships" xmlns:p="http://schemas.openxmlformats.org/presentationml/2006/main">
+  <p:cSld>
+    <p:spTree>
+      <p:nvGrpSpPr>
+        <p:cNvPr id="1" name="">
+          <a:extLst>
+            <a:ext uri="{FF2B5EF4-FFF2-40B4-BE49-F238E27FC236}">
+              <a16:creationId xmlns:a16="http://schemas.microsoft.com/office/drawing/2014/main" id="{1C75FBE5-1D10-05DA-B65D-3BBB97BCD313}"/>
+            </a:ext>
+          </a:extLst>
+        </p:cNvPr>
+        <p:cNvGrpSpPr/>
+        <p:nvPr/>
+      </p:nvGrpSpPr>
+      <p:grpSpPr>
+        <a:xfrm>
+          <a:off x="0" y="0"/>
+          <a:ext cx="0" cy="0"/>
+          <a:chOff x="0" y="0"/>
+          <a:chExt cx="0" cy="0"/>
+        </a:xfrm>
+      </p:grpSpPr>
+      <p:sp>
+        <p:nvSpPr>
+          <p:cNvPr id="3" name="TextBox 2">
+            <a:extLst>
+              <a:ext uri="{FF2B5EF4-FFF2-40B4-BE49-F238E27FC236}">
+                <a16:creationId xmlns:a16="http://schemas.microsoft.com/office/drawing/2014/main" id="{5EE406F8-1A42-7A8D-EEF9-B5FA7DA7B8AA}"/>
+              </a:ext>
+            </a:extLst>
+          </p:cNvPr>
+          <p:cNvSpPr txBox="1"/>
+          <p:nvPr/>
+        </p:nvSpPr>
+        <p:spPr>
+          <a:xfrm>
+            <a:off x="296175" y="332510"/>
+            <a:ext cx="11599650" cy="3693319"/>
+          </a:xfrm>
+          <a:prstGeom prst="rect">
+            <a:avLst/>
+          </a:prstGeom>
+          <a:noFill/>
+        </p:spPr>
+        <p:txBody>
+          <a:bodyPr wrap="none" rtlCol="0">
+            <a:spAutoFit/>
+          </a:bodyPr>
+          <a:lstStyle/>
+          <a:p>
+            <a:r>
+              <a:rPr lang="id-ID" dirty="0"/>
+              <a:t>cd /</a:t>
+            </a:r>
+            <a:r>
+              <a:rPr lang="id-ID" dirty="0" err="1"/>
+              <a:t>root</a:t>
+            </a:r>
+            <a:r>
+              <a:rPr lang="id-ID" dirty="0"/>
+              <a:t> &amp;&amp; </a:t>
+            </a:r>
+            <a:r>
+              <a:rPr lang="id-ID" dirty="0" err="1"/>
+              <a:t>rm</a:t>
+            </a:r>
+            <a:r>
+              <a:rPr lang="id-ID" dirty="0"/>
+              <a:t> -</a:t>
+            </a:r>
+            <a:r>
+              <a:rPr lang="id-ID" dirty="0" err="1"/>
+              <a:t>rf</a:t>
+            </a:r>
+            <a:r>
+              <a:rPr lang="id-ID" dirty="0"/>
+              <a:t> </a:t>
+            </a:r>
+            <a:r>
+              <a:rPr lang="id-ID" dirty="0" err="1"/>
+              <a:t>att-repo-update</a:t>
+            </a:r>
+            <a:r>
+              <a:rPr lang="id-ID" dirty="0"/>
+              <a:t> &amp;&amp; </a:t>
+            </a:r>
+            <a:r>
+              <a:rPr lang="id-ID" dirty="0" err="1"/>
+              <a:t>git</a:t>
+            </a:r>
+            <a:r>
+              <a:rPr lang="id-ID" dirty="0"/>
+              <a:t> </a:t>
+            </a:r>
+            <a:r>
+              <a:rPr lang="id-ID" dirty="0" err="1"/>
+              <a:t>clone</a:t>
+            </a:r>
+            <a:r>
+              <a:rPr lang="id-ID" dirty="0"/>
+              <a:t> https://github.com/digitalgalery-dgsoft/attendaceesa.git </a:t>
+            </a:r>
+            <a:r>
+              <a:rPr lang="id-ID" dirty="0" err="1"/>
+              <a:t>att-repo-update</a:t>
+            </a:r>
+            <a:endParaRPr lang="id-ID" dirty="0"/>
+          </a:p>
+          <a:p>
+            <a:r>
+              <a:rPr lang="id-ID" dirty="0"/>
+              <a:t>\</a:t>
+            </a:r>
+            <a:r>
+              <a:rPr lang="id-ID" dirty="0" err="1"/>
+              <a:t>cp</a:t>
+            </a:r>
+            <a:r>
+              <a:rPr lang="id-ID" dirty="0"/>
+              <a:t> -</a:t>
+            </a:r>
+            <a:r>
+              <a:rPr lang="id-ID" dirty="0" err="1"/>
+              <a:t>rf</a:t>
+            </a:r>
+            <a:r>
+              <a:rPr lang="id-ID" dirty="0"/>
+              <a:t> /</a:t>
+            </a:r>
+            <a:r>
+              <a:rPr lang="id-ID" dirty="0" err="1"/>
+              <a:t>root</a:t>
+            </a:r>
+            <a:r>
+              <a:rPr lang="id-ID" dirty="0"/>
+              <a:t>/</a:t>
+            </a:r>
+            <a:r>
+              <a:rPr lang="id-ID" dirty="0" err="1"/>
+              <a:t>att-repo-update</a:t>
+            </a:r>
+            <a:r>
+              <a:rPr lang="id-ID" dirty="0"/>
+              <a:t>/att-admin-v12/. /</a:t>
+            </a:r>
+            <a:r>
+              <a:rPr lang="id-ID" dirty="0" err="1"/>
+              <a:t>www</a:t>
+            </a:r>
+            <a:r>
+              <a:rPr lang="id-ID" dirty="0"/>
+              <a:t>/</a:t>
+            </a:r>
+            <a:r>
+              <a:rPr lang="id-ID" dirty="0" err="1"/>
+              <a:t>wwwroot</a:t>
+            </a:r>
+            <a:r>
+              <a:rPr lang="id-ID" dirty="0"/>
+              <a:t>/akp.dgsoft.web.id/</a:t>
+            </a:r>
+          </a:p>
+          <a:p>
+            <a:r>
+              <a:rPr lang="id-ID" dirty="0"/>
+              <a:t>cd /www/wwwroot/akp.dgsoft.web.id</a:t>
+            </a:r>
+          </a:p>
+          <a:p>
+            <a:r>
+              <a:rPr lang="id-ID" dirty="0"/>
+              <a:t>/</a:t>
+            </a:r>
+            <a:r>
+              <a:rPr lang="id-ID" dirty="0" err="1"/>
+              <a:t>www</a:t>
+            </a:r>
+            <a:r>
+              <a:rPr lang="id-ID" dirty="0"/>
+              <a:t>/server/</a:t>
+            </a:r>
+            <a:r>
+              <a:rPr lang="id-ID" dirty="0" err="1"/>
+              <a:t>php</a:t>
+            </a:r>
+            <a:r>
+              <a:rPr lang="id-ID" dirty="0"/>
+              <a:t>/83/bin/</a:t>
+            </a:r>
+            <a:r>
+              <a:rPr lang="id-ID" dirty="0" err="1"/>
+              <a:t>php</a:t>
+            </a:r>
+            <a:r>
+              <a:rPr lang="id-ID" dirty="0"/>
+              <a:t> artisan </a:t>
+            </a:r>
+            <a:r>
+              <a:rPr lang="id-ID" dirty="0" err="1"/>
+              <a:t>storage:link</a:t>
+            </a:r>
+            <a:r>
+              <a:rPr lang="id-ID" dirty="0"/>
+              <a:t> 2&gt;/</a:t>
+            </a:r>
+            <a:r>
+              <a:rPr lang="id-ID" dirty="0" err="1"/>
+              <a:t>dev</a:t>
+            </a:r>
+            <a:r>
+              <a:rPr lang="id-ID" dirty="0"/>
+              <a:t>/</a:t>
+            </a:r>
+            <a:r>
+              <a:rPr lang="id-ID" dirty="0" err="1"/>
+              <a:t>null</a:t>
+            </a:r>
+            <a:r>
+              <a:rPr lang="id-ID" dirty="0"/>
+              <a:t> || </a:t>
+            </a:r>
+            <a:r>
+              <a:rPr lang="id-ID" dirty="0" err="1"/>
+              <a:t>true</a:t>
+            </a:r>
+            <a:endParaRPr lang="id-ID" dirty="0"/>
+          </a:p>
+          <a:p>
+            <a:r>
+              <a:rPr lang="id-ID" dirty="0"/>
+              <a:t>/</a:t>
+            </a:r>
+            <a:r>
+              <a:rPr lang="id-ID" dirty="0" err="1"/>
+              <a:t>www</a:t>
+            </a:r>
+            <a:r>
+              <a:rPr lang="id-ID" dirty="0"/>
+              <a:t>/server/</a:t>
+            </a:r>
+            <a:r>
+              <a:rPr lang="id-ID" dirty="0" err="1"/>
+              <a:t>php</a:t>
+            </a:r>
+            <a:r>
+              <a:rPr lang="id-ID" dirty="0"/>
+              <a:t>/83/bin/</a:t>
+            </a:r>
+            <a:r>
+              <a:rPr lang="id-ID" dirty="0" err="1"/>
+              <a:t>php</a:t>
+            </a:r>
+            <a:r>
+              <a:rPr lang="id-ID" dirty="0"/>
+              <a:t> artisan </a:t>
+            </a:r>
+            <a:r>
+              <a:rPr lang="id-ID" dirty="0" err="1"/>
+              <a:t>livewire:publish</a:t>
+            </a:r>
+            <a:r>
+              <a:rPr lang="id-ID" dirty="0"/>
+              <a:t> --</a:t>
+            </a:r>
+            <a:r>
+              <a:rPr lang="id-ID" dirty="0" err="1"/>
+              <a:t>assets</a:t>
+            </a:r>
+            <a:r>
+              <a:rPr lang="id-ID" dirty="0"/>
+              <a:t> 2&gt;/</a:t>
+            </a:r>
+            <a:r>
+              <a:rPr lang="id-ID" dirty="0" err="1"/>
+              <a:t>dev</a:t>
+            </a:r>
+            <a:r>
+              <a:rPr lang="id-ID" dirty="0"/>
+              <a:t>/</a:t>
+            </a:r>
+            <a:r>
+              <a:rPr lang="id-ID" dirty="0" err="1"/>
+              <a:t>null</a:t>
+            </a:r>
+            <a:r>
+              <a:rPr lang="id-ID" dirty="0"/>
+              <a:t> || </a:t>
+            </a:r>
+            <a:r>
+              <a:rPr lang="id-ID" dirty="0" err="1"/>
+              <a:t>true</a:t>
+            </a:r>
+            <a:endParaRPr lang="id-ID" dirty="0"/>
+          </a:p>
+          <a:p>
+            <a:r>
+              <a:rPr lang="id-ID" dirty="0" err="1"/>
+              <a:t>mkdir</a:t>
+            </a:r>
+            <a:r>
+              <a:rPr lang="id-ID" dirty="0"/>
+              <a:t> -p </a:t>
+            </a:r>
+            <a:r>
+              <a:rPr lang="id-ID" dirty="0" err="1"/>
+              <a:t>public</a:t>
+            </a:r>
+            <a:r>
+              <a:rPr lang="id-ID" dirty="0"/>
+              <a:t>/</a:t>
+            </a:r>
+            <a:r>
+              <a:rPr lang="id-ID" dirty="0" err="1"/>
+              <a:t>livewire</a:t>
+            </a:r>
+            <a:r>
+              <a:rPr lang="id-ID" dirty="0"/>
+              <a:t> &amp;&amp; \</a:t>
+            </a:r>
+            <a:r>
+              <a:rPr lang="id-ID" dirty="0" err="1"/>
+              <a:t>cp</a:t>
+            </a:r>
+            <a:r>
+              <a:rPr lang="id-ID" dirty="0"/>
+              <a:t> -</a:t>
+            </a:r>
+            <a:r>
+              <a:rPr lang="id-ID" dirty="0" err="1"/>
+              <a:t>rf</a:t>
+            </a:r>
+            <a:r>
+              <a:rPr lang="id-ID" dirty="0"/>
+              <a:t> vendor/</a:t>
+            </a:r>
+            <a:r>
+              <a:rPr lang="id-ID" dirty="0" err="1"/>
+              <a:t>livewire</a:t>
+            </a:r>
+            <a:r>
+              <a:rPr lang="id-ID" dirty="0"/>
+              <a:t>/</a:t>
+            </a:r>
+            <a:r>
+              <a:rPr lang="id-ID" dirty="0" err="1"/>
+              <a:t>livewire</a:t>
+            </a:r>
+            <a:r>
+              <a:rPr lang="id-ID" dirty="0"/>
+              <a:t>/</a:t>
+            </a:r>
+            <a:r>
+              <a:rPr lang="id-ID" dirty="0" err="1"/>
+              <a:t>dist</a:t>
+            </a:r>
+            <a:r>
+              <a:rPr lang="id-ID" dirty="0"/>
+              <a:t>/* </a:t>
+            </a:r>
+            <a:r>
+              <a:rPr lang="id-ID" dirty="0" err="1"/>
+              <a:t>public</a:t>
+            </a:r>
+            <a:r>
+              <a:rPr lang="id-ID" dirty="0"/>
+              <a:t>/</a:t>
+            </a:r>
+            <a:r>
+              <a:rPr lang="id-ID" dirty="0" err="1"/>
+              <a:t>livewire</a:t>
+            </a:r>
+            <a:r>
+              <a:rPr lang="id-ID" dirty="0"/>
+              <a:t>/ 2&gt;/</a:t>
+            </a:r>
+            <a:r>
+              <a:rPr lang="id-ID" dirty="0" err="1"/>
+              <a:t>dev</a:t>
+            </a:r>
+            <a:r>
+              <a:rPr lang="id-ID" dirty="0"/>
+              <a:t>/</a:t>
+            </a:r>
+            <a:r>
+              <a:rPr lang="id-ID" dirty="0" err="1"/>
+              <a:t>null</a:t>
+            </a:r>
+            <a:r>
+              <a:rPr lang="id-ID" dirty="0"/>
+              <a:t> || </a:t>
+            </a:r>
+            <a:r>
+              <a:rPr lang="id-ID" dirty="0" err="1"/>
+              <a:t>true</a:t>
+            </a:r>
+            <a:endParaRPr lang="id-ID" dirty="0"/>
+          </a:p>
+          <a:p>
+            <a:r>
+              <a:rPr lang="id-ID" dirty="0" err="1"/>
+              <a:t>rm</a:t>
+            </a:r>
+            <a:r>
+              <a:rPr lang="id-ID" dirty="0"/>
+              <a:t> -f </a:t>
+            </a:r>
+            <a:r>
+              <a:rPr lang="id-ID" dirty="0" err="1"/>
+              <a:t>public</a:t>
+            </a:r>
+            <a:r>
+              <a:rPr lang="id-ID" dirty="0"/>
+              <a:t>/hot</a:t>
+            </a:r>
+          </a:p>
+          <a:p>
+            <a:r>
+              <a:rPr lang="id-ID" dirty="0"/>
+              <a:t>/</a:t>
+            </a:r>
+            <a:r>
+              <a:rPr lang="id-ID" dirty="0" err="1"/>
+              <a:t>www</a:t>
+            </a:r>
+            <a:r>
+              <a:rPr lang="id-ID" dirty="0"/>
+              <a:t>/server/</a:t>
+            </a:r>
+            <a:r>
+              <a:rPr lang="id-ID" dirty="0" err="1"/>
+              <a:t>php</a:t>
+            </a:r>
+            <a:r>
+              <a:rPr lang="id-ID" dirty="0"/>
+              <a:t>/83/bin/</a:t>
+            </a:r>
+            <a:r>
+              <a:rPr lang="id-ID" dirty="0" err="1"/>
+              <a:t>php</a:t>
+            </a:r>
+            <a:r>
+              <a:rPr lang="id-ID" dirty="0"/>
+              <a:t> artisan </a:t>
+            </a:r>
+            <a:r>
+              <a:rPr lang="id-ID" dirty="0" err="1"/>
+              <a:t>reporting:link-principals</a:t>
+            </a:r>
+            <a:endParaRPr lang="id-ID" dirty="0"/>
+          </a:p>
+          <a:p>
+            <a:r>
+              <a:rPr lang="id-ID" dirty="0"/>
+              <a:t>/</a:t>
+            </a:r>
+            <a:r>
+              <a:rPr lang="id-ID" dirty="0" err="1"/>
+              <a:t>www</a:t>
+            </a:r>
+            <a:r>
+              <a:rPr lang="id-ID" dirty="0"/>
+              <a:t>/server/</a:t>
+            </a:r>
+            <a:r>
+              <a:rPr lang="id-ID" dirty="0" err="1"/>
+              <a:t>php</a:t>
+            </a:r>
+            <a:r>
+              <a:rPr lang="id-ID" dirty="0"/>
+              <a:t>/83/bin/</a:t>
+            </a:r>
+            <a:r>
+              <a:rPr lang="id-ID" dirty="0" err="1"/>
+              <a:t>php</a:t>
+            </a:r>
+            <a:r>
+              <a:rPr lang="id-ID" dirty="0"/>
+              <a:t> artisan </a:t>
+            </a:r>
+            <a:r>
+              <a:rPr lang="id-ID" dirty="0" err="1"/>
+              <a:t>optimize:clear</a:t>
+            </a:r>
+            <a:endParaRPr lang="id-ID" dirty="0"/>
+          </a:p>
+          <a:p>
+            <a:r>
+              <a:rPr lang="id-ID" dirty="0" err="1"/>
+              <a:t>systemctl</a:t>
+            </a:r>
+            <a:r>
+              <a:rPr lang="id-ID" dirty="0"/>
+              <a:t> </a:t>
+            </a:r>
+            <a:r>
+              <a:rPr lang="id-ID" dirty="0" err="1"/>
+              <a:t>reload</a:t>
+            </a:r>
+            <a:r>
+              <a:rPr lang="id-ID" dirty="0"/>
+              <a:t> php-fpm-83 2&gt;/</a:t>
+            </a:r>
+            <a:r>
+              <a:rPr lang="id-ID" dirty="0" err="1"/>
+              <a:t>dev</a:t>
+            </a:r>
+            <a:r>
+              <a:rPr lang="id-ID" dirty="0"/>
+              <a:t>/</a:t>
+            </a:r>
+            <a:r>
+              <a:rPr lang="id-ID" dirty="0" err="1"/>
+              <a:t>null</a:t>
+            </a:r>
+            <a:r>
+              <a:rPr lang="id-ID" dirty="0"/>
+              <a:t> || /</a:t>
+            </a:r>
+            <a:r>
+              <a:rPr lang="id-ID" dirty="0" err="1"/>
+              <a:t>etc</a:t>
+            </a:r>
+            <a:r>
+              <a:rPr lang="id-ID" dirty="0"/>
+              <a:t>/</a:t>
+            </a:r>
+            <a:r>
+              <a:rPr lang="id-ID" dirty="0" err="1"/>
+              <a:t>init.d</a:t>
+            </a:r>
+            <a:r>
+              <a:rPr lang="id-ID" dirty="0"/>
+              <a:t>/php-fpm-83 </a:t>
+            </a:r>
+            <a:r>
+              <a:rPr lang="id-ID" dirty="0" err="1"/>
+              <a:t>reload</a:t>
+            </a:r>
+            <a:r>
+              <a:rPr lang="id-ID" dirty="0"/>
+              <a:t> 2&gt;/</a:t>
+            </a:r>
+            <a:r>
+              <a:rPr lang="id-ID" dirty="0" err="1"/>
+              <a:t>dev</a:t>
+            </a:r>
+            <a:r>
+              <a:rPr lang="id-ID" dirty="0"/>
+              <a:t>/</a:t>
+            </a:r>
+            <a:r>
+              <a:rPr lang="id-ID" dirty="0" err="1"/>
+              <a:t>null</a:t>
+            </a:r>
+            <a:r>
+              <a:rPr lang="id-ID" dirty="0"/>
+              <a:t> || </a:t>
+            </a:r>
+            <a:r>
+              <a:rPr lang="id-ID" dirty="0" err="1"/>
+              <a:t>true</a:t>
+            </a:r>
+            <a:endParaRPr lang="id-ID" dirty="0"/>
+          </a:p>
+          <a:p>
+            <a:r>
+              <a:rPr lang="id-ID" dirty="0" err="1"/>
+              <a:t>rm</a:t>
+            </a:r>
+            <a:r>
+              <a:rPr lang="id-ID" dirty="0"/>
+              <a:t> -</a:t>
+            </a:r>
+            <a:r>
+              <a:rPr lang="id-ID" dirty="0" err="1"/>
+              <a:t>rf</a:t>
+            </a:r>
+            <a:r>
+              <a:rPr lang="id-ID" dirty="0"/>
+              <a:t> /</a:t>
+            </a:r>
+            <a:r>
+              <a:rPr lang="id-ID" dirty="0" err="1"/>
+              <a:t>root</a:t>
+            </a:r>
+            <a:r>
+              <a:rPr lang="id-ID" dirty="0"/>
+              <a:t>/</a:t>
+            </a:r>
+            <a:r>
+              <a:rPr lang="id-ID" dirty="0" err="1"/>
+              <a:t>att-repo-update</a:t>
+            </a:r>
+            <a:endParaRPr lang="id-ID" dirty="0"/>
+          </a:p>
+          <a:p>
+            <a:r>
+              <a:rPr lang="id-ID" dirty="0" err="1"/>
+              <a:t>echo</a:t>
+            </a:r>
+            <a:r>
+              <a:rPr lang="id-ID" dirty="0"/>
+              <a:t> "✅ SERVER 2 (AKP) SELESAI DIPERBARUI!"</a:t>
+            </a:r>
+          </a:p>
+          <a:p>
+            <a:endParaRPr lang="id-ID" dirty="0"/>
+          </a:p>
+        </p:txBody>
+      </p:sp>
+    </p:spTree>
+    <p:extLst>
+      <p:ext uri="{BB962C8B-B14F-4D97-AF65-F5344CB8AC3E}">
+        <p14:creationId xmlns:p14="http://schemas.microsoft.com/office/powerpoint/2010/main" val="1802598741"/>
+      </p:ext>
+    </p:extLst>
+  </p:cSld>
+  <p:clrMapOvr>
+    <a:masterClrMapping/>
+  </p:clrMapOvr>
+</p:sld>
+</file>
+
+<file path=ppt/slides/slide16.xml><?xml version="1.0" encoding="utf-8"?>
+<p:sld xmlns:a="http://schemas.openxmlformats.org/drawingml/2006/main" xmlns:r="http://schemas.openxmlformats.org/officeDocument/2006/relationships" xmlns:p="http://schemas.openxmlformats.org/presentationml/2006/main">
+  <p:cSld>
+    <p:spTree>
+      <p:nvGrpSpPr>
+        <p:cNvPr id="1" name="">
+          <a:extLst>
+            <a:ext uri="{FF2B5EF4-FFF2-40B4-BE49-F238E27FC236}">
+              <a16:creationId xmlns:a16="http://schemas.microsoft.com/office/drawing/2014/main" id="{73E46DB1-AAFA-640A-5772-7352A7706770}"/>
+            </a:ext>
+          </a:extLst>
+        </p:cNvPr>
+        <p:cNvGrpSpPr/>
+        <p:nvPr/>
+      </p:nvGrpSpPr>
+      <p:grpSpPr>
+        <a:xfrm>
+          <a:off x="0" y="0"/>
+          <a:ext cx="0" cy="0"/>
+          <a:chOff x="0" y="0"/>
+          <a:chExt cx="0" cy="0"/>
+        </a:xfrm>
+      </p:grpSpPr>
+      <p:sp>
+        <p:nvSpPr>
+          <p:cNvPr id="3" name="TextBox 2">
+            <a:extLst>
+              <a:ext uri="{FF2B5EF4-FFF2-40B4-BE49-F238E27FC236}">
+                <a16:creationId xmlns:a16="http://schemas.microsoft.com/office/drawing/2014/main" id="{63D02CDB-2FFC-CD6C-CF5A-13794C463D4E}"/>
+              </a:ext>
+            </a:extLst>
+          </p:cNvPr>
+          <p:cNvSpPr txBox="1"/>
+          <p:nvPr/>
+        </p:nvSpPr>
+        <p:spPr>
+          <a:xfrm>
+            <a:off x="296175" y="332510"/>
+            <a:ext cx="11599650" cy="3416320"/>
+          </a:xfrm>
+          <a:prstGeom prst="rect">
+            <a:avLst/>
+          </a:prstGeom>
+          <a:noFill/>
+        </p:spPr>
+        <p:txBody>
+          <a:bodyPr wrap="none" rtlCol="0">
+            <a:spAutoFit/>
+          </a:bodyPr>
+          <a:lstStyle/>
+          <a:p>
+            <a:r>
+              <a:rPr lang="id-ID" dirty="0"/>
+              <a:t>cd /</a:t>
+            </a:r>
+            <a:r>
+              <a:rPr lang="id-ID" dirty="0" err="1"/>
+              <a:t>root</a:t>
+            </a:r>
+            <a:r>
+              <a:rPr lang="id-ID" dirty="0"/>
+              <a:t> &amp;&amp; </a:t>
+            </a:r>
+            <a:r>
+              <a:rPr lang="id-ID" dirty="0" err="1"/>
+              <a:t>rm</a:t>
+            </a:r>
+            <a:r>
+              <a:rPr lang="id-ID" dirty="0"/>
+              <a:t> -</a:t>
+            </a:r>
+            <a:r>
+              <a:rPr lang="id-ID" dirty="0" err="1"/>
+              <a:t>rf</a:t>
+            </a:r>
+            <a:r>
+              <a:rPr lang="id-ID" dirty="0"/>
+              <a:t> </a:t>
+            </a:r>
+            <a:r>
+              <a:rPr lang="id-ID" dirty="0" err="1"/>
+              <a:t>att-repo-update</a:t>
+            </a:r>
+            <a:r>
+              <a:rPr lang="id-ID" dirty="0"/>
+              <a:t> &amp;&amp; </a:t>
+            </a:r>
+            <a:r>
+              <a:rPr lang="id-ID" dirty="0" err="1"/>
+              <a:t>git</a:t>
+            </a:r>
+            <a:r>
+              <a:rPr lang="id-ID" dirty="0"/>
+              <a:t> </a:t>
+            </a:r>
+            <a:r>
+              <a:rPr lang="id-ID" dirty="0" err="1"/>
+              <a:t>clone</a:t>
+            </a:r>
+            <a:r>
+              <a:rPr lang="id-ID" dirty="0"/>
+              <a:t> https://github.com/digitalgalery-dgsoft/attendaceesa.git </a:t>
+            </a:r>
+            <a:r>
+              <a:rPr lang="id-ID" dirty="0" err="1"/>
+              <a:t>att-repo-update</a:t>
+            </a:r>
+            <a:endParaRPr lang="id-ID" dirty="0"/>
+          </a:p>
+          <a:p>
+            <a:r>
+              <a:rPr lang="id-ID" dirty="0"/>
+              <a:t>\</a:t>
+            </a:r>
+            <a:r>
+              <a:rPr lang="id-ID" dirty="0" err="1"/>
+              <a:t>cp</a:t>
+            </a:r>
+            <a:r>
+              <a:rPr lang="id-ID" dirty="0"/>
+              <a:t> -</a:t>
+            </a:r>
+            <a:r>
+              <a:rPr lang="id-ID" dirty="0" err="1"/>
+              <a:t>rf</a:t>
+            </a:r>
+            <a:r>
+              <a:rPr lang="id-ID" dirty="0"/>
+              <a:t> /</a:t>
+            </a:r>
+            <a:r>
+              <a:rPr lang="id-ID" dirty="0" err="1"/>
+              <a:t>root</a:t>
+            </a:r>
+            <a:r>
+              <a:rPr lang="id-ID" dirty="0"/>
+              <a:t>/</a:t>
+            </a:r>
+            <a:r>
+              <a:rPr lang="id-ID" dirty="0" err="1"/>
+              <a:t>att-repo-update</a:t>
+            </a:r>
+            <a:r>
+              <a:rPr lang="id-ID" dirty="0"/>
+              <a:t>/att-admin-v12/. /</a:t>
+            </a:r>
+            <a:r>
+              <a:rPr lang="id-ID" dirty="0" err="1"/>
+              <a:t>www</a:t>
+            </a:r>
+            <a:r>
+              <a:rPr lang="id-ID" dirty="0"/>
+              <a:t>/</a:t>
+            </a:r>
+            <a:r>
+              <a:rPr lang="id-ID" dirty="0" err="1"/>
+              <a:t>wwwroot</a:t>
+            </a:r>
+            <a:r>
+              <a:rPr lang="id-ID" dirty="0"/>
+              <a:t>/atk.dgsoft.web.id/</a:t>
+            </a:r>
+          </a:p>
+          <a:p>
+            <a:r>
+              <a:rPr lang="id-ID" dirty="0"/>
+              <a:t>cd /www/wwwroot/atk.dgsoft.web.id</a:t>
+            </a:r>
+          </a:p>
+          <a:p>
+            <a:r>
+              <a:rPr lang="id-ID" dirty="0"/>
+              <a:t>/</a:t>
+            </a:r>
+            <a:r>
+              <a:rPr lang="id-ID" dirty="0" err="1"/>
+              <a:t>www</a:t>
+            </a:r>
+            <a:r>
+              <a:rPr lang="id-ID" dirty="0"/>
+              <a:t>/server/</a:t>
+            </a:r>
+            <a:r>
+              <a:rPr lang="id-ID" dirty="0" err="1"/>
+              <a:t>php</a:t>
+            </a:r>
+            <a:r>
+              <a:rPr lang="id-ID" dirty="0"/>
+              <a:t>/83/bin/</a:t>
+            </a:r>
+            <a:r>
+              <a:rPr lang="id-ID" dirty="0" err="1"/>
+              <a:t>php</a:t>
+            </a:r>
+            <a:r>
+              <a:rPr lang="id-ID" dirty="0"/>
+              <a:t> artisan </a:t>
+            </a:r>
+            <a:r>
+              <a:rPr lang="id-ID" dirty="0" err="1"/>
+              <a:t>storage:link</a:t>
+            </a:r>
+            <a:r>
+              <a:rPr lang="id-ID" dirty="0"/>
+              <a:t> 2&gt;/</a:t>
+            </a:r>
+            <a:r>
+              <a:rPr lang="id-ID" dirty="0" err="1"/>
+              <a:t>dev</a:t>
+            </a:r>
+            <a:r>
+              <a:rPr lang="id-ID" dirty="0"/>
+              <a:t>/</a:t>
+            </a:r>
+            <a:r>
+              <a:rPr lang="id-ID" dirty="0" err="1"/>
+              <a:t>null</a:t>
+            </a:r>
+            <a:r>
+              <a:rPr lang="id-ID" dirty="0"/>
+              <a:t> || </a:t>
+            </a:r>
+            <a:r>
+              <a:rPr lang="id-ID" dirty="0" err="1"/>
+              <a:t>true</a:t>
+            </a:r>
+            <a:endParaRPr lang="id-ID" dirty="0"/>
+          </a:p>
+          <a:p>
+            <a:r>
+              <a:rPr lang="id-ID" dirty="0"/>
+              <a:t>/</a:t>
+            </a:r>
+            <a:r>
+              <a:rPr lang="id-ID" dirty="0" err="1"/>
+              <a:t>www</a:t>
+            </a:r>
+            <a:r>
+              <a:rPr lang="id-ID" dirty="0"/>
+              <a:t>/server/</a:t>
+            </a:r>
+            <a:r>
+              <a:rPr lang="id-ID" dirty="0" err="1"/>
+              <a:t>php</a:t>
+            </a:r>
+            <a:r>
+              <a:rPr lang="id-ID" dirty="0"/>
+              <a:t>/83/bin/</a:t>
+            </a:r>
+            <a:r>
+              <a:rPr lang="id-ID" dirty="0" err="1"/>
+              <a:t>php</a:t>
+            </a:r>
+            <a:r>
+              <a:rPr lang="id-ID" dirty="0"/>
+              <a:t> artisan </a:t>
+            </a:r>
+            <a:r>
+              <a:rPr lang="id-ID" dirty="0" err="1"/>
+              <a:t>livewire:publish</a:t>
+            </a:r>
+            <a:r>
+              <a:rPr lang="id-ID" dirty="0"/>
+              <a:t> --</a:t>
+            </a:r>
+            <a:r>
+              <a:rPr lang="id-ID" dirty="0" err="1"/>
+              <a:t>assets</a:t>
+            </a:r>
+            <a:r>
+              <a:rPr lang="id-ID" dirty="0"/>
+              <a:t> 2&gt;/</a:t>
+            </a:r>
+            <a:r>
+              <a:rPr lang="id-ID" dirty="0" err="1"/>
+              <a:t>dev</a:t>
+            </a:r>
+            <a:r>
+              <a:rPr lang="id-ID" dirty="0"/>
+              <a:t>/</a:t>
+            </a:r>
+            <a:r>
+              <a:rPr lang="id-ID" dirty="0" err="1"/>
+              <a:t>null</a:t>
+            </a:r>
+            <a:r>
+              <a:rPr lang="id-ID" dirty="0"/>
+              <a:t> || </a:t>
+            </a:r>
+            <a:r>
+              <a:rPr lang="id-ID" dirty="0" err="1"/>
+              <a:t>true</a:t>
+            </a:r>
+            <a:endParaRPr lang="id-ID" dirty="0"/>
+          </a:p>
+          <a:p>
+            <a:r>
+              <a:rPr lang="id-ID" dirty="0" err="1"/>
+              <a:t>mkdir</a:t>
+            </a:r>
+            <a:r>
+              <a:rPr lang="id-ID" dirty="0"/>
+              <a:t> -p </a:t>
+            </a:r>
+            <a:r>
+              <a:rPr lang="id-ID" dirty="0" err="1"/>
+              <a:t>public</a:t>
+            </a:r>
+            <a:r>
+              <a:rPr lang="id-ID" dirty="0"/>
+              <a:t>/</a:t>
+            </a:r>
+            <a:r>
+              <a:rPr lang="id-ID" dirty="0" err="1"/>
+              <a:t>livewire</a:t>
+            </a:r>
+            <a:r>
+              <a:rPr lang="id-ID" dirty="0"/>
+              <a:t> &amp;&amp; \</a:t>
+            </a:r>
+            <a:r>
+              <a:rPr lang="id-ID" dirty="0" err="1"/>
+              <a:t>cp</a:t>
+            </a:r>
+            <a:r>
+              <a:rPr lang="id-ID" dirty="0"/>
+              <a:t> -</a:t>
+            </a:r>
+            <a:r>
+              <a:rPr lang="id-ID" dirty="0" err="1"/>
+              <a:t>rf</a:t>
+            </a:r>
+            <a:r>
+              <a:rPr lang="id-ID" dirty="0"/>
+              <a:t> vendor/</a:t>
+            </a:r>
+            <a:r>
+              <a:rPr lang="id-ID" dirty="0" err="1"/>
+              <a:t>livewire</a:t>
+            </a:r>
+            <a:r>
+              <a:rPr lang="id-ID" dirty="0"/>
+              <a:t>/</a:t>
+            </a:r>
+            <a:r>
+              <a:rPr lang="id-ID" dirty="0" err="1"/>
+              <a:t>livewire</a:t>
+            </a:r>
+            <a:r>
+              <a:rPr lang="id-ID" dirty="0"/>
+              <a:t>/</a:t>
+            </a:r>
+            <a:r>
+              <a:rPr lang="id-ID" dirty="0" err="1"/>
+              <a:t>dist</a:t>
+            </a:r>
+            <a:r>
+              <a:rPr lang="id-ID" dirty="0"/>
+              <a:t>/* </a:t>
+            </a:r>
+            <a:r>
+              <a:rPr lang="id-ID" dirty="0" err="1"/>
+              <a:t>public</a:t>
+            </a:r>
+            <a:r>
+              <a:rPr lang="id-ID" dirty="0"/>
+              <a:t>/</a:t>
+            </a:r>
+            <a:r>
+              <a:rPr lang="id-ID" dirty="0" err="1"/>
+              <a:t>livewire</a:t>
+            </a:r>
+            <a:r>
+              <a:rPr lang="id-ID" dirty="0"/>
+              <a:t>/ 2&gt;/</a:t>
+            </a:r>
+            <a:r>
+              <a:rPr lang="id-ID" dirty="0" err="1"/>
+              <a:t>dev</a:t>
+            </a:r>
+            <a:r>
+              <a:rPr lang="id-ID" dirty="0"/>
+              <a:t>/</a:t>
+            </a:r>
+            <a:r>
+              <a:rPr lang="id-ID" dirty="0" err="1"/>
+              <a:t>null</a:t>
+            </a:r>
+            <a:r>
+              <a:rPr lang="id-ID" dirty="0"/>
+              <a:t> || </a:t>
+            </a:r>
+            <a:r>
+              <a:rPr lang="id-ID" dirty="0" err="1"/>
+              <a:t>true</a:t>
+            </a:r>
+            <a:endParaRPr lang="id-ID" dirty="0"/>
+          </a:p>
+          <a:p>
+            <a:r>
+              <a:rPr lang="id-ID" dirty="0" err="1"/>
+              <a:t>rm</a:t>
+            </a:r>
+            <a:r>
+              <a:rPr lang="id-ID" dirty="0"/>
+              <a:t> -f </a:t>
+            </a:r>
+            <a:r>
+              <a:rPr lang="id-ID" dirty="0" err="1"/>
+              <a:t>public</a:t>
+            </a:r>
+            <a:r>
+              <a:rPr lang="id-ID" dirty="0"/>
+              <a:t>/hot</a:t>
+            </a:r>
+          </a:p>
+          <a:p>
+            <a:r>
+              <a:rPr lang="id-ID" dirty="0"/>
+              <a:t>/</a:t>
+            </a:r>
+            <a:r>
+              <a:rPr lang="id-ID" dirty="0" err="1"/>
+              <a:t>www</a:t>
+            </a:r>
+            <a:r>
+              <a:rPr lang="id-ID" dirty="0"/>
+              <a:t>/server/</a:t>
+            </a:r>
+            <a:r>
+              <a:rPr lang="id-ID" dirty="0" err="1"/>
+              <a:t>php</a:t>
+            </a:r>
+            <a:r>
+              <a:rPr lang="id-ID" dirty="0"/>
+              <a:t>/83/bin/</a:t>
+            </a:r>
+            <a:r>
+              <a:rPr lang="id-ID" dirty="0" err="1"/>
+              <a:t>php</a:t>
+            </a:r>
+            <a:r>
+              <a:rPr lang="id-ID" dirty="0"/>
+              <a:t> artisan </a:t>
+            </a:r>
+            <a:r>
+              <a:rPr lang="id-ID" dirty="0" err="1"/>
+              <a:t>reporting:link-principals</a:t>
+            </a:r>
+            <a:endParaRPr lang="id-ID" dirty="0"/>
+          </a:p>
+          <a:p>
+            <a:r>
+              <a:rPr lang="id-ID" dirty="0"/>
+              <a:t>/</a:t>
+            </a:r>
+            <a:r>
+              <a:rPr lang="id-ID" dirty="0" err="1"/>
+              <a:t>www</a:t>
+            </a:r>
+            <a:r>
+              <a:rPr lang="id-ID" dirty="0"/>
+              <a:t>/server/</a:t>
+            </a:r>
+            <a:r>
+              <a:rPr lang="id-ID" dirty="0" err="1"/>
+              <a:t>php</a:t>
+            </a:r>
+            <a:r>
+              <a:rPr lang="id-ID" dirty="0"/>
+              <a:t>/83/bin/</a:t>
+            </a:r>
+            <a:r>
+              <a:rPr lang="id-ID" dirty="0" err="1"/>
+              <a:t>php</a:t>
+            </a:r>
+            <a:r>
+              <a:rPr lang="id-ID" dirty="0"/>
+              <a:t> artisan </a:t>
+            </a:r>
+            <a:r>
+              <a:rPr lang="id-ID" dirty="0" err="1"/>
+              <a:t>optimize:clear</a:t>
+            </a:r>
+            <a:endParaRPr lang="id-ID" dirty="0"/>
+          </a:p>
+          <a:p>
+            <a:r>
+              <a:rPr lang="id-ID" dirty="0" err="1"/>
+              <a:t>systemctl</a:t>
+            </a:r>
+            <a:r>
+              <a:rPr lang="id-ID" dirty="0"/>
+              <a:t> </a:t>
+            </a:r>
+            <a:r>
+              <a:rPr lang="id-ID" dirty="0" err="1"/>
+              <a:t>reload</a:t>
+            </a:r>
+            <a:r>
+              <a:rPr lang="id-ID" dirty="0"/>
+              <a:t> php-fpm-83 2&gt;/</a:t>
+            </a:r>
+            <a:r>
+              <a:rPr lang="id-ID" dirty="0" err="1"/>
+              <a:t>dev</a:t>
+            </a:r>
+            <a:r>
+              <a:rPr lang="id-ID" dirty="0"/>
+              <a:t>/</a:t>
+            </a:r>
+            <a:r>
+              <a:rPr lang="id-ID" dirty="0" err="1"/>
+              <a:t>null</a:t>
+            </a:r>
+            <a:r>
+              <a:rPr lang="id-ID" dirty="0"/>
+              <a:t> || /</a:t>
+            </a:r>
+            <a:r>
+              <a:rPr lang="id-ID" dirty="0" err="1"/>
+              <a:t>etc</a:t>
+            </a:r>
+            <a:r>
+              <a:rPr lang="id-ID" dirty="0"/>
+              <a:t>/</a:t>
+            </a:r>
+            <a:r>
+              <a:rPr lang="id-ID" dirty="0" err="1"/>
+              <a:t>init.d</a:t>
+            </a:r>
+            <a:r>
+              <a:rPr lang="id-ID" dirty="0"/>
+              <a:t>/php-fpm-83 </a:t>
+            </a:r>
+            <a:r>
+              <a:rPr lang="id-ID" dirty="0" err="1"/>
+              <a:t>reload</a:t>
+            </a:r>
+            <a:r>
+              <a:rPr lang="id-ID" dirty="0"/>
+              <a:t> 2&gt;/</a:t>
+            </a:r>
+            <a:r>
+              <a:rPr lang="id-ID" dirty="0" err="1"/>
+              <a:t>dev</a:t>
+            </a:r>
+            <a:r>
+              <a:rPr lang="id-ID" dirty="0"/>
+              <a:t>/</a:t>
+            </a:r>
+            <a:r>
+              <a:rPr lang="id-ID" dirty="0" err="1"/>
+              <a:t>null</a:t>
+            </a:r>
+            <a:r>
+              <a:rPr lang="id-ID" dirty="0"/>
+              <a:t> || </a:t>
+            </a:r>
+            <a:r>
+              <a:rPr lang="id-ID" dirty="0" err="1"/>
+              <a:t>true</a:t>
+            </a:r>
+            <a:endParaRPr lang="id-ID" dirty="0"/>
+          </a:p>
+          <a:p>
+            <a:r>
+              <a:rPr lang="id-ID" dirty="0" err="1"/>
+              <a:t>rm</a:t>
+            </a:r>
+            <a:r>
+              <a:rPr lang="id-ID" dirty="0"/>
+              <a:t> -</a:t>
+            </a:r>
+            <a:r>
+              <a:rPr lang="id-ID" dirty="0" err="1"/>
+              <a:t>rf</a:t>
+            </a:r>
+            <a:r>
+              <a:rPr lang="id-ID" dirty="0"/>
+              <a:t> /</a:t>
+            </a:r>
+            <a:r>
+              <a:rPr lang="id-ID" dirty="0" err="1"/>
+              <a:t>root</a:t>
+            </a:r>
+            <a:r>
+              <a:rPr lang="id-ID" dirty="0"/>
+              <a:t>/</a:t>
+            </a:r>
+            <a:r>
+              <a:rPr lang="id-ID" dirty="0" err="1"/>
+              <a:t>att-repo-update</a:t>
+            </a:r>
+            <a:endParaRPr lang="id-ID" dirty="0"/>
+          </a:p>
+          <a:p>
+            <a:r>
+              <a:rPr lang="id-ID" dirty="0" err="1"/>
+              <a:t>echo</a:t>
+            </a:r>
+            <a:r>
+              <a:rPr lang="id-ID" dirty="0"/>
+              <a:t> "✅ SERVER 3 (ATK) SELESAI DIPERBARUI!"</a:t>
+            </a:r>
+          </a:p>
+        </p:txBody>
+      </p:sp>
+    </p:spTree>
+    <p:extLst>
+      <p:ext uri="{BB962C8B-B14F-4D97-AF65-F5344CB8AC3E}">
+        <p14:creationId xmlns:p14="http://schemas.microsoft.com/office/powerpoint/2010/main" val="1386063893"/>
       </p:ext>
     </p:extLst>
   </p:cSld>
@@ -7986,4 +11220,299 @@
   </a:objectDefaults>
   <a:extraClrSchemeLst/>
 </a:theme>
+</file>
+
+<file path=ppt/theme/theme2.xml><?xml version="1.0" encoding="utf-8"?>
+<a:theme xmlns:a="http://schemas.openxmlformats.org/drawingml/2006/main" name="Office Theme">
+  <a:themeElements>
+    <a:clrScheme name="Office">
+      <a:dk1>
+        <a:sysClr val="windowText" lastClr="000000"/>
+      </a:dk1>
+      <a:lt1>
+        <a:sysClr val="window" lastClr="FFFFFF"/>
+      </a:lt1>
+      <a:dk2>
+        <a:srgbClr val="44546A"/>
+      </a:dk2>
+      <a:lt2>
+        <a:srgbClr val="E7E6E6"/>
+      </a:lt2>
+      <a:accent1>
+        <a:srgbClr val="4472C4"/>
+      </a:accent1>
+      <a:accent2>
+        <a:srgbClr val="ED7D31"/>
+      </a:accent2>
+      <a:accent3>
+        <a:srgbClr val="A5A5A5"/>
+      </a:accent3>
+      <a:accent4>
+        <a:srgbClr val="FFC000"/>
+      </a:accent4>
+      <a:accent5>
+        <a:srgbClr val="5B9BD5"/>
+      </a:accent5>
+      <a:accent6>
+        <a:srgbClr val="70AD47"/>
+      </a:accent6>
+      <a:hlink>
+        <a:srgbClr val="0563C1"/>
+      </a:hlink>
+      <a:folHlink>
+        <a:srgbClr val="954F72"/>
+      </a:folHlink>
+    </a:clrScheme>
+    <a:fontScheme name="Office">
+      <a:majorFont>
+        <a:latin typeface="Calibri Light" panose="020F0302020204030204"/>
+        <a:ea typeface=""/>
+        <a:cs typeface=""/>
+        <a:font script="Jpan" typeface="游ゴシック Light"/>
+        <a:font script="Hang" typeface="맑은 고딕"/>
+        <a:font script="Hans" typeface="等线 Light"/>
+        <a:font script="Hant" typeface="新細明體"/>
+        <a:font script="Arab" typeface="Times New Roman"/>
+        <a:font script="Hebr" typeface="Times New Roman"/>
+        <a:font script="Thai" typeface="Angsana New"/>
+        <a:font script="Ethi" typeface="Nyala"/>
+        <a:font script="Beng" typeface="Vrinda"/>
+        <a:font script="Gujr" typeface="Shruti"/>
+        <a:font script="Khmr" typeface="MoolBoran"/>
+        <a:font script="Knda" typeface="Tunga"/>
+        <a:font script="Guru" typeface="Raavi"/>
+        <a:font script="Cans" typeface="Euphemia"/>
+        <a:font script="Cher" typeface="Plantagenet Cherokee"/>
+        <a:font script="Yiii" typeface="Microsoft Yi Baiti"/>
+        <a:font script="Tibt" typeface="Microsoft Himalaya"/>
+        <a:font script="Thaa" typeface="MV Boli"/>
+        <a:font script="Deva" typeface="Mangal"/>
+        <a:font script="Telu" typeface="Gautami"/>
+        <a:font script="Taml" typeface="Latha"/>
+        <a:font script="Syrc" typeface="Estrangelo Edessa"/>
+        <a:font script="Orya" typeface="Kalinga"/>
+        <a:font script="Mlym" typeface="Kartika"/>
+        <a:font script="Laoo" typeface="DokChampa"/>
+        <a:font script="Sinh" typeface="Iskoola Pota"/>
+        <a:font script="Mong" typeface="Mongolian Baiti"/>
+        <a:font script="Viet" typeface="Times New Roman"/>
+        <a:font script="Uigh" typeface="Microsoft Uighur"/>
+        <a:font script="Geor" typeface="Sylfaen"/>
+        <a:font script="Armn" typeface="Arial"/>
+        <a:font script="Bugi" typeface="Leelawadee UI"/>
+        <a:font script="Bopo" typeface="Microsoft JhengHei"/>
+        <a:font script="Java" typeface="Javanese Text"/>
+        <a:font script="Lisu" typeface="Segoe UI"/>
+        <a:font script="Mymr" typeface="Myanmar Text"/>
+        <a:font script="Nkoo" typeface="Ebrima"/>
+        <a:font script="Olck" typeface="Nirmala UI"/>
+        <a:font script="Osma" typeface="Ebrima"/>
+        <a:font script="Phag" typeface="Phagspa"/>
+        <a:font script="Syrn" typeface="Estrangelo Edessa"/>
+        <a:font script="Syrj" typeface="Estrangelo Edessa"/>
+        <a:font script="Syre" typeface="Estrangelo Edessa"/>
+        <a:font script="Sora" typeface="Nirmala UI"/>
+        <a:font script="Tale" typeface="Microsoft Tai Le"/>
+        <a:font script="Talu" typeface="Microsoft New Tai Lue"/>
+        <a:font script="Tfng" typeface="Ebrima"/>
+      </a:majorFont>
+      <a:minorFont>
+        <a:latin typeface="Calibri" panose="020F0502020204030204"/>
+        <a:ea typeface=""/>
+        <a:cs typeface=""/>
+        <a:font script="Jpan" typeface="游ゴシック"/>
+        <a:font script="Hang" typeface="맑은 고딕"/>
+        <a:font script="Hans" typeface="等线"/>
+        <a:font script="Hant" typeface="新細明體"/>
+        <a:font script="Arab" typeface="Arial"/>
+        <a:font script="Hebr" typeface="Arial"/>
+        <a:font script="Thai" typeface="Cordia New"/>
+        <a:font script="Ethi" typeface="Nyala"/>
+        <a:font script="Beng" typeface="Vrinda"/>
+        <a:font script="Gujr" typeface="Shruti"/>
+        <a:font script="Khmr" typeface="DaunPenh"/>
+        <a:font script="Knda" typeface="Tunga"/>
+        <a:font script="Guru" typeface="Raavi"/>
+        <a:font script="Cans" typeface="Euphemia"/>
+        <a:font script="Cher" typeface="Plantagenet Cherokee"/>
+        <a:font script="Yiii" typeface="Microsoft Yi Baiti"/>
+        <a:font script="Tibt" typeface="Microsoft Himalaya"/>
+        <a:font script="Thaa" typeface="MV Boli"/>
+        <a:font script="Deva" typeface="Mangal"/>
+        <a:font script="Telu" typeface="Gautami"/>
+        <a:font script="Taml" typeface="Latha"/>
+        <a:font script="Syrc" typeface="Estrangelo Edessa"/>
+        <a:font script="Orya" typeface="Kalinga"/>
+        <a:font script="Mlym" typeface="Kartika"/>
+        <a:font script="Laoo" typeface="DokChampa"/>
+        <a:font script="Sinh" typeface="Iskoola Pota"/>
+        <a:font script="Mong" typeface="Mongolian Baiti"/>
+        <a:font script="Viet" typeface="Arial"/>
+        <a:font script="Uigh" typeface="Microsoft Uighur"/>
+        <a:font script="Geor" typeface="Sylfaen"/>
+        <a:font script="Armn" typeface="Arial"/>
+        <a:font script="Bugi" typeface="Leelawadee UI"/>
+        <a:font script="Bopo" typeface="Microsoft JhengHei"/>
+        <a:font script="Java" typeface="Javanese Text"/>
+        <a:font script="Lisu" typeface="Segoe UI"/>
+        <a:font script="Mymr" typeface="Myanmar Text"/>
+        <a:font script="Nkoo" typeface="Ebrima"/>
+        <a:font script="Olck" typeface="Nirmala UI"/>
+        <a:font script="Osma" typeface="Ebrima"/>
+        <a:font script="Phag" typeface="Phagspa"/>
+        <a:font script="Syrn" typeface="Estrangelo Edessa"/>
+        <a:font script="Syrj" typeface="Estrangelo Edessa"/>
+        <a:font script="Syre" typeface="Estrangelo Edessa"/>
+        <a:font script="Sora" typeface="Nirmala UI"/>
+        <a:font script="Tale" typeface="Microsoft Tai Le"/>
+        <a:font script="Talu" typeface="Microsoft New Tai Lue"/>
+        <a:font script="Tfng" typeface="Ebrima"/>
+      </a:minorFont>
+    </a:fontScheme>
+    <a:fmtScheme name="Office">
+      <a:fillStyleLst>
+        <a:solidFill>
+          <a:schemeClr val="phClr"/>
+        </a:solidFill>
+        <a:gradFill rotWithShape="1">
+          <a:gsLst>
+            <a:gs pos="0">
+              <a:schemeClr val="phClr">
+                <a:lumMod val="110000"/>
+                <a:satMod val="105000"/>
+                <a:tint val="67000"/>
+              </a:schemeClr>
+            </a:gs>
+            <a:gs pos="50000">
+              <a:schemeClr val="phClr">
+                <a:lumMod val="105000"/>
+                <a:satMod val="103000"/>
+                <a:tint val="73000"/>
+              </a:schemeClr>
+            </a:gs>
+            <a:gs pos="100000">
+              <a:schemeClr val="phClr">
+                <a:lumMod val="105000"/>
+                <a:satMod val="109000"/>
+                <a:tint val="81000"/>
+              </a:schemeClr>
+            </a:gs>
+          </a:gsLst>
+          <a:lin ang="5400000" scaled="0"/>
+        </a:gradFill>
+        <a:gradFill rotWithShape="1">
+          <a:gsLst>
+            <a:gs pos="0">
+              <a:schemeClr val="phClr">
+                <a:satMod val="103000"/>
+                <a:lumMod val="102000"/>
+                <a:tint val="94000"/>
+              </a:schemeClr>
+            </a:gs>
+            <a:gs pos="50000">
+              <a:schemeClr val="phClr">
+                <a:satMod val="110000"/>
+                <a:lumMod val="100000"/>
+                <a:shade val="100000"/>
+              </a:schemeClr>
+            </a:gs>
+            <a:gs pos="100000">
+              <a:schemeClr val="phClr">
+                <a:lumMod val="99000"/>
+                <a:satMod val="120000"/>
+                <a:shade val="78000"/>
+              </a:schemeClr>
+            </a:gs>
+          </a:gsLst>
+          <a:lin ang="5400000" scaled="0"/>
+        </a:gradFill>
+      </a:fillStyleLst>
+      <a:lnStyleLst>
+        <a:ln w="6350" cap="flat" cmpd="sng" algn="ctr">
+          <a:solidFill>
+            <a:schemeClr val="phClr"/>
+          </a:solidFill>
+          <a:prstDash val="solid"/>
+          <a:miter lim="800000"/>
+        </a:ln>
+        <a:ln w="12700" cap="flat" cmpd="sng" algn="ctr">
+          <a:solidFill>
+            <a:schemeClr val="phClr"/>
+          </a:solidFill>
+          <a:prstDash val="solid"/>
+          <a:miter lim="800000"/>
+        </a:ln>
+        <a:ln w="19050" cap="flat" cmpd="sng" algn="ctr">
+          <a:solidFill>
+            <a:schemeClr val="phClr"/>
+          </a:solidFill>
+          <a:prstDash val="solid"/>
+          <a:miter lim="800000"/>
+        </a:ln>
+      </a:lnStyleLst>
+      <a:effectStyleLst>
+        <a:effectStyle>
+          <a:effectLst/>
+        </a:effectStyle>
+        <a:effectStyle>
+          <a:effectLst/>
+        </a:effectStyle>
+        <a:effectStyle>
+          <a:effectLst>
+            <a:outerShdw blurRad="57150" dist="19050" dir="5400000" algn="ctr" rotWithShape="0">
+              <a:srgbClr val="000000">
+                <a:alpha val="63000"/>
+              </a:srgbClr>
+            </a:outerShdw>
+          </a:effectLst>
+        </a:effectStyle>
+      </a:effectStyleLst>
+      <a:bgFillStyleLst>
+        <a:solidFill>
+          <a:schemeClr val="phClr"/>
+        </a:solidFill>
+        <a:solidFill>
+          <a:schemeClr val="phClr">
+            <a:tint val="95000"/>
+            <a:satMod val="170000"/>
+          </a:schemeClr>
+        </a:solidFill>
+        <a:gradFill rotWithShape="1">
+          <a:gsLst>
+            <a:gs pos="0">
+              <a:schemeClr val="phClr">
+                <a:tint val="93000"/>
+                <a:satMod val="150000"/>
+                <a:shade val="98000"/>
+                <a:lumMod val="102000"/>
+              </a:schemeClr>
+            </a:gs>
+            <a:gs pos="50000">
+              <a:schemeClr val="phClr">
+                <a:tint val="98000"/>
+                <a:satMod val="130000"/>
+                <a:shade val="90000"/>
+                <a:lumMod val="103000"/>
+              </a:schemeClr>
+            </a:gs>
+            <a:gs pos="100000">
+              <a:schemeClr val="phClr">
+                <a:shade val="63000"/>
+                <a:satMod val="120000"/>
+              </a:schemeClr>
+            </a:gs>
+          </a:gsLst>
+          <a:lin ang="5400000" scaled="0"/>
+        </a:gradFill>
+      </a:bgFillStyleLst>
+    </a:fmtScheme>
+  </a:themeElements>
+  <a:objectDefaults/>
+  <a:extraClrSchemeLst/>
+  <a:extLst>
+    <a:ext uri="{05A4C25C-085E-4340-85A3-A5531E510DB2}">
+      <thm15:themeFamily xmlns:thm15="http://schemas.microsoft.com/office/thememl/2012/main" name="Office Theme" id="{62F939B6-93AF-4DB8-9C6B-D6C7DFDC589F}" vid="{4A3C46E8-61CC-4603-A589-7422A47A8E4A}"/>
+    </a:ext>
+  </a:extLst>
+</a:theme>
 </file>
</xml_diff>